<commit_message>
Update test report and presentation with final results
- HTML report: 98 tests passed (13 Selenium + 85 PyTest)
- Slide 8: new counts and the defects found by exploratory testing

Co-Authored-By: Claude Opus 5.5 <noreply@anthropic.com>
Claude-Session: https://claude.ai/code/session_01KhLoTHysDZctQ2NgKJXDRu
</commit_message>
<xml_diff>
--- a/presentation/Hospital_Management_System_Selenium_Testing.pptx
+++ b/presentation/Hospital_Management_System_Selenium_Testing.pptx
@@ -115,31 +115,31 @@
   <p:extLst>
     <p:ext uri="{521415D9-36F7-43E2-AB2F-B90AF26B5E84}">
       <p14:sectionLst xmlns:p14="http://schemas.microsoft.com/office/powerpoint/2010/main">
-        <p14:section name="Introduction" id="{ea2becd7-7d1f-0e66-8390-6021c211cc24}">
+        <p14:section name="Introduction" id="{d873fe79-eb67-8d6c-1d52-b433f9c1adc1}">
           <p14:sldIdLst>
             <p14:sldId id="256"/>
             <p14:sldId id="257"/>
           </p14:sldIdLst>
         </p14:section>
-        <p14:section name="The System" id="{d927c3e7-b509-a243-4e95-75068b14499c}">
+        <p14:section name="The System" id="{a54bd806-5240-b05f-88c3-a7c654323e0b}">
           <p14:sldIdLst>
             <p14:sldId id="258"/>
             <p14:sldId id="259"/>
           </p14:sldIdLst>
         </p14:section>
-        <p14:section name="Testing" id="{f8ce8a09-bb1d-17aa-6a11-fc30d6759dce}">
+        <p14:section name="Testing" id="{37679590-d564-b5af-e3fb-5948fc2f5a0c}">
           <p14:sldIdLst>
             <p14:sldId id="260"/>
             <p14:sldId id="261"/>
             <p14:sldId id="262"/>
           </p14:sldIdLst>
         </p14:section>
-        <p14:section name="Results" id="{7f2e8c36-e905-f9e1-ddab-33437a92b009}">
+        <p14:section name="Results" id="{3982fc1d-658e-be13-96f8-88fa5011c114}">
           <p14:sldIdLst>
             <p14:sldId id="263"/>
           </p14:sldIdLst>
         </p14:section>
-        <p14:section name="Conclusion" id="{a5235601-cea5-71e1-aef2-7045974cc0fe}">
+        <p14:section name="Conclusion" id="{1fed0cc7-ad87-ee72-5a18-139830b31cb3}">
           <p14:sldIdLst>
             <p14:sldId id="264"/>
           </p14:sldIdLst>
@@ -1164,7 +1164,7 @@
           <a:p>
             <a:r>
               <a:rPr lang="en-US" dirty="0"/>
-              <a:t>All 13 Selenium tests passed, and we also have 68 PyTest tests that check the validation rules and database directly, without a browser. All 81 run in about 24 seconds and produce this HTML report. An honest lesson: at first one test failed randomly because Selenium clicked Login and immediately opened the next page before login finished. We fixed it by making Selenium wait for the page to reload. This is a very common problem in test automation called synchronization.</a:t>
+              <a:t>All 13 Selenium tests passed, and we also have 85 PyTest tests that check the validation rules and database directly, without a browser. All 98 run in about 25 seconds and produce this HTML report. Our testing also FOUND real defects. Using exploratory testing we tried to break the app on purpose: typing 'nan' as a doctor fee crashed the server, infinity was accepted as a bill amount, the same patient could be booked with two doctors at the same time, and deleting a record that does not exist still showed success. We also found that our Selenium tests failed randomly about one run in three, because Selenium checked the page while Chrome was still loading it - a common automation problem called synchronization. We fixed all 9 defects and added a regression test for each one, so they can never come back. The full list is in our README.</a:t>
             </a:r>
             <a:endParaRPr lang="en-US" dirty="0"/>
           </a:p>
@@ -11783,7 +11783,7 @@
                   <a:schemeClr val="accent1"/>
                 </a:solidFill>
               </a:rPr>
-              <a:t>68</a:t>
+              <a:t>85</a:t>
             </a:r>
             <a:endParaRPr lang="en-US" sz="4000" dirty="0"/>
           </a:p>
@@ -11827,7 +11827,7 @@
       </p:sp>
       <p:sp>
         <p:nvSpPr>
-          <p:cNvPr id="12" name="To run all 81 tests card"/>
+          <p:cNvPr id="12" name="To run all 98 tests card"/>
           <p:cNvSpPr/>
           <p:nvPr/>
         </p:nvSpPr>
@@ -11849,7 +11849,7 @@
       </p:sp>
       <p:sp>
         <p:nvSpPr>
-          <p:cNvPr id="13" name="To run all 81 tests number"/>
+          <p:cNvPr id="13" name="To run all 98 tests number"/>
           <p:cNvSpPr txBox="1"/>
           <p:nvPr/>
         </p:nvSpPr>
@@ -11877,7 +11877,7 @@
                   <a:schemeClr val="accent1"/>
                 </a:solidFill>
               </a:rPr>
-              <a:t>~24 s</a:t>
+              <a:t>~25 s</a:t>
             </a:r>
             <a:endParaRPr lang="en-US" sz="4000" dirty="0"/>
           </a:p>
@@ -11885,7 +11885,7 @@
       </p:sp>
       <p:sp>
         <p:nvSpPr>
-          <p:cNvPr id="14" name="To run all 81 tests label"/>
+          <p:cNvPr id="14" name="To run all 98 tests label"/>
           <p:cNvSpPr txBox="1"/>
           <p:nvPr/>
         </p:nvSpPr>
@@ -11913,7 +11913,7 @@
                   <a:schemeClr val="tx1"/>
                 </a:solidFill>
               </a:rPr>
-              <a:t>To run all 81 tests</a:t>
+              <a:t>To run all 98 tests</a:t>
             </a:r>
             <a:endParaRPr lang="en-US" sz="1200" dirty="0"/>
           </a:p>
@@ -11921,7 +11921,7 @@
       </p:sp>
       <p:sp>
         <p:nvSpPr>
-          <p:cNvPr id="15" name="Lesson box"/>
+          <p:cNvPr id="15" name="Defects box"/>
           <p:cNvSpPr/>
           <p:nvPr/>
         </p:nvSpPr>
@@ -11943,7 +11943,7 @@
       </p:sp>
       <p:sp>
         <p:nvSpPr>
-          <p:cNvPr id="16" name="Lesson icon circle"/>
+          <p:cNvPr id="16" name="Defects icon circle"/>
           <p:cNvSpPr/>
           <p:nvPr/>
         </p:nvSpPr>
@@ -11963,7 +11963,7 @@
       </p:sp>
       <p:pic>
         <p:nvPicPr>
-          <p:cNvPr id="17" name="Lesson icon" descr="preencoded.png">    </p:cNvPr>
+          <p:cNvPr id="17" name="Defects icon" descr="preencoded.png">    </p:cNvPr>
           <p:cNvPicPr>
             <a:picLocks noChangeAspect="1"/>
           </p:cNvPicPr>
@@ -11987,7 +11987,7 @@
       </p:pic>
       <p:sp>
         <p:nvSpPr>
-          <p:cNvPr id="18" name="Lesson text"/>
+          <p:cNvPr id="18" name="Defects text"/>
           <p:cNvSpPr txBox="1"/>
           <p:nvPr/>
         </p:nvSpPr>
@@ -12015,7 +12015,7 @@
                   <a:schemeClr val="tx2"/>
                 </a:solidFill>
               </a:rPr>
-              <a:t>Lesson learned: </a:t>
+              <a:t>9 defects found and fixed: </a:t>
             </a:r>
             <a:pPr indent="0" marL="0">
               <a:buNone/>
@@ -12026,7 +12026,7 @@
                   <a:schemeClr val="tx1"/>
                 </a:solidFill>
               </a:rPr>
-              <a:t>one test first failed because Selenium moved on before the page loaded. Fixed by waiting for the page (WebDriverWait) - now stable in repeated runs.</a:t>
+              <a:t>e.g. typing 'nan' as a fee crashed the server, a patient could be double-booked, and flaky Selenium waits. Each now has a regression test.</a:t>
             </a:r>
             <a:endParaRPr lang="en-US" sz="1300" dirty="0"/>
           </a:p>

</xml_diff>

<commit_message>
Redesign the UI and add a live Selenium demo for the class
- New professional UI: sidebar layout, icons, labelled forms, badges,
  empty states, dashboard with upcoming appointments and quick actions,
  split-screen login. Every element id used by the tests is unchanged.
- run.py: live demo that runs TC01-TC13 slowly in Chrome, highlights each
  element, shows a caption, prints the real Selenium command behind every
  step and PASS / FAIL, and shows a results page. Reopens Chrome if the
  Selenium window is closed.
- login.py (renamed from selenium_login_demo.py): first Selenium test.
- report.py: runs all 98 tests and opens the HTML report.
- DEMO_GUIDE.md: step-by-step classroom script with Q&A and fixes.
- Stop Chrome password pop-ups in the Selenium tests.
- New screenshots, regenerated test report, presentation updated with
  new screenshots and a Live Demo slide (10 slides).
- Add the project document PDF.

Co-Authored-By: Claude Opus 5.5 <noreply@anthropic.com>
</commit_message>
<xml_diff>
--- a/presentation/Hospital_Management_System_Selenium_Testing.pptx
+++ b/presentation/Hospital_Management_System_Selenium_Testing.pptx
@@ -12,6 +12,7 @@
     <p:sldId id="260" r:id="rId6"/>
     <p:sldId id="261" r:id="rId7"/>
     <p:sldId id="262" r:id="rId8"/>
+    <p:sldId id="265" r:id="rId16"/>
     <p:sldId id="263" r:id="rId9"/>
     <p:sldId id="264" r:id="rId10"/>
   </p:sldIdLst>
@@ -590,6 +591,76 @@
 </p:notes>
 </file>
 
+<file path=ppt/notesSlides/notesSlide10.xml><?xml version="1.0" encoding="utf-8"?>
+<p:notes xmlns:a="http://schemas.openxmlformats.org/drawingml/2006/main" xmlns:p="http://schemas.openxmlformats.org/presentationml/2006/main" xmlns:r="http://schemas.openxmlformats.org/officeDocument/2006/relationships">
+  <p:cSld>
+    <p:spTree>
+      <p:nvGrpSpPr>
+        <p:cNvPr id="1" name=""/>
+        <p:cNvGrpSpPr/>
+        <p:nvPr/>
+      </p:nvGrpSpPr>
+      <p:grpSpPr>
+        <a:xfrm>
+          <a:off x="0" y="0"/>
+          <a:ext cx="0" cy="0"/>
+          <a:chOff x="0" y="0"/>
+          <a:chExt cx="0" cy="0"/>
+        </a:xfrm>
+      </p:grpSpPr>
+      <p:sp>
+        <p:nvSpPr>
+          <p:cNvPr id="2" name="Slide Image Placeholder 1"/>
+          <p:cNvSpPr>
+            <a:spLocks noGrp="1"/>
+          </p:cNvSpPr>
+          <p:nvPr>
+            <p:ph type="sldImg" idx="2"/>
+          </p:nvPr>
+        </p:nvSpPr>
+        <p:spPr/>
+      </p:sp>
+      <p:sp>
+        <p:nvSpPr>
+          <p:cNvPr id="3" name="Notes Placeholder 2"/>
+          <p:cNvSpPr>
+            <a:spLocks noGrp="1"/>
+          </p:cNvSpPr>
+          <p:nvPr>
+            <p:ph type="body" idx="3" sz="quarter"/>
+          </p:nvPr>
+        </p:nvSpPr>
+        <p:spPr/>
+        <p:txBody>
+          <a:bodyPr/>
+          <a:lstStyle/>
+          <a:p>
+            <a:r>
+              <a:t>This is our live demo. First we open the Hospital Management System that we built (python app.py) and show the modules by hand. Then we run our first Selenium test, login.py, the code from the previous slide: Chrome opens by itself, types admin and admin123 and logs in. Next we run run.py: Selenium tests all 13 test cases one by one. The orange box shows which element Selenium found by its id, the caption at the bottom says what it is doing, and the terminal prints the real Selenium command behind every step and PASS for every check. To show that the tests really check something, we change the expected bill total from 1700.00 to 1800.00 and run TC13 again: the test FAILS and a screenshot is saved. Finally python report.py runs all 98 tests in about 40 seconds and opens the HTML test report.</a:t>
+            </a:r>
+          </a:p>
+        </p:txBody>
+      </p:sp>
+      <p:sp>
+        <p:nvSpPr>
+          <p:cNvPr id="4" name="Slide Number Placeholder 3"/>
+          <p:cNvSpPr>
+            <a:spLocks noGrp="1"/>
+          </p:cNvSpPr>
+          <p:nvPr>
+            <p:ph type="sldNum" idx="5" sz="quarter"/>
+          </p:nvPr>
+        </p:nvSpPr>
+        <p:spPr/>
+      </p:sp>
+    </p:spTree>
+  </p:cSld>
+  <p:clrMapOvr>
+    <a:masterClrMapping/>
+  </p:clrMapOvr>
+</p:notes>
+</file>
+
 <file path=ppt/notesSlides/notesSlide2.xml><?xml version="1.0" encoding="utf-8"?>
 <p:notes xmlns:a="http://schemas.openxmlformats.org/drawingml/2006/main" xmlns:r="http://schemas.openxmlformats.org/officeDocument/2006/relationships" xmlns:p="http://schemas.openxmlformats.org/presentationml/2006/main">
   <p:cSld>
@@ -1075,10 +1146,8 @@
           <a:lstStyle/>
           <a:p>
             <a:r>
-              <a:rPr lang="en-US" dirty="0"/>
-              <a:t>This is the same login example as in our document, written in Python. It is in our project as selenium_login_demo.py. webdriver.Chrome opens Chrome, get opens our HMS, find_element finds the username box by its id, send_keys types into it, click presses the login button. The assert line is the actual test: if the dashboard did not open, the test fails. quit closes the browser. Our full test file uses exactly these commands for all 13 test cases, run by PyTest. LIVE DEMO: run 'python -m pytest tests/ui' and Chrome will open and run all tests in front of you.</a:t>
-            </a:r>
-            <a:endParaRPr lang="en-US" dirty="0"/>
+              <a:t>This is the same login example as in our document, written in Python. It is in our project as login.py. webdriver.Chrome opens Chrome, get opens our HMS, find_element finds the username box by its id, send_keys types into it, click presses the login button. The assert line is the actual test: if the dashboard did not open, the test fails. quit closes the browser. Our full test file uses exactly these commands for all 13 test cases, run by PyTest. Now we will show this live: the next slide is our demo plan.</a:t>
+            </a:r>
           </a:p>
         </p:txBody>
       </p:sp>
@@ -1163,10 +1232,8 @@
           <a:lstStyle/>
           <a:p>
             <a:r>
-              <a:rPr lang="en-US" dirty="0"/>
-              <a:t>All 13 Selenium tests passed, and we also have 85 PyTest tests that check the validation rules and database directly, without a browser. All 98 run in about 25 seconds and produce this HTML report. Our testing also FOUND real defects. Using exploratory testing we tried to break the app on purpose: typing 'nan' as a doctor fee crashed the server, infinity was accepted as a bill amount, the same patient could be booked with two doctors at the same time, and deleting a record that does not exist still showed success. We also found that our Selenium tests failed randomly about one run in three, because Selenium checked the page while Chrome was still loading it - a common automation problem called synchronization. We fixed all 9 defects and added a regression test for each one, so they can never come back. The full list is in our README.</a:t>
-            </a:r>
-            <a:endParaRPr lang="en-US" dirty="0"/>
+              <a:t>All 13 Selenium tests passed, and we also have 85 PyTest tests that check the validation rules and database directly, without a browser. All 98 run in about 40 seconds and produce this HTML report. Our testing also FOUND real defects. Using exploratory testing we tried to break the app on purpose: typing 'nan' as a doctor fee crashed the server, infinity was accepted as a bill amount, the same patient could be booked with two doctors at the same time, and deleting a record that does not exist still showed success. We also found that our Selenium tests failed randomly about one run in three, because Selenium checked the page while Chrome was still loading it - a common automation problem called synchronization. We fixed all 9 defects and added a regression test for each one, so they can never come back. The full list is in our README.</a:t>
+            </a:r>
           </a:p>
         </p:txBody>
       </p:sp>
@@ -2330,6 +2397,739 @@
 </p:sld>
 </file>
 
+<file path=ppt/slides/slide10.xml><?xml version="1.0" encoding="utf-8"?>
+<p:sld xmlns:a="http://schemas.openxmlformats.org/drawingml/2006/main" xmlns:r="http://schemas.openxmlformats.org/officeDocument/2006/relationships" xmlns:p="http://schemas.openxmlformats.org/presentationml/2006/main">
+  <p:cSld name="Slide 9">
+    <p:spTree>
+      <p:nvGrpSpPr>
+        <p:cNvPr id="1" name=""/>
+        <p:cNvGrpSpPr/>
+        <p:nvPr/>
+      </p:nvGrpSpPr>
+      <p:grpSpPr>
+        <a:xfrm>
+          <a:off x="0" y="0"/>
+          <a:ext cx="0" cy="0"/>
+          <a:chOff x="0" y="0"/>
+          <a:chExt cx="0" cy="0"/>
+        </a:xfrm>
+      </p:grpSpPr>
+      <p:sp>
+        <p:nvSpPr>
+          <p:cNvPr id="2" name="Text 0"/>
+          <p:cNvSpPr/>
+          <p:nvPr>
+            <p:ph idx="100" type="title" hasCustomPrompt="1"/>
+          </p:nvPr>
+        </p:nvSpPr>
+        <p:spPr>
+          <a:xfrm>
+            <a:off x="548640" y="320040"/>
+            <a:ext cx="11064240" cy="777240"/>
+          </a:xfrm>
+          <a:prstGeom prst="rect">
+            <a:avLst/>
+          </a:prstGeom>
+          <a:noFill/>
+          <a:ln/>
+        </p:spPr>
+        <p:txBody>
+          <a:bodyPr wrap="square" lIns="0" tIns="0" rIns="0" bIns="0" rtlCol="0" anchor="ctr"/>
+          <a:lstStyle/>
+          <a:p>
+            <a:pPr indent="0" marL="0">
+              <a:buNone/>
+            </a:pPr>
+            <a:r>
+              <a:rPr lang="en-US" sz="3400" b="1" dirty="0">
+                <a:solidFill>
+                  <a:schemeClr val="bg1"/>
+                </a:solidFill>
+              </a:rPr>
+              <a:t>Conclusion and Future Scope</a:t>
+            </a:r>
+            <a:endParaRPr lang="en-US" sz="3400" dirty="0"/>
+          </a:p>
+        </p:txBody>
+      </p:sp>
+      <p:sp>
+        <p:nvSpPr>
+          <p:cNvPr id="3" name="Conclusion points"/>
+          <p:cNvSpPr txBox="1"/>
+          <p:nvPr/>
+        </p:nvSpPr>
+        <p:spPr>
+          <a:xfrm>
+            <a:off x="548640" y="1325880"/>
+            <a:ext cx="5120640" cy="3291840"/>
+          </a:xfrm>
+          <a:prstGeom prst="rect">
+            <a:avLst/>
+          </a:prstGeom>
+          <a:noFill/>
+          <a:ln/>
+        </p:spPr>
+        <p:txBody>
+          <a:bodyPr wrap="square" lIns="0" tIns="0" rIns="0" bIns="0" rtlCol="0" anchor="t"/>
+          <a:lstStyle/>
+          <a:p>
+            <a:pPr marL="342900" indent="-342900">
+              <a:spcAft>
+                <a:spcPts val="1400"/>
+              </a:spcAft>
+              <a:buSzPct val="100000"/>
+              <a:buChar char="•"/>
+            </a:pPr>
+            <a:r>
+              <a:rPr lang="en-US" sz="1600" dirty="0">
+                <a:solidFill>
+                  <a:schemeClr val="bg1"/>
+                </a:solidFill>
+              </a:rPr>
+              <a:t>We built a working HMS with 6 modules: login, patients, doctors, appointments, medical records and billing</a:t>
+            </a:r>
+            <a:endParaRPr lang="en-US" sz="1600" dirty="0"/>
+          </a:p>
+          <a:p>
+            <a:pPr marL="342900" indent="-342900">
+              <a:spcAft>
+                <a:spcPts val="1400"/>
+              </a:spcAft>
+              <a:buSzPct val="100000"/>
+              <a:buChar char="•"/>
+            </a:pPr>
+            <a:r>
+              <a:rPr lang="en-US" sz="1600" dirty="0">
+                <a:solidFill>
+                  <a:schemeClr val="bg1"/>
+                </a:solidFill>
+              </a:rPr>
+              <a:t>Selenium WebDriver automated every test case from our document, for valid and invalid inputs</a:t>
+            </a:r>
+            <a:endParaRPr lang="en-US" sz="1600" dirty="0"/>
+          </a:p>
+          <a:p>
+            <a:pPr marL="342900" indent="-342900">
+              <a:spcAft>
+                <a:spcPts val="1400"/>
+              </a:spcAft>
+              <a:buSzPct val="100000"/>
+              <a:buChar char="•"/>
+            </a:pPr>
+            <a:r>
+              <a:rPr lang="en-US" sz="1600" dirty="0">
+                <a:solidFill>
+                  <a:schemeClr val="bg1"/>
+                </a:solidFill>
+              </a:rPr>
+              <a:t>Automated tests run again in seconds after every change, giving fast and consistent regression testing</a:t>
+            </a:r>
+            <a:endParaRPr lang="en-US" sz="1600" dirty="0"/>
+          </a:p>
+        </p:txBody>
+      </p:sp>
+      <p:sp>
+        <p:nvSpPr>
+          <p:cNvPr id="4" name="Future scope heading"/>
+          <p:cNvSpPr txBox="1"/>
+          <p:nvPr/>
+        </p:nvSpPr>
+        <p:spPr>
+          <a:xfrm>
+            <a:off x="6217920" y="1280160"/>
+            <a:ext cx="5394960" cy="411480"/>
+          </a:xfrm>
+          <a:prstGeom prst="rect">
+            <a:avLst/>
+          </a:prstGeom>
+          <a:noFill/>
+          <a:ln/>
+        </p:spPr>
+        <p:txBody>
+          <a:bodyPr wrap="square" lIns="0" tIns="0" rIns="0" bIns="0" rtlCol="0" anchor="ctr"/>
+          <a:lstStyle/>
+          <a:p>
+            <a:pPr indent="0" marL="0">
+              <a:buNone/>
+            </a:pPr>
+            <a:r>
+              <a:rPr lang="en-US" sz="2000" b="1" dirty="0">
+                <a:solidFill>
+                  <a:schemeClr val="accent2"/>
+                </a:solidFill>
+                <a:latin typeface="Cambria" pitchFamily="34" charset="0"/>
+                <a:ea typeface="Cambria" pitchFamily="34" charset="-122"/>
+                <a:cs typeface="Cambria" pitchFamily="34" charset="-120"/>
+              </a:rPr>
+              <a:t>Future Scope</a:t>
+            </a:r>
+            <a:endParaRPr lang="en-US" sz="2000" dirty="0"/>
+          </a:p>
+        </p:txBody>
+      </p:sp>
+      <p:sp>
+        <p:nvSpPr>
+          <p:cNvPr id="5" name="AI-based test case generation icon circle"/>
+          <p:cNvSpPr/>
+          <p:nvPr/>
+        </p:nvSpPr>
+        <p:spPr>
+          <a:xfrm>
+            <a:off x="6217920" y="1874520"/>
+            <a:ext cx="548640" cy="548640"/>
+          </a:xfrm>
+          <a:prstGeom prst="ellipse">
+            <a:avLst/>
+          </a:prstGeom>
+          <a:solidFill>
+            <a:schemeClr val="accent1"/>
+          </a:solidFill>
+          <a:ln/>
+        </p:spPr>
+      </p:sp>
+      <p:pic>
+        <p:nvPicPr>
+          <p:cNvPr id="6" name="AI-based test case generation icon" descr="preencoded.png">    </p:cNvPr>
+          <p:cNvPicPr>
+            <a:picLocks noChangeAspect="1"/>
+          </p:cNvPicPr>
+          <p:nvPr/>
+        </p:nvPicPr>
+        <p:blipFill>
+          <a:blip r:embed="rId1"/>
+          <a:stretch>
+            <a:fillRect/>
+          </a:stretch>
+        </p:blipFill>
+        <p:spPr>
+          <a:xfrm>
+            <a:off x="6355080" y="2011680"/>
+            <a:ext cx="274320" cy="274320"/>
+          </a:xfrm>
+          <a:prstGeom prst="rect">
+            <a:avLst/>
+          </a:prstGeom>
+        </p:spPr>
+      </p:pic>
+      <p:sp>
+        <p:nvSpPr>
+          <p:cNvPr id="7" name="AI-based test case generation"/>
+          <p:cNvSpPr txBox="1"/>
+          <p:nvPr/>
+        </p:nvSpPr>
+        <p:spPr>
+          <a:xfrm>
+            <a:off x="6903720" y="1874520"/>
+            <a:ext cx="1965960" cy="548640"/>
+          </a:xfrm>
+          <a:prstGeom prst="rect">
+            <a:avLst/>
+          </a:prstGeom>
+          <a:noFill/>
+          <a:ln/>
+        </p:spPr>
+        <p:txBody>
+          <a:bodyPr wrap="square" lIns="0" tIns="0" rIns="0" bIns="0" rtlCol="0" anchor="ctr"/>
+          <a:lstStyle/>
+          <a:p>
+            <a:pPr indent="0" marL="0">
+              <a:buNone/>
+            </a:pPr>
+            <a:r>
+              <a:rPr lang="en-US" sz="1300" dirty="0">
+                <a:solidFill>
+                  <a:schemeClr val="bg1"/>
+                </a:solidFill>
+              </a:rPr>
+              <a:t>AI-based test case generation</a:t>
+            </a:r>
+            <a:endParaRPr lang="en-US" sz="1300" dirty="0"/>
+          </a:p>
+        </p:txBody>
+      </p:sp>
+      <p:sp>
+        <p:nvSpPr>
+          <p:cNvPr id="8" name="Cross-browser testing with Selenium Grid icon circle"/>
+          <p:cNvSpPr/>
+          <p:nvPr/>
+        </p:nvSpPr>
+        <p:spPr>
+          <a:xfrm>
+            <a:off x="8961120" y="1874520"/>
+            <a:ext cx="548640" cy="548640"/>
+          </a:xfrm>
+          <a:prstGeom prst="ellipse">
+            <a:avLst/>
+          </a:prstGeom>
+          <a:solidFill>
+            <a:schemeClr val="accent1"/>
+          </a:solidFill>
+          <a:ln/>
+        </p:spPr>
+      </p:sp>
+      <p:pic>
+        <p:nvPicPr>
+          <p:cNvPr id="9" name="Cross-browser testing with Selenium Grid icon" descr="preencoded.png">    </p:cNvPr>
+          <p:cNvPicPr>
+            <a:picLocks noChangeAspect="1"/>
+          </p:cNvPicPr>
+          <p:nvPr/>
+        </p:nvPicPr>
+        <p:blipFill>
+          <a:blip r:embed="rId2"/>
+          <a:stretch>
+            <a:fillRect/>
+          </a:stretch>
+        </p:blipFill>
+        <p:spPr>
+          <a:xfrm>
+            <a:off x="9098280" y="2011680"/>
+            <a:ext cx="274320" cy="274320"/>
+          </a:xfrm>
+          <a:prstGeom prst="rect">
+            <a:avLst/>
+          </a:prstGeom>
+        </p:spPr>
+      </p:pic>
+      <p:sp>
+        <p:nvSpPr>
+          <p:cNvPr id="10" name="Cross-browser testing with Selenium Grid"/>
+          <p:cNvSpPr txBox="1"/>
+          <p:nvPr/>
+        </p:nvSpPr>
+        <p:spPr>
+          <a:xfrm>
+            <a:off x="9646920" y="1874520"/>
+            <a:ext cx="1965960" cy="548640"/>
+          </a:xfrm>
+          <a:prstGeom prst="rect">
+            <a:avLst/>
+          </a:prstGeom>
+          <a:noFill/>
+          <a:ln/>
+        </p:spPr>
+        <p:txBody>
+          <a:bodyPr wrap="square" lIns="0" tIns="0" rIns="0" bIns="0" rtlCol="0" anchor="ctr"/>
+          <a:lstStyle/>
+          <a:p>
+            <a:pPr indent="0" marL="0">
+              <a:buNone/>
+            </a:pPr>
+            <a:r>
+              <a:rPr lang="en-US" sz="1300" dirty="0">
+                <a:solidFill>
+                  <a:schemeClr val="bg1"/>
+                </a:solidFill>
+              </a:rPr>
+              <a:t>Cross-browser testing with Selenium Grid</a:t>
+            </a:r>
+            <a:endParaRPr lang="en-US" sz="1300" dirty="0"/>
+          </a:p>
+        </p:txBody>
+      </p:sp>
+      <p:sp>
+        <p:nvSpPr>
+          <p:cNvPr id="11" name="CI pipeline: tests run on every code change icon circle"/>
+          <p:cNvSpPr/>
+          <p:nvPr/>
+        </p:nvSpPr>
+        <p:spPr>
+          <a:xfrm>
+            <a:off x="6217920" y="2788920"/>
+            <a:ext cx="548640" cy="548640"/>
+          </a:xfrm>
+          <a:prstGeom prst="ellipse">
+            <a:avLst/>
+          </a:prstGeom>
+          <a:solidFill>
+            <a:schemeClr val="accent1"/>
+          </a:solidFill>
+          <a:ln/>
+        </p:spPr>
+      </p:sp>
+      <p:pic>
+        <p:nvPicPr>
+          <p:cNvPr id="12" name="CI pipeline: tests run on every code change icon" descr="preencoded.png">    </p:cNvPr>
+          <p:cNvPicPr>
+            <a:picLocks noChangeAspect="1"/>
+          </p:cNvPicPr>
+          <p:nvPr/>
+        </p:nvPicPr>
+        <p:blipFill>
+          <a:blip r:embed="rId3"/>
+          <a:stretch>
+            <a:fillRect/>
+          </a:stretch>
+        </p:blipFill>
+        <p:spPr>
+          <a:xfrm>
+            <a:off x="6355080" y="2926080"/>
+            <a:ext cx="274320" cy="274320"/>
+          </a:xfrm>
+          <a:prstGeom prst="rect">
+            <a:avLst/>
+          </a:prstGeom>
+        </p:spPr>
+      </p:pic>
+      <p:sp>
+        <p:nvSpPr>
+          <p:cNvPr id="13" name="CI pipeline: tests run on every code change"/>
+          <p:cNvSpPr txBox="1"/>
+          <p:nvPr/>
+        </p:nvSpPr>
+        <p:spPr>
+          <a:xfrm>
+            <a:off x="6903720" y="2788920"/>
+            <a:ext cx="1965960" cy="548640"/>
+          </a:xfrm>
+          <a:prstGeom prst="rect">
+            <a:avLst/>
+          </a:prstGeom>
+          <a:noFill/>
+          <a:ln/>
+        </p:spPr>
+        <p:txBody>
+          <a:bodyPr wrap="square" lIns="0" tIns="0" rIns="0" bIns="0" rtlCol="0" anchor="ctr"/>
+          <a:lstStyle/>
+          <a:p>
+            <a:pPr indent="0" marL="0">
+              <a:buNone/>
+            </a:pPr>
+            <a:r>
+              <a:rPr lang="en-US" sz="1300" dirty="0">
+                <a:solidFill>
+                  <a:schemeClr val="bg1"/>
+                </a:solidFill>
+              </a:rPr>
+              <a:t>CI pipeline: tests run on every code change</a:t>
+            </a:r>
+            <a:endParaRPr lang="en-US" sz="1300" dirty="0"/>
+          </a:p>
+        </p:txBody>
+      </p:sp>
+      <p:sp>
+        <p:nvSpPr>
+          <p:cNvPr id="14" name="Performance and load testing icon circle"/>
+          <p:cNvSpPr/>
+          <p:nvPr/>
+        </p:nvSpPr>
+        <p:spPr>
+          <a:xfrm>
+            <a:off x="8961120" y="2788920"/>
+            <a:ext cx="548640" cy="548640"/>
+          </a:xfrm>
+          <a:prstGeom prst="ellipse">
+            <a:avLst/>
+          </a:prstGeom>
+          <a:solidFill>
+            <a:schemeClr val="accent1"/>
+          </a:solidFill>
+          <a:ln/>
+        </p:spPr>
+      </p:sp>
+      <p:pic>
+        <p:nvPicPr>
+          <p:cNvPr id="15" name="Performance and load testing icon" descr="preencoded.png">    </p:cNvPr>
+          <p:cNvPicPr>
+            <a:picLocks noChangeAspect="1"/>
+          </p:cNvPicPr>
+          <p:nvPr/>
+        </p:nvPicPr>
+        <p:blipFill>
+          <a:blip r:embed="rId4"/>
+          <a:stretch>
+            <a:fillRect/>
+          </a:stretch>
+        </p:blipFill>
+        <p:spPr>
+          <a:xfrm>
+            <a:off x="9098280" y="2926080"/>
+            <a:ext cx="274320" cy="274320"/>
+          </a:xfrm>
+          <a:prstGeom prst="rect">
+            <a:avLst/>
+          </a:prstGeom>
+        </p:spPr>
+      </p:pic>
+      <p:sp>
+        <p:nvSpPr>
+          <p:cNvPr id="16" name="Performance and load testing"/>
+          <p:cNvSpPr txBox="1"/>
+          <p:nvPr/>
+        </p:nvSpPr>
+        <p:spPr>
+          <a:xfrm>
+            <a:off x="9646920" y="2788920"/>
+            <a:ext cx="1965960" cy="548640"/>
+          </a:xfrm>
+          <a:prstGeom prst="rect">
+            <a:avLst/>
+          </a:prstGeom>
+          <a:noFill/>
+          <a:ln/>
+        </p:spPr>
+        <p:txBody>
+          <a:bodyPr wrap="square" lIns="0" tIns="0" rIns="0" bIns="0" rtlCol="0" anchor="ctr"/>
+          <a:lstStyle/>
+          <a:p>
+            <a:pPr indent="0" marL="0">
+              <a:buNone/>
+            </a:pPr>
+            <a:r>
+              <a:rPr lang="en-US" sz="1300" dirty="0">
+                <a:solidFill>
+                  <a:schemeClr val="bg1"/>
+                </a:solidFill>
+              </a:rPr>
+              <a:t>Performance and load testing</a:t>
+            </a:r>
+            <a:endParaRPr lang="en-US" sz="1300" dirty="0"/>
+          </a:p>
+        </p:txBody>
+      </p:sp>
+      <p:sp>
+        <p:nvSpPr>
+          <p:cNvPr id="17" name="Mobile app testing with Appium icon circle"/>
+          <p:cNvSpPr/>
+          <p:nvPr/>
+        </p:nvSpPr>
+        <p:spPr>
+          <a:xfrm>
+            <a:off x="6217920" y="3703320"/>
+            <a:ext cx="548640" cy="548640"/>
+          </a:xfrm>
+          <a:prstGeom prst="ellipse">
+            <a:avLst/>
+          </a:prstGeom>
+          <a:solidFill>
+            <a:schemeClr val="accent1"/>
+          </a:solidFill>
+          <a:ln/>
+        </p:spPr>
+      </p:sp>
+      <p:pic>
+        <p:nvPicPr>
+          <p:cNvPr id="18" name="Mobile app testing with Appium icon" descr="preencoded.png">    </p:cNvPr>
+          <p:cNvPicPr>
+            <a:picLocks noChangeAspect="1"/>
+          </p:cNvPicPr>
+          <p:nvPr/>
+        </p:nvPicPr>
+        <p:blipFill>
+          <a:blip r:embed="rId5"/>
+          <a:stretch>
+            <a:fillRect/>
+          </a:stretch>
+        </p:blipFill>
+        <p:spPr>
+          <a:xfrm>
+            <a:off x="6355080" y="3840480"/>
+            <a:ext cx="274320" cy="274320"/>
+          </a:xfrm>
+          <a:prstGeom prst="rect">
+            <a:avLst/>
+          </a:prstGeom>
+        </p:spPr>
+      </p:pic>
+      <p:sp>
+        <p:nvSpPr>
+          <p:cNvPr id="19" name="Mobile app testing with Appium"/>
+          <p:cNvSpPr txBox="1"/>
+          <p:nvPr/>
+        </p:nvSpPr>
+        <p:spPr>
+          <a:xfrm>
+            <a:off x="6903720" y="3703320"/>
+            <a:ext cx="1965960" cy="548640"/>
+          </a:xfrm>
+          <a:prstGeom prst="rect">
+            <a:avLst/>
+          </a:prstGeom>
+          <a:noFill/>
+          <a:ln/>
+        </p:spPr>
+        <p:txBody>
+          <a:bodyPr wrap="square" lIns="0" tIns="0" rIns="0" bIns="0" rtlCol="0" anchor="ctr"/>
+          <a:lstStyle/>
+          <a:p>
+            <a:pPr indent="0" marL="0">
+              <a:buNone/>
+            </a:pPr>
+            <a:r>
+              <a:rPr lang="en-US" sz="1300" dirty="0">
+                <a:solidFill>
+                  <a:schemeClr val="bg1"/>
+                </a:solidFill>
+              </a:rPr>
+              <a:t>Mobile app testing with Appium</a:t>
+            </a:r>
+            <a:endParaRPr lang="en-US" sz="1300" dirty="0"/>
+          </a:p>
+        </p:txBody>
+      </p:sp>
+      <p:sp>
+        <p:nvSpPr>
+          <p:cNvPr id="20" name="Security testing of login and data icon circle"/>
+          <p:cNvSpPr/>
+          <p:nvPr/>
+        </p:nvSpPr>
+        <p:spPr>
+          <a:xfrm>
+            <a:off x="8961120" y="3703320"/>
+            <a:ext cx="548640" cy="548640"/>
+          </a:xfrm>
+          <a:prstGeom prst="ellipse">
+            <a:avLst/>
+          </a:prstGeom>
+          <a:solidFill>
+            <a:schemeClr val="accent1"/>
+          </a:solidFill>
+          <a:ln/>
+        </p:spPr>
+      </p:sp>
+      <p:pic>
+        <p:nvPicPr>
+          <p:cNvPr id="21" name="Security testing of login and data icon" descr="preencoded.png">    </p:cNvPr>
+          <p:cNvPicPr>
+            <a:picLocks noChangeAspect="1"/>
+          </p:cNvPicPr>
+          <p:nvPr/>
+        </p:nvPicPr>
+        <p:blipFill>
+          <a:blip r:embed="rId6"/>
+          <a:stretch>
+            <a:fillRect/>
+          </a:stretch>
+        </p:blipFill>
+        <p:spPr>
+          <a:xfrm>
+            <a:off x="9098280" y="3840480"/>
+            <a:ext cx="274320" cy="274320"/>
+          </a:xfrm>
+          <a:prstGeom prst="rect">
+            <a:avLst/>
+          </a:prstGeom>
+        </p:spPr>
+      </p:pic>
+      <p:sp>
+        <p:nvSpPr>
+          <p:cNvPr id="22" name="Security testing of login and data"/>
+          <p:cNvSpPr txBox="1"/>
+          <p:nvPr/>
+        </p:nvSpPr>
+        <p:spPr>
+          <a:xfrm>
+            <a:off x="9646920" y="3703320"/>
+            <a:ext cx="1965960" cy="548640"/>
+          </a:xfrm>
+          <a:prstGeom prst="rect">
+            <a:avLst/>
+          </a:prstGeom>
+          <a:noFill/>
+          <a:ln/>
+        </p:spPr>
+        <p:txBody>
+          <a:bodyPr wrap="square" lIns="0" tIns="0" rIns="0" bIns="0" rtlCol="0" anchor="ctr"/>
+          <a:lstStyle/>
+          <a:p>
+            <a:pPr indent="0" marL="0">
+              <a:buNone/>
+            </a:pPr>
+            <a:r>
+              <a:rPr lang="en-US" sz="1300" dirty="0">
+                <a:solidFill>
+                  <a:schemeClr val="bg1"/>
+                </a:solidFill>
+              </a:rPr>
+              <a:t>Security testing of login and data</a:t>
+            </a:r>
+            <a:endParaRPr lang="en-US" sz="1300" dirty="0"/>
+          </a:p>
+        </p:txBody>
+      </p:sp>
+      <p:sp>
+        <p:nvSpPr>
+          <p:cNvPr id="23" name="Thank you box"/>
+          <p:cNvSpPr/>
+          <p:nvPr/>
+        </p:nvSpPr>
+        <p:spPr>
+          <a:xfrm>
+            <a:off x="548640" y="4983480"/>
+            <a:ext cx="11064240" cy="1188720"/>
+          </a:xfrm>
+          <a:prstGeom prst="roundRect">
+            <a:avLst>
+              <a:gd name="adj" fmla="val 7692"/>
+            </a:avLst>
+          </a:prstGeom>
+          <a:solidFill>
+            <a:schemeClr val="accent1"/>
+          </a:solidFill>
+          <a:ln/>
+        </p:spPr>
+      </p:sp>
+      <p:sp>
+        <p:nvSpPr>
+          <p:cNvPr id="24" name="Thank you text"/>
+          <p:cNvSpPr txBox="1"/>
+          <p:nvPr/>
+        </p:nvSpPr>
+        <p:spPr>
+          <a:xfrm>
+            <a:off x="548640" y="4983480"/>
+            <a:ext cx="11064240" cy="1188720"/>
+          </a:xfrm>
+          <a:prstGeom prst="rect">
+            <a:avLst/>
+          </a:prstGeom>
+          <a:noFill/>
+          <a:ln/>
+        </p:spPr>
+        <p:txBody>
+          <a:bodyPr wrap="square" lIns="0" tIns="0" rIns="0" bIns="0" rtlCol="0" anchor="ctr"/>
+          <a:lstStyle/>
+          <a:p>
+            <a:pPr algn="ctr" indent="0" marL="0">
+              <a:buNone/>
+            </a:pPr>
+            <a:r>
+              <a:rPr lang="en-US" sz="3000" b="1" dirty="0">
+                <a:solidFill>
+                  <a:schemeClr val="bg1"/>
+                </a:solidFill>
+                <a:latin typeface="Cambria" pitchFamily="34" charset="0"/>
+                <a:ea typeface="Cambria" pitchFamily="34" charset="-122"/>
+                <a:cs typeface="Cambria" pitchFamily="34" charset="-120"/>
+              </a:rPr>
+              <a:t>Thank You</a:t>
+            </a:r>
+            <a:endParaRPr lang="en-US" sz="3000" dirty="0"/>
+          </a:p>
+          <a:p>
+            <a:pPr algn="ctr" indent="0" marL="0">
+              <a:buNone/>
+            </a:pPr>
+            <a:r>
+              <a:rPr lang="en-US" sz="1500" dirty="0">
+                <a:solidFill>
+                  <a:schemeClr val="bg1"/>
+                </a:solidFill>
+              </a:rPr>
+              <a:t>Questions?  |  Arun C (23MIS0445)  |  Sai Chandan K S (23MIS0115)</a:t>
+            </a:r>
+            <a:endParaRPr lang="en-US" sz="3000" dirty="0"/>
+          </a:p>
+        </p:txBody>
+      </p:sp>
+    </p:spTree>
+  </p:cSld>
+  <p:clrMapOvr>
+    <a:masterClrMapping/>
+  </p:clrMapOvr>
+</p:sld>
+</file>
+
 <file path=ppt/slides/slide2.xml><?xml version="1.0" encoding="utf-8"?>
 <p:sld xmlns:a="http://schemas.openxmlformats.org/drawingml/2006/main" xmlns:r="http://schemas.openxmlformats.org/officeDocument/2006/relationships" xmlns:p="http://schemas.openxmlformats.org/presentationml/2006/main">
   <p:cSld name="Slide 2">
@@ -4917,7 +5717,7 @@
           <p:nvPr/>
         </p:nvPicPr>
         <p:blipFill>
-          <a:blip r:embed="rId6"/>
+          <a:blip r:embed="rId9"/>
           <a:stretch>
             <a:fillRect/>
           </a:stretch>
@@ -10549,7 +11349,7 @@
                 <a:ea typeface="Courier New" pitchFamily="34" charset="-122"/>
                 <a:cs typeface="Courier New" pitchFamily="34" charset="-120"/>
               </a:rPr>
-              <a:t>selenium_login_demo.py</a:t>
+              <a:t>login.py</a:t>
             </a:r>
             <a:endParaRPr lang="en-US" sz="1200" dirty="0"/>
           </a:p>
@@ -10887,7 +11687,7 @@
                 <a:ea typeface="Courier New" pitchFamily="34" charset="-122"/>
                 <a:cs typeface="Courier New" pitchFamily="34" charset="-120"/>
               </a:rPr>
-              <a:t>$ python selenium_login_demo.py</a:t>
+              <a:t>$ python login.py</a:t>
             </a:r>
             <a:endParaRPr lang="en-US" sz="1200" dirty="0"/>
           </a:p>
@@ -11489,6 +12289,624 @@
 </file>
 
 <file path=ppt/slides/slide8.xml><?xml version="1.0" encoding="utf-8"?>
+<p:sld xmlns:a="http://schemas.openxmlformats.org/drawingml/2006/main" xmlns:p="http://schemas.openxmlformats.org/presentationml/2006/main" xmlns:r="http://schemas.openxmlformats.org/officeDocument/2006/relationships">
+  <p:cSld>
+    <p:spTree>
+      <p:nvGrpSpPr>
+        <p:cNvPr id="1" name=""/>
+        <p:cNvGrpSpPr/>
+        <p:nvPr/>
+      </p:nvGrpSpPr>
+      <p:grpSpPr/>
+      <p:sp>
+        <p:nvSpPr>
+          <p:cNvPr id="3" name="Text 0"/>
+          <p:cNvSpPr/>
+          <p:nvPr>
+            <p:ph idx="100" type="title" hasCustomPrompt="1"/>
+          </p:nvPr>
+        </p:nvSpPr>
+        <p:spPr>
+          <a:xfrm>
+            <a:off x="548640" y="320040"/>
+            <a:ext cx="11064240" cy="777240"/>
+          </a:xfrm>
+          <a:prstGeom prst="rect">
+            <a:avLst/>
+          </a:prstGeom>
+          <a:noFill/>
+          <a:ln/>
+        </p:spPr>
+        <p:txBody>
+          <a:bodyPr wrap="square" lIns="0" tIns="0" rIns="0" bIns="0" rtlCol="0" anchor="ctr"/>
+          <a:lstStyle/>
+          <a:p>
+            <a:pPr indent="0" marL="0">
+              <a:buNone/>
+            </a:pPr>
+            <a:r>
+              <a:rPr lang="en-US" sz="3400" b="1" dirty="0">
+                <a:solidFill>
+                  <a:schemeClr val="tx2"/>
+                </a:solidFill>
+              </a:rPr>
+              <a:t>Live Demo: Selenium Tests Our HMS</a:t>
+            </a:r>
+            <a:endParaRPr lang="en-US" sz="3400" dirty="0"/>
+          </a:p>
+        </p:txBody>
+      </p:sp>
+      <p:sp>
+        <p:nvSpPr>
+          <p:cNvPr id="26" name="Slide Number Placeholder 0"/>
+          <p:cNvSpPr>
+            <a:spLocks noGrp="1"/>
+          </p:cNvSpPr>
+          <p:nvPr>
+            <p:ph type="sldNum" sz="quarter" idx="4294967295"/>
+          </p:nvPr>
+        </p:nvSpPr>
+        <p:spPr>
+          <a:xfrm>
+            <a:off x="11155680" y="6400800"/>
+            <a:ext cx="457200" cy="274320"/>
+          </a:xfrm>
+          <a:prstGeom prst="rect">
+            <a:avLst/>
+          </a:prstGeom>
+          <a:extLst>
+            <a:ext uri="{C572A759-6A51-4108-AA02-DFA0A04FC94B}">
+              <ma14:wrappingTextBoxFlag xmlns:ma14="http://schemas.microsoft.com/office/mac/drawingml/2011/main" val="0"/>
+            </a:ext>
+          </a:extLst>
+        </p:spPr>
+        <p:txBody>
+          <a:bodyPr/>
+          <a:lstStyle>
+            <a:lvl1pPr>
+              <a:defRPr sz="1000">
+                <a:solidFill>
+                  <a:schemeClr val="accent6"/>
+                </a:solidFill>
+              </a:defRPr>
+            </a:lvl1pPr>
+          </a:lstStyle>
+          <a:p>
+            <a:pPr algn="r"/>
+            <a:fld id="{F7021451-1387-4CA6-816F-3879F97B5CBC}" type="slidenum">
+              <a:rPr b="0" lang="en-US"/>
+              <a:t>7</a:t>
+            </a:fld>
+            <a:endParaRPr lang="en-US"/>
+          </a:p>
+        </p:txBody>
+      </p:sp>
+      <p:pic>
+        <p:nvPicPr>
+          <p:cNvPr id="27" name="Live demo screenshot" descr="demo_01_selenium_typing.png"/>
+          <p:cNvPicPr>
+            <a:picLocks noChangeAspect="1"/>
+          </p:cNvPicPr>
+          <p:nvPr/>
+        </p:nvPicPr>
+        <p:blipFill>
+          <a:blip r:embed="rId2"/>
+          <a:stretch>
+            <a:fillRect/>
+          </a:stretch>
+        </p:blipFill>
+        <p:spPr>
+          <a:xfrm>
+            <a:off x="548640" y="1280160"/>
+            <a:ext cx="6766560" cy="3091271"/>
+          </a:xfrm>
+          <a:prstGeom prst="rect">
+            <a:avLst/>
+          </a:prstGeom>
+        </p:spPr>
+      </p:pic>
+      <p:sp>
+        <p:nvSpPr>
+          <p:cNvPr id="28" name="Report frame"/>
+          <p:cNvSpPr/>
+          <p:nvPr/>
+        </p:nvSpPr>
+        <p:spPr>
+          <a:xfrm>
+            <a:off x="548640" y="1280160"/>
+            <a:ext cx="6766560" cy="3091271"/>
+          </a:xfrm>
+          <a:prstGeom prst="rect">
+            <a:avLst/>
+          </a:prstGeom>
+          <a:ln w="12700">
+            <a:solidFill>
+              <a:srgbClr val="C9D7DB"/>
+            </a:solidFill>
+            <a:prstDash val="solid"/>
+          </a:ln>
+        </p:spPr>
+        <p:txBody>
+          <a:bodyPr/>
+          <a:p/>
+        </p:txBody>
+      </p:sp>
+      <p:sp>
+        <p:nvSpPr>
+          <p:cNvPr id="29" name="Report caption"/>
+          <p:cNvSpPr txBox="1"/>
+          <p:nvPr/>
+        </p:nvSpPr>
+        <p:spPr>
+          <a:xfrm>
+            <a:off x="548640" y="4462871"/>
+            <a:ext cx="6766560" cy="274320"/>
+          </a:xfrm>
+          <a:prstGeom prst="rect">
+            <a:avLst/>
+          </a:prstGeom>
+          <a:noFill/>
+          <a:ln/>
+        </p:spPr>
+        <p:txBody>
+          <a:bodyPr wrap="square" lIns="0" tIns="0" rIns="0" bIns="0" rtlCol="0" anchor="ctr"/>
+          <a:lstStyle/>
+          <a:p>
+            <a:pPr indent="0" marL="0">
+              <a:buNone/>
+            </a:pPr>
+            <a:r>
+              <a:rPr lang="en-US" sz="1100" i="1" dirty="0">
+                <a:solidFill>
+                  <a:schemeClr val="accent6"/>
+                </a:solidFill>
+              </a:rPr>
+              <a:t>python run.py: Selenium highlights every field it uses and prints the Selenium command behind it</a:t>
+            </a:r>
+            <a:endParaRPr lang="en-US" sz="1100" dirty="0"/>
+          </a:p>
+        </p:txBody>
+      </p:sp>
+      <p:sp>
+        <p:nvSpPr>
+          <p:cNvPr id="30" name="Demo step 1 box"/>
+          <p:cNvSpPr/>
+          <p:nvPr/>
+        </p:nvSpPr>
+        <p:spPr>
+          <a:xfrm>
+            <a:off x="7589520" y="1280160"/>
+            <a:ext cx="4023360" cy="566928"/>
+          </a:xfrm>
+          <a:prstGeom prst="roundRect">
+            <a:avLst>
+              <a:gd name="adj" fmla="val 12903"/>
+            </a:avLst>
+          </a:prstGeom>
+          <a:solidFill>
+            <a:schemeClr val="bg2"/>
+          </a:solidFill>
+          <a:ln/>
+        </p:spPr>
+        <p:txBody>
+          <a:bodyPr/>
+          <a:p/>
+        </p:txBody>
+      </p:sp>
+      <p:sp>
+        <p:nvSpPr>
+          <p:cNvPr id="31" name="Demo step 1 text"/>
+          <p:cNvSpPr txBox="1"/>
+          <p:nvPr/>
+        </p:nvSpPr>
+        <p:spPr>
+          <a:xfrm>
+            <a:off x="7726680" y="1280160"/>
+            <a:ext cx="3794760" cy="566928"/>
+          </a:xfrm>
+          <a:prstGeom prst="rect">
+            <a:avLst/>
+          </a:prstGeom>
+          <a:noFill/>
+          <a:ln/>
+        </p:spPr>
+        <p:txBody>
+          <a:bodyPr wrap="square" lIns="0" tIns="0" rIns="0" bIns="0" rtlCol="0" anchor="ctr"/>
+          <a:lstStyle/>
+          <a:p>
+            <a:pPr indent="0" marL="0">
+              <a:buNone/>
+            </a:pPr>
+            <a:r>
+              <a:rPr lang="en-US" sz="1300" b="1" dirty="0">
+                <a:solidFill>
+                  <a:schemeClr val="accent1"/>
+                </a:solidFill>
+                <a:latin typeface="Courier New" pitchFamily="34" charset="0"/>
+                <a:ea typeface="Courier New" pitchFamily="34" charset="-122"/>
+                <a:cs typeface="Courier New" pitchFamily="34" charset="-120"/>
+              </a:rPr>
+              <a:t>1  python app.py</a:t>
+            </a:r>
+            <a:endParaRPr lang="en-US" sz="1300" dirty="0"/>
+          </a:p>
+          <a:p>
+            <a:pPr indent="0" marL="0">
+              <a:buNone/>
+            </a:pPr>
+            <a:r>
+              <a:rPr lang="en-US" sz="1300" dirty="0">
+                <a:solidFill>
+                  <a:schemeClr val="tx1"/>
+                </a:solidFill>
+              </a:rPr>
+              <a:t>Show our running Hospital Management System</a:t>
+            </a:r>
+            <a:endParaRPr lang="en-US" sz="1300" dirty="0"/>
+          </a:p>
+        </p:txBody>
+      </p:sp>
+      <p:sp>
+        <p:nvSpPr>
+          <p:cNvPr id="32" name="Demo step 2 box"/>
+          <p:cNvSpPr/>
+          <p:nvPr/>
+        </p:nvSpPr>
+        <p:spPr>
+          <a:xfrm>
+            <a:off x="7589520" y="1965960"/>
+            <a:ext cx="4023360" cy="566928"/>
+          </a:xfrm>
+          <a:prstGeom prst="roundRect">
+            <a:avLst>
+              <a:gd name="adj" fmla="val 12903"/>
+            </a:avLst>
+          </a:prstGeom>
+          <a:solidFill>
+            <a:schemeClr val="bg2"/>
+          </a:solidFill>
+          <a:ln/>
+        </p:spPr>
+        <p:txBody>
+          <a:bodyPr/>
+          <a:p/>
+        </p:txBody>
+      </p:sp>
+      <p:sp>
+        <p:nvSpPr>
+          <p:cNvPr id="33" name="Demo step 2 text"/>
+          <p:cNvSpPr txBox="1"/>
+          <p:nvPr/>
+        </p:nvSpPr>
+        <p:spPr>
+          <a:xfrm>
+            <a:off x="7726680" y="1965960"/>
+            <a:ext cx="3794760" cy="566928"/>
+          </a:xfrm>
+          <a:prstGeom prst="rect">
+            <a:avLst/>
+          </a:prstGeom>
+          <a:noFill/>
+          <a:ln/>
+        </p:spPr>
+        <p:txBody>
+          <a:bodyPr wrap="square" lIns="0" tIns="0" rIns="0" bIns="0" rtlCol="0" anchor="ctr"/>
+          <a:lstStyle/>
+          <a:p>
+            <a:pPr indent="0" marL="0">
+              <a:buNone/>
+            </a:pPr>
+            <a:r>
+              <a:rPr lang="en-US" sz="1300" b="1" dirty="0">
+                <a:solidFill>
+                  <a:schemeClr val="accent1"/>
+                </a:solidFill>
+                <a:latin typeface="Courier New" pitchFamily="34" charset="0"/>
+                <a:ea typeface="Courier New" pitchFamily="34" charset="-122"/>
+                <a:cs typeface="Courier New" pitchFamily="34" charset="-120"/>
+              </a:rPr>
+              <a:t>2  python login.py</a:t>
+            </a:r>
+            <a:endParaRPr lang="en-US" sz="1300" dirty="0"/>
+          </a:p>
+          <a:p>
+            <a:pPr indent="0" marL="0">
+              <a:buNone/>
+            </a:pPr>
+            <a:r>
+              <a:rPr lang="en-US" sz="1300" dirty="0">
+                <a:solidFill>
+                  <a:schemeClr val="tx1"/>
+                </a:solidFill>
+              </a:rPr>
+              <a:t>Our first Selenium test (code on slide 7)</a:t>
+            </a:r>
+            <a:endParaRPr lang="en-US" sz="1300" dirty="0"/>
+          </a:p>
+        </p:txBody>
+      </p:sp>
+      <p:sp>
+        <p:nvSpPr>
+          <p:cNvPr id="34" name="Demo step 3 box"/>
+          <p:cNvSpPr/>
+          <p:nvPr/>
+        </p:nvSpPr>
+        <p:spPr>
+          <a:xfrm>
+            <a:off x="7589520" y="2651760"/>
+            <a:ext cx="4023360" cy="566928"/>
+          </a:xfrm>
+          <a:prstGeom prst="roundRect">
+            <a:avLst>
+              <a:gd name="adj" fmla="val 12903"/>
+            </a:avLst>
+          </a:prstGeom>
+          <a:solidFill>
+            <a:schemeClr val="bg2"/>
+          </a:solidFill>
+          <a:ln/>
+        </p:spPr>
+        <p:txBody>
+          <a:bodyPr/>
+          <a:p/>
+        </p:txBody>
+      </p:sp>
+      <p:sp>
+        <p:nvSpPr>
+          <p:cNvPr id="35" name="Demo step 3 text"/>
+          <p:cNvSpPr txBox="1"/>
+          <p:nvPr/>
+        </p:nvSpPr>
+        <p:spPr>
+          <a:xfrm>
+            <a:off x="7726680" y="2651760"/>
+            <a:ext cx="3794760" cy="566928"/>
+          </a:xfrm>
+          <a:prstGeom prst="rect">
+            <a:avLst/>
+          </a:prstGeom>
+          <a:noFill/>
+          <a:ln/>
+        </p:spPr>
+        <p:txBody>
+          <a:bodyPr wrap="square" lIns="0" tIns="0" rIns="0" bIns="0" rtlCol="0" anchor="ctr"/>
+          <a:lstStyle/>
+          <a:p>
+            <a:pPr indent="0" marL="0">
+              <a:buNone/>
+            </a:pPr>
+            <a:r>
+              <a:rPr lang="en-US" sz="1300" b="1" dirty="0">
+                <a:solidFill>
+                  <a:schemeClr val="accent1"/>
+                </a:solidFill>
+                <a:latin typeface="Courier New" pitchFamily="34" charset="0"/>
+                <a:ea typeface="Courier New" pitchFamily="34" charset="-122"/>
+                <a:cs typeface="Courier New" pitchFamily="34" charset="-120"/>
+              </a:rPr>
+              <a:t>3  python run.py --step</a:t>
+            </a:r>
+            <a:endParaRPr lang="en-US" sz="1300" dirty="0"/>
+          </a:p>
+          <a:p>
+            <a:pPr indent="0" marL="0">
+              <a:buNone/>
+            </a:pPr>
+            <a:r>
+              <a:rPr lang="en-US" sz="1300" dirty="0">
+                <a:solidFill>
+                  <a:schemeClr val="tx1"/>
+                </a:solidFill>
+              </a:rPr>
+              <a:t>Selenium runs all 13 test cases in front of you</a:t>
+            </a:r>
+            <a:endParaRPr lang="en-US" sz="1300" dirty="0"/>
+          </a:p>
+        </p:txBody>
+      </p:sp>
+      <p:sp>
+        <p:nvSpPr>
+          <p:cNvPr id="36" name="Demo step 4 box"/>
+          <p:cNvSpPr/>
+          <p:nvPr/>
+        </p:nvSpPr>
+        <p:spPr>
+          <a:xfrm>
+            <a:off x="7589520" y="3337560"/>
+            <a:ext cx="4023360" cy="566928"/>
+          </a:xfrm>
+          <a:prstGeom prst="roundRect">
+            <a:avLst>
+              <a:gd name="adj" fmla="val 12903"/>
+            </a:avLst>
+          </a:prstGeom>
+          <a:solidFill>
+            <a:schemeClr val="bg2"/>
+          </a:solidFill>
+          <a:ln/>
+        </p:spPr>
+        <p:txBody>
+          <a:bodyPr/>
+          <a:p/>
+        </p:txBody>
+      </p:sp>
+      <p:sp>
+        <p:nvSpPr>
+          <p:cNvPr id="37" name="Demo step 4 text"/>
+          <p:cNvSpPr txBox="1"/>
+          <p:nvPr/>
+        </p:nvSpPr>
+        <p:spPr>
+          <a:xfrm>
+            <a:off x="7726680" y="3337560"/>
+            <a:ext cx="3794760" cy="566928"/>
+          </a:xfrm>
+          <a:prstGeom prst="rect">
+            <a:avLst/>
+          </a:prstGeom>
+          <a:noFill/>
+          <a:ln/>
+        </p:spPr>
+        <p:txBody>
+          <a:bodyPr wrap="square" lIns="0" tIns="0" rIns="0" bIns="0" rtlCol="0" anchor="ctr"/>
+          <a:lstStyle/>
+          <a:p>
+            <a:pPr indent="0" marL="0">
+              <a:buNone/>
+            </a:pPr>
+            <a:r>
+              <a:rPr lang="en-US" sz="1300" b="1" dirty="0">
+                <a:solidFill>
+                  <a:schemeClr val="accent1"/>
+                </a:solidFill>
+                <a:latin typeface="Courier New" pitchFamily="34" charset="0"/>
+                <a:ea typeface="Courier New" pitchFamily="34" charset="-122"/>
+                <a:cs typeface="Courier New" pitchFamily="34" charset="-120"/>
+              </a:rPr>
+              <a:t>4  Edit "1700.00" -&gt; "1800.00"</a:t>
+            </a:r>
+            <a:endParaRPr lang="en-US" sz="1300" dirty="0"/>
+          </a:p>
+          <a:p>
+            <a:pPr indent="0" marL="0">
+              <a:buNone/>
+            </a:pPr>
+            <a:r>
+              <a:rPr lang="en-US" sz="1300" dirty="0">
+                <a:solidFill>
+                  <a:schemeClr val="tx1"/>
+                </a:solidFill>
+              </a:rPr>
+              <a:t>In run.py TC13: see a test FAIL</a:t>
+            </a:r>
+            <a:endParaRPr lang="en-US" sz="1300" dirty="0"/>
+          </a:p>
+        </p:txBody>
+      </p:sp>
+      <p:sp>
+        <p:nvSpPr>
+          <p:cNvPr id="38" name="Demo step 5 box"/>
+          <p:cNvSpPr/>
+          <p:nvPr/>
+        </p:nvSpPr>
+        <p:spPr>
+          <a:xfrm>
+            <a:off x="7589520" y="4023360"/>
+            <a:ext cx="4023360" cy="566928"/>
+          </a:xfrm>
+          <a:prstGeom prst="roundRect">
+            <a:avLst>
+              <a:gd name="adj" fmla="val 12903"/>
+            </a:avLst>
+          </a:prstGeom>
+          <a:solidFill>
+            <a:schemeClr val="bg2"/>
+          </a:solidFill>
+          <a:ln/>
+        </p:spPr>
+        <p:txBody>
+          <a:bodyPr/>
+          <a:p/>
+        </p:txBody>
+      </p:sp>
+      <p:sp>
+        <p:nvSpPr>
+          <p:cNvPr id="39" name="Demo step 5 text"/>
+          <p:cNvSpPr txBox="1"/>
+          <p:nvPr/>
+        </p:nvSpPr>
+        <p:spPr>
+          <a:xfrm>
+            <a:off x="7726680" y="4023360"/>
+            <a:ext cx="3794760" cy="566928"/>
+          </a:xfrm>
+          <a:prstGeom prst="rect">
+            <a:avLst/>
+          </a:prstGeom>
+          <a:noFill/>
+          <a:ln/>
+        </p:spPr>
+        <p:txBody>
+          <a:bodyPr wrap="square" lIns="0" tIns="0" rIns="0" bIns="0" rtlCol="0" anchor="ctr"/>
+          <a:lstStyle/>
+          <a:p>
+            <a:pPr indent="0" marL="0">
+              <a:buNone/>
+            </a:pPr>
+            <a:r>
+              <a:rPr lang="en-US" sz="1300" b="1" dirty="0">
+                <a:solidFill>
+                  <a:schemeClr val="accent1"/>
+                </a:solidFill>
+                <a:latin typeface="Courier New" pitchFamily="34" charset="0"/>
+                <a:ea typeface="Courier New" pitchFamily="34" charset="-122"/>
+                <a:cs typeface="Courier New" pitchFamily="34" charset="-120"/>
+              </a:rPr>
+              <a:t>5  python report.py</a:t>
+            </a:r>
+            <a:endParaRPr lang="en-US" sz="1300" dirty="0"/>
+          </a:p>
+          <a:p>
+            <a:pPr indent="0" marL="0">
+              <a:buNone/>
+            </a:pPr>
+            <a:r>
+              <a:rPr lang="en-US" sz="1300" dirty="0">
+                <a:solidFill>
+                  <a:schemeClr val="tx1"/>
+                </a:solidFill>
+              </a:rPr>
+              <a:t>All 98 tests and the HTML test report</a:t>
+            </a:r>
+            <a:endParaRPr lang="en-US" sz="1300" dirty="0"/>
+          </a:p>
+        </p:txBody>
+      </p:sp>
+      <p:sp>
+        <p:nvSpPr>
+          <p:cNvPr id="40" name="Report caption"/>
+          <p:cNvSpPr txBox="1"/>
+          <p:nvPr/>
+        </p:nvSpPr>
+        <p:spPr>
+          <a:xfrm>
+            <a:off x="7589520" y="4754880"/>
+            <a:ext cx="4023360" cy="274320"/>
+          </a:xfrm>
+          <a:prstGeom prst="rect">
+            <a:avLst/>
+          </a:prstGeom>
+          <a:noFill/>
+          <a:ln/>
+        </p:spPr>
+        <p:txBody>
+          <a:bodyPr wrap="square" lIns="0" tIns="0" rIns="0" bIns="0" rtlCol="0" anchor="ctr"/>
+          <a:lstStyle/>
+          <a:p>
+            <a:pPr indent="0" marL="0">
+              <a:buNone/>
+            </a:pPr>
+            <a:r>
+              <a:rPr lang="en-US" sz="1100" i="1" dirty="0">
+                <a:solidFill>
+                  <a:schemeClr val="accent6"/>
+                </a:solidFill>
+              </a:rPr>
+              <a:t>Tip: python run.py TC03 runs only one test case</a:t>
+            </a:r>
+            <a:endParaRPr lang="en-US" sz="1100" dirty="0"/>
+          </a:p>
+        </p:txBody>
+      </p:sp>
+    </p:spTree>
+  </p:cSld>
+  <p:clrMapOvr>
+    <a:masterClrMapping/>
+  </p:clrMapOvr>
+</p:sld>
+</file>
+
+<file path=ppt/slides/slide9.xml><?xml version="1.0" encoding="utf-8"?>
 <p:sld xmlns:a="http://schemas.openxmlformats.org/drawingml/2006/main" xmlns:r="http://schemas.openxmlformats.org/officeDocument/2006/relationships" xmlns:p="http://schemas.openxmlformats.org/presentationml/2006/main">
   <p:cSld name="Slide 8">
     <p:spTree>
@@ -11877,7 +13295,7 @@
                   <a:schemeClr val="accent1"/>
                 </a:solidFill>
               </a:rPr>
-              <a:t>~25 s</a:t>
+              <a:t>~40 s</a:t>
             </a:r>
             <a:endParaRPr lang="en-US" sz="4000" dirty="0"/>
           </a:p>
@@ -12041,7 +13459,7 @@
           <p:nvPr/>
         </p:nvPicPr>
         <p:blipFill>
-          <a:blip r:embed="rId2"/>
+          <a:blip r:embed="rId6"/>
           <a:stretch>
             <a:fillRect/>
           </a:stretch>
@@ -12269,739 +13687,6 @@
               <a:t>8</a:t>
             </a:fld>
             <a:endParaRPr lang="en-US"/>
-          </a:p>
-        </p:txBody>
-      </p:sp>
-    </p:spTree>
-  </p:cSld>
-  <p:clrMapOvr>
-    <a:masterClrMapping/>
-  </p:clrMapOvr>
-</p:sld>
-</file>
-
-<file path=ppt/slides/slide9.xml><?xml version="1.0" encoding="utf-8"?>
-<p:sld xmlns:a="http://schemas.openxmlformats.org/drawingml/2006/main" xmlns:r="http://schemas.openxmlformats.org/officeDocument/2006/relationships" xmlns:p="http://schemas.openxmlformats.org/presentationml/2006/main">
-  <p:cSld name="Slide 9">
-    <p:spTree>
-      <p:nvGrpSpPr>
-        <p:cNvPr id="1" name=""/>
-        <p:cNvGrpSpPr/>
-        <p:nvPr/>
-      </p:nvGrpSpPr>
-      <p:grpSpPr>
-        <a:xfrm>
-          <a:off x="0" y="0"/>
-          <a:ext cx="0" cy="0"/>
-          <a:chOff x="0" y="0"/>
-          <a:chExt cx="0" cy="0"/>
-        </a:xfrm>
-      </p:grpSpPr>
-      <p:sp>
-        <p:nvSpPr>
-          <p:cNvPr id="2" name="Text 0"/>
-          <p:cNvSpPr/>
-          <p:nvPr>
-            <p:ph idx="100" type="title" hasCustomPrompt="1"/>
-          </p:nvPr>
-        </p:nvSpPr>
-        <p:spPr>
-          <a:xfrm>
-            <a:off x="548640" y="320040"/>
-            <a:ext cx="11064240" cy="777240"/>
-          </a:xfrm>
-          <a:prstGeom prst="rect">
-            <a:avLst/>
-          </a:prstGeom>
-          <a:noFill/>
-          <a:ln/>
-        </p:spPr>
-        <p:txBody>
-          <a:bodyPr wrap="square" lIns="0" tIns="0" rIns="0" bIns="0" rtlCol="0" anchor="ctr"/>
-          <a:lstStyle/>
-          <a:p>
-            <a:pPr indent="0" marL="0">
-              <a:buNone/>
-            </a:pPr>
-            <a:r>
-              <a:rPr lang="en-US" sz="3400" b="1" dirty="0">
-                <a:solidFill>
-                  <a:schemeClr val="bg1"/>
-                </a:solidFill>
-              </a:rPr>
-              <a:t>Conclusion and Future Scope</a:t>
-            </a:r>
-            <a:endParaRPr lang="en-US" sz="3400" dirty="0"/>
-          </a:p>
-        </p:txBody>
-      </p:sp>
-      <p:sp>
-        <p:nvSpPr>
-          <p:cNvPr id="3" name="Conclusion points"/>
-          <p:cNvSpPr txBox="1"/>
-          <p:nvPr/>
-        </p:nvSpPr>
-        <p:spPr>
-          <a:xfrm>
-            <a:off x="548640" y="1325880"/>
-            <a:ext cx="5120640" cy="3291840"/>
-          </a:xfrm>
-          <a:prstGeom prst="rect">
-            <a:avLst/>
-          </a:prstGeom>
-          <a:noFill/>
-          <a:ln/>
-        </p:spPr>
-        <p:txBody>
-          <a:bodyPr wrap="square" lIns="0" tIns="0" rIns="0" bIns="0" rtlCol="0" anchor="t"/>
-          <a:lstStyle/>
-          <a:p>
-            <a:pPr marL="342900" indent="-342900">
-              <a:spcAft>
-                <a:spcPts val="1400"/>
-              </a:spcAft>
-              <a:buSzPct val="100000"/>
-              <a:buChar char="•"/>
-            </a:pPr>
-            <a:r>
-              <a:rPr lang="en-US" sz="1600" dirty="0">
-                <a:solidFill>
-                  <a:schemeClr val="bg1"/>
-                </a:solidFill>
-              </a:rPr>
-              <a:t>We built a working HMS with 6 modules: login, patients, doctors, appointments, medical records and billing</a:t>
-            </a:r>
-            <a:endParaRPr lang="en-US" sz="1600" dirty="0"/>
-          </a:p>
-          <a:p>
-            <a:pPr marL="342900" indent="-342900">
-              <a:spcAft>
-                <a:spcPts val="1400"/>
-              </a:spcAft>
-              <a:buSzPct val="100000"/>
-              <a:buChar char="•"/>
-            </a:pPr>
-            <a:r>
-              <a:rPr lang="en-US" sz="1600" dirty="0">
-                <a:solidFill>
-                  <a:schemeClr val="bg1"/>
-                </a:solidFill>
-              </a:rPr>
-              <a:t>Selenium WebDriver automated every test case from our document, for valid and invalid inputs</a:t>
-            </a:r>
-            <a:endParaRPr lang="en-US" sz="1600" dirty="0"/>
-          </a:p>
-          <a:p>
-            <a:pPr marL="342900" indent="-342900">
-              <a:spcAft>
-                <a:spcPts val="1400"/>
-              </a:spcAft>
-              <a:buSzPct val="100000"/>
-              <a:buChar char="•"/>
-            </a:pPr>
-            <a:r>
-              <a:rPr lang="en-US" sz="1600" dirty="0">
-                <a:solidFill>
-                  <a:schemeClr val="bg1"/>
-                </a:solidFill>
-              </a:rPr>
-              <a:t>Automated tests run again in seconds after every change, giving fast and consistent regression testing</a:t>
-            </a:r>
-            <a:endParaRPr lang="en-US" sz="1600" dirty="0"/>
-          </a:p>
-        </p:txBody>
-      </p:sp>
-      <p:sp>
-        <p:nvSpPr>
-          <p:cNvPr id="4" name="Future scope heading"/>
-          <p:cNvSpPr txBox="1"/>
-          <p:nvPr/>
-        </p:nvSpPr>
-        <p:spPr>
-          <a:xfrm>
-            <a:off x="6217920" y="1280160"/>
-            <a:ext cx="5394960" cy="411480"/>
-          </a:xfrm>
-          <a:prstGeom prst="rect">
-            <a:avLst/>
-          </a:prstGeom>
-          <a:noFill/>
-          <a:ln/>
-        </p:spPr>
-        <p:txBody>
-          <a:bodyPr wrap="square" lIns="0" tIns="0" rIns="0" bIns="0" rtlCol="0" anchor="ctr"/>
-          <a:lstStyle/>
-          <a:p>
-            <a:pPr indent="0" marL="0">
-              <a:buNone/>
-            </a:pPr>
-            <a:r>
-              <a:rPr lang="en-US" sz="2000" b="1" dirty="0">
-                <a:solidFill>
-                  <a:schemeClr val="accent2"/>
-                </a:solidFill>
-                <a:latin typeface="Cambria" pitchFamily="34" charset="0"/>
-                <a:ea typeface="Cambria" pitchFamily="34" charset="-122"/>
-                <a:cs typeface="Cambria" pitchFamily="34" charset="-120"/>
-              </a:rPr>
-              <a:t>Future Scope</a:t>
-            </a:r>
-            <a:endParaRPr lang="en-US" sz="2000" dirty="0"/>
-          </a:p>
-        </p:txBody>
-      </p:sp>
-      <p:sp>
-        <p:nvSpPr>
-          <p:cNvPr id="5" name="AI-based test case generation icon circle"/>
-          <p:cNvSpPr/>
-          <p:nvPr/>
-        </p:nvSpPr>
-        <p:spPr>
-          <a:xfrm>
-            <a:off x="6217920" y="1874520"/>
-            <a:ext cx="548640" cy="548640"/>
-          </a:xfrm>
-          <a:prstGeom prst="ellipse">
-            <a:avLst/>
-          </a:prstGeom>
-          <a:solidFill>
-            <a:schemeClr val="accent1"/>
-          </a:solidFill>
-          <a:ln/>
-        </p:spPr>
-      </p:sp>
-      <p:pic>
-        <p:nvPicPr>
-          <p:cNvPr id="6" name="AI-based test case generation icon" descr="preencoded.png">    </p:cNvPr>
-          <p:cNvPicPr>
-            <a:picLocks noChangeAspect="1"/>
-          </p:cNvPicPr>
-          <p:nvPr/>
-        </p:nvPicPr>
-        <p:blipFill>
-          <a:blip r:embed="rId1"/>
-          <a:stretch>
-            <a:fillRect/>
-          </a:stretch>
-        </p:blipFill>
-        <p:spPr>
-          <a:xfrm>
-            <a:off x="6355080" y="2011680"/>
-            <a:ext cx="274320" cy="274320"/>
-          </a:xfrm>
-          <a:prstGeom prst="rect">
-            <a:avLst/>
-          </a:prstGeom>
-        </p:spPr>
-      </p:pic>
-      <p:sp>
-        <p:nvSpPr>
-          <p:cNvPr id="7" name="AI-based test case generation"/>
-          <p:cNvSpPr txBox="1"/>
-          <p:nvPr/>
-        </p:nvSpPr>
-        <p:spPr>
-          <a:xfrm>
-            <a:off x="6903720" y="1874520"/>
-            <a:ext cx="1965960" cy="548640"/>
-          </a:xfrm>
-          <a:prstGeom prst="rect">
-            <a:avLst/>
-          </a:prstGeom>
-          <a:noFill/>
-          <a:ln/>
-        </p:spPr>
-        <p:txBody>
-          <a:bodyPr wrap="square" lIns="0" tIns="0" rIns="0" bIns="0" rtlCol="0" anchor="ctr"/>
-          <a:lstStyle/>
-          <a:p>
-            <a:pPr indent="0" marL="0">
-              <a:buNone/>
-            </a:pPr>
-            <a:r>
-              <a:rPr lang="en-US" sz="1300" dirty="0">
-                <a:solidFill>
-                  <a:schemeClr val="bg1"/>
-                </a:solidFill>
-              </a:rPr>
-              <a:t>AI-based test case generation</a:t>
-            </a:r>
-            <a:endParaRPr lang="en-US" sz="1300" dirty="0"/>
-          </a:p>
-        </p:txBody>
-      </p:sp>
-      <p:sp>
-        <p:nvSpPr>
-          <p:cNvPr id="8" name="Cross-browser testing with Selenium Grid icon circle"/>
-          <p:cNvSpPr/>
-          <p:nvPr/>
-        </p:nvSpPr>
-        <p:spPr>
-          <a:xfrm>
-            <a:off x="8961120" y="1874520"/>
-            <a:ext cx="548640" cy="548640"/>
-          </a:xfrm>
-          <a:prstGeom prst="ellipse">
-            <a:avLst/>
-          </a:prstGeom>
-          <a:solidFill>
-            <a:schemeClr val="accent1"/>
-          </a:solidFill>
-          <a:ln/>
-        </p:spPr>
-      </p:sp>
-      <p:pic>
-        <p:nvPicPr>
-          <p:cNvPr id="9" name="Cross-browser testing with Selenium Grid icon" descr="preencoded.png">    </p:cNvPr>
-          <p:cNvPicPr>
-            <a:picLocks noChangeAspect="1"/>
-          </p:cNvPicPr>
-          <p:nvPr/>
-        </p:nvPicPr>
-        <p:blipFill>
-          <a:blip r:embed="rId2"/>
-          <a:stretch>
-            <a:fillRect/>
-          </a:stretch>
-        </p:blipFill>
-        <p:spPr>
-          <a:xfrm>
-            <a:off x="9098280" y="2011680"/>
-            <a:ext cx="274320" cy="274320"/>
-          </a:xfrm>
-          <a:prstGeom prst="rect">
-            <a:avLst/>
-          </a:prstGeom>
-        </p:spPr>
-      </p:pic>
-      <p:sp>
-        <p:nvSpPr>
-          <p:cNvPr id="10" name="Cross-browser testing with Selenium Grid"/>
-          <p:cNvSpPr txBox="1"/>
-          <p:nvPr/>
-        </p:nvSpPr>
-        <p:spPr>
-          <a:xfrm>
-            <a:off x="9646920" y="1874520"/>
-            <a:ext cx="1965960" cy="548640"/>
-          </a:xfrm>
-          <a:prstGeom prst="rect">
-            <a:avLst/>
-          </a:prstGeom>
-          <a:noFill/>
-          <a:ln/>
-        </p:spPr>
-        <p:txBody>
-          <a:bodyPr wrap="square" lIns="0" tIns="0" rIns="0" bIns="0" rtlCol="0" anchor="ctr"/>
-          <a:lstStyle/>
-          <a:p>
-            <a:pPr indent="0" marL="0">
-              <a:buNone/>
-            </a:pPr>
-            <a:r>
-              <a:rPr lang="en-US" sz="1300" dirty="0">
-                <a:solidFill>
-                  <a:schemeClr val="bg1"/>
-                </a:solidFill>
-              </a:rPr>
-              <a:t>Cross-browser testing with Selenium Grid</a:t>
-            </a:r>
-            <a:endParaRPr lang="en-US" sz="1300" dirty="0"/>
-          </a:p>
-        </p:txBody>
-      </p:sp>
-      <p:sp>
-        <p:nvSpPr>
-          <p:cNvPr id="11" name="CI pipeline: tests run on every code change icon circle"/>
-          <p:cNvSpPr/>
-          <p:nvPr/>
-        </p:nvSpPr>
-        <p:spPr>
-          <a:xfrm>
-            <a:off x="6217920" y="2788920"/>
-            <a:ext cx="548640" cy="548640"/>
-          </a:xfrm>
-          <a:prstGeom prst="ellipse">
-            <a:avLst/>
-          </a:prstGeom>
-          <a:solidFill>
-            <a:schemeClr val="accent1"/>
-          </a:solidFill>
-          <a:ln/>
-        </p:spPr>
-      </p:sp>
-      <p:pic>
-        <p:nvPicPr>
-          <p:cNvPr id="12" name="CI pipeline: tests run on every code change icon" descr="preencoded.png">    </p:cNvPr>
-          <p:cNvPicPr>
-            <a:picLocks noChangeAspect="1"/>
-          </p:cNvPicPr>
-          <p:nvPr/>
-        </p:nvPicPr>
-        <p:blipFill>
-          <a:blip r:embed="rId3"/>
-          <a:stretch>
-            <a:fillRect/>
-          </a:stretch>
-        </p:blipFill>
-        <p:spPr>
-          <a:xfrm>
-            <a:off x="6355080" y="2926080"/>
-            <a:ext cx="274320" cy="274320"/>
-          </a:xfrm>
-          <a:prstGeom prst="rect">
-            <a:avLst/>
-          </a:prstGeom>
-        </p:spPr>
-      </p:pic>
-      <p:sp>
-        <p:nvSpPr>
-          <p:cNvPr id="13" name="CI pipeline: tests run on every code change"/>
-          <p:cNvSpPr txBox="1"/>
-          <p:nvPr/>
-        </p:nvSpPr>
-        <p:spPr>
-          <a:xfrm>
-            <a:off x="6903720" y="2788920"/>
-            <a:ext cx="1965960" cy="548640"/>
-          </a:xfrm>
-          <a:prstGeom prst="rect">
-            <a:avLst/>
-          </a:prstGeom>
-          <a:noFill/>
-          <a:ln/>
-        </p:spPr>
-        <p:txBody>
-          <a:bodyPr wrap="square" lIns="0" tIns="0" rIns="0" bIns="0" rtlCol="0" anchor="ctr"/>
-          <a:lstStyle/>
-          <a:p>
-            <a:pPr indent="0" marL="0">
-              <a:buNone/>
-            </a:pPr>
-            <a:r>
-              <a:rPr lang="en-US" sz="1300" dirty="0">
-                <a:solidFill>
-                  <a:schemeClr val="bg1"/>
-                </a:solidFill>
-              </a:rPr>
-              <a:t>CI pipeline: tests run on every code change</a:t>
-            </a:r>
-            <a:endParaRPr lang="en-US" sz="1300" dirty="0"/>
-          </a:p>
-        </p:txBody>
-      </p:sp>
-      <p:sp>
-        <p:nvSpPr>
-          <p:cNvPr id="14" name="Performance and load testing icon circle"/>
-          <p:cNvSpPr/>
-          <p:nvPr/>
-        </p:nvSpPr>
-        <p:spPr>
-          <a:xfrm>
-            <a:off x="8961120" y="2788920"/>
-            <a:ext cx="548640" cy="548640"/>
-          </a:xfrm>
-          <a:prstGeom prst="ellipse">
-            <a:avLst/>
-          </a:prstGeom>
-          <a:solidFill>
-            <a:schemeClr val="accent1"/>
-          </a:solidFill>
-          <a:ln/>
-        </p:spPr>
-      </p:sp>
-      <p:pic>
-        <p:nvPicPr>
-          <p:cNvPr id="15" name="Performance and load testing icon" descr="preencoded.png">    </p:cNvPr>
-          <p:cNvPicPr>
-            <a:picLocks noChangeAspect="1"/>
-          </p:cNvPicPr>
-          <p:nvPr/>
-        </p:nvPicPr>
-        <p:blipFill>
-          <a:blip r:embed="rId4"/>
-          <a:stretch>
-            <a:fillRect/>
-          </a:stretch>
-        </p:blipFill>
-        <p:spPr>
-          <a:xfrm>
-            <a:off x="9098280" y="2926080"/>
-            <a:ext cx="274320" cy="274320"/>
-          </a:xfrm>
-          <a:prstGeom prst="rect">
-            <a:avLst/>
-          </a:prstGeom>
-        </p:spPr>
-      </p:pic>
-      <p:sp>
-        <p:nvSpPr>
-          <p:cNvPr id="16" name="Performance and load testing"/>
-          <p:cNvSpPr txBox="1"/>
-          <p:nvPr/>
-        </p:nvSpPr>
-        <p:spPr>
-          <a:xfrm>
-            <a:off x="9646920" y="2788920"/>
-            <a:ext cx="1965960" cy="548640"/>
-          </a:xfrm>
-          <a:prstGeom prst="rect">
-            <a:avLst/>
-          </a:prstGeom>
-          <a:noFill/>
-          <a:ln/>
-        </p:spPr>
-        <p:txBody>
-          <a:bodyPr wrap="square" lIns="0" tIns="0" rIns="0" bIns="0" rtlCol="0" anchor="ctr"/>
-          <a:lstStyle/>
-          <a:p>
-            <a:pPr indent="0" marL="0">
-              <a:buNone/>
-            </a:pPr>
-            <a:r>
-              <a:rPr lang="en-US" sz="1300" dirty="0">
-                <a:solidFill>
-                  <a:schemeClr val="bg1"/>
-                </a:solidFill>
-              </a:rPr>
-              <a:t>Performance and load testing</a:t>
-            </a:r>
-            <a:endParaRPr lang="en-US" sz="1300" dirty="0"/>
-          </a:p>
-        </p:txBody>
-      </p:sp>
-      <p:sp>
-        <p:nvSpPr>
-          <p:cNvPr id="17" name="Mobile app testing with Appium icon circle"/>
-          <p:cNvSpPr/>
-          <p:nvPr/>
-        </p:nvSpPr>
-        <p:spPr>
-          <a:xfrm>
-            <a:off x="6217920" y="3703320"/>
-            <a:ext cx="548640" cy="548640"/>
-          </a:xfrm>
-          <a:prstGeom prst="ellipse">
-            <a:avLst/>
-          </a:prstGeom>
-          <a:solidFill>
-            <a:schemeClr val="accent1"/>
-          </a:solidFill>
-          <a:ln/>
-        </p:spPr>
-      </p:sp>
-      <p:pic>
-        <p:nvPicPr>
-          <p:cNvPr id="18" name="Mobile app testing with Appium icon" descr="preencoded.png">    </p:cNvPr>
-          <p:cNvPicPr>
-            <a:picLocks noChangeAspect="1"/>
-          </p:cNvPicPr>
-          <p:nvPr/>
-        </p:nvPicPr>
-        <p:blipFill>
-          <a:blip r:embed="rId5"/>
-          <a:stretch>
-            <a:fillRect/>
-          </a:stretch>
-        </p:blipFill>
-        <p:spPr>
-          <a:xfrm>
-            <a:off x="6355080" y="3840480"/>
-            <a:ext cx="274320" cy="274320"/>
-          </a:xfrm>
-          <a:prstGeom prst="rect">
-            <a:avLst/>
-          </a:prstGeom>
-        </p:spPr>
-      </p:pic>
-      <p:sp>
-        <p:nvSpPr>
-          <p:cNvPr id="19" name="Mobile app testing with Appium"/>
-          <p:cNvSpPr txBox="1"/>
-          <p:nvPr/>
-        </p:nvSpPr>
-        <p:spPr>
-          <a:xfrm>
-            <a:off x="6903720" y="3703320"/>
-            <a:ext cx="1965960" cy="548640"/>
-          </a:xfrm>
-          <a:prstGeom prst="rect">
-            <a:avLst/>
-          </a:prstGeom>
-          <a:noFill/>
-          <a:ln/>
-        </p:spPr>
-        <p:txBody>
-          <a:bodyPr wrap="square" lIns="0" tIns="0" rIns="0" bIns="0" rtlCol="0" anchor="ctr"/>
-          <a:lstStyle/>
-          <a:p>
-            <a:pPr indent="0" marL="0">
-              <a:buNone/>
-            </a:pPr>
-            <a:r>
-              <a:rPr lang="en-US" sz="1300" dirty="0">
-                <a:solidFill>
-                  <a:schemeClr val="bg1"/>
-                </a:solidFill>
-              </a:rPr>
-              <a:t>Mobile app testing with Appium</a:t>
-            </a:r>
-            <a:endParaRPr lang="en-US" sz="1300" dirty="0"/>
-          </a:p>
-        </p:txBody>
-      </p:sp>
-      <p:sp>
-        <p:nvSpPr>
-          <p:cNvPr id="20" name="Security testing of login and data icon circle"/>
-          <p:cNvSpPr/>
-          <p:nvPr/>
-        </p:nvSpPr>
-        <p:spPr>
-          <a:xfrm>
-            <a:off x="8961120" y="3703320"/>
-            <a:ext cx="548640" cy="548640"/>
-          </a:xfrm>
-          <a:prstGeom prst="ellipse">
-            <a:avLst/>
-          </a:prstGeom>
-          <a:solidFill>
-            <a:schemeClr val="accent1"/>
-          </a:solidFill>
-          <a:ln/>
-        </p:spPr>
-      </p:sp>
-      <p:pic>
-        <p:nvPicPr>
-          <p:cNvPr id="21" name="Security testing of login and data icon" descr="preencoded.png">    </p:cNvPr>
-          <p:cNvPicPr>
-            <a:picLocks noChangeAspect="1"/>
-          </p:cNvPicPr>
-          <p:nvPr/>
-        </p:nvPicPr>
-        <p:blipFill>
-          <a:blip r:embed="rId6"/>
-          <a:stretch>
-            <a:fillRect/>
-          </a:stretch>
-        </p:blipFill>
-        <p:spPr>
-          <a:xfrm>
-            <a:off x="9098280" y="3840480"/>
-            <a:ext cx="274320" cy="274320"/>
-          </a:xfrm>
-          <a:prstGeom prst="rect">
-            <a:avLst/>
-          </a:prstGeom>
-        </p:spPr>
-      </p:pic>
-      <p:sp>
-        <p:nvSpPr>
-          <p:cNvPr id="22" name="Security testing of login and data"/>
-          <p:cNvSpPr txBox="1"/>
-          <p:nvPr/>
-        </p:nvSpPr>
-        <p:spPr>
-          <a:xfrm>
-            <a:off x="9646920" y="3703320"/>
-            <a:ext cx="1965960" cy="548640"/>
-          </a:xfrm>
-          <a:prstGeom prst="rect">
-            <a:avLst/>
-          </a:prstGeom>
-          <a:noFill/>
-          <a:ln/>
-        </p:spPr>
-        <p:txBody>
-          <a:bodyPr wrap="square" lIns="0" tIns="0" rIns="0" bIns="0" rtlCol="0" anchor="ctr"/>
-          <a:lstStyle/>
-          <a:p>
-            <a:pPr indent="0" marL="0">
-              <a:buNone/>
-            </a:pPr>
-            <a:r>
-              <a:rPr lang="en-US" sz="1300" dirty="0">
-                <a:solidFill>
-                  <a:schemeClr val="bg1"/>
-                </a:solidFill>
-              </a:rPr>
-              <a:t>Security testing of login and data</a:t>
-            </a:r>
-            <a:endParaRPr lang="en-US" sz="1300" dirty="0"/>
-          </a:p>
-        </p:txBody>
-      </p:sp>
-      <p:sp>
-        <p:nvSpPr>
-          <p:cNvPr id="23" name="Thank you box"/>
-          <p:cNvSpPr/>
-          <p:nvPr/>
-        </p:nvSpPr>
-        <p:spPr>
-          <a:xfrm>
-            <a:off x="548640" y="4983480"/>
-            <a:ext cx="11064240" cy="1188720"/>
-          </a:xfrm>
-          <a:prstGeom prst="roundRect">
-            <a:avLst>
-              <a:gd name="adj" fmla="val 7692"/>
-            </a:avLst>
-          </a:prstGeom>
-          <a:solidFill>
-            <a:schemeClr val="accent1"/>
-          </a:solidFill>
-          <a:ln/>
-        </p:spPr>
-      </p:sp>
-      <p:sp>
-        <p:nvSpPr>
-          <p:cNvPr id="24" name="Thank you text"/>
-          <p:cNvSpPr txBox="1"/>
-          <p:nvPr/>
-        </p:nvSpPr>
-        <p:spPr>
-          <a:xfrm>
-            <a:off x="548640" y="4983480"/>
-            <a:ext cx="11064240" cy="1188720"/>
-          </a:xfrm>
-          <a:prstGeom prst="rect">
-            <a:avLst/>
-          </a:prstGeom>
-          <a:noFill/>
-          <a:ln/>
-        </p:spPr>
-        <p:txBody>
-          <a:bodyPr wrap="square" lIns="0" tIns="0" rIns="0" bIns="0" rtlCol="0" anchor="ctr"/>
-          <a:lstStyle/>
-          <a:p>
-            <a:pPr algn="ctr" indent="0" marL="0">
-              <a:buNone/>
-            </a:pPr>
-            <a:r>
-              <a:rPr lang="en-US" sz="3000" b="1" dirty="0">
-                <a:solidFill>
-                  <a:schemeClr val="bg1"/>
-                </a:solidFill>
-                <a:latin typeface="Cambria" pitchFamily="34" charset="0"/>
-                <a:ea typeface="Cambria" pitchFamily="34" charset="-122"/>
-                <a:cs typeface="Cambria" pitchFamily="34" charset="-120"/>
-              </a:rPr>
-              <a:t>Thank You</a:t>
-            </a:r>
-            <a:endParaRPr lang="en-US" sz="3000" dirty="0"/>
-          </a:p>
-          <a:p>
-            <a:pPr algn="ctr" indent="0" marL="0">
-              <a:buNone/>
-            </a:pPr>
-            <a:r>
-              <a:rPr lang="en-US" sz="1500" dirty="0">
-                <a:solidFill>
-                  <a:schemeClr val="bg1"/>
-                </a:solidFill>
-              </a:rPr>
-              <a:t>Questions?  |  Arun C (23MIS0445)  |  Sai Chandan K S (23MIS0115)</a:t>
-            </a:r>
-            <a:endParaRPr lang="en-US" sz="3000" dirty="0"/>
           </a:p>
         </p:txBody>
       </p:sp>

</xml_diff>

<commit_message>
Add 24 negative, boundary/edge and security Selenium test cases
- TC14-TC37 in tests/ui/test_selenium_hms.py and in the run.py live demo:
  17 negative, 7 boundary/edge, 3 security (37 Selenium tests in total)
- Negative tests check both the error message and that nothing was saved;
  run.py checks the rejected item by name so old data in the real
  database cannot cause false failures
- run.py: Type column, --type filter and TC ranges (python run.py TC01-TC13)
- Mutation testing: 6 planted bugs, each caught by its test
- README, DEMO_GUIDE (new Step 6b) and report.py updated: 122 tests
- Presentation: new slide 7 for these tests, updated counts, demo step and
  report screenshot (11 slides)

Co-Authored-By: Claude Opus 5.5 <noreply@anthropic.com>
Claude-Session: https://claude.ai/code/session_01KhLoTHysDZctQ2NgKJXDRu
</commit_message>
<xml_diff>
--- a/presentation/Hospital_Management_System_Selenium_Testing.pptx
+++ b/presentation/Hospital_Management_System_Selenium_Testing.pptx
@@ -11,6 +11,7 @@
     <p:sldId id="259" r:id="rId5"/>
     <p:sldId id="260" r:id="rId6"/>
     <p:sldId id="261" r:id="rId7"/>
+    <p:sldId id="266" r:id="rId17"/>
     <p:sldId id="262" r:id="rId8"/>
     <p:sldId id="265" r:id="rId16"/>
     <p:sldId id="263" r:id="rId9"/>
@@ -636,7 +637,77 @@
           <a:lstStyle/>
           <a:p>
             <a:r>
-              <a:t>This is our live demo. First we open the Hospital Management System that we built (python app.py) and show the modules by hand. Then we run our first Selenium test, login.py, the code from the previous slide: Chrome opens by itself, types admin and admin123 and logs in. Next we run run.py: Selenium tests all 13 test cases one by one. The orange box shows which element Selenium found by its id, the caption at the bottom says what it is doing, and the terminal prints the real Selenium command behind every step and PASS for every check. To show that the tests really check something, we change the expected bill total from 1700.00 to 1800.00 and run TC13 again: the test FAILS and a screenshot is saved. Finally python report.py runs all 98 tests in about 40 seconds and opens the HTML test report.</a:t>
+              <a:t>This is our live demo. First we open the Hospital Management System that we built (python app.py) and show the modules by hand. Then we run our first Selenium test, login.py, the code from the previous slide: Chrome opens by itself, types admin and admin123 and logs in. Next we run run.py: Selenium tests the 13 main test cases one by one. The orange box shows which element Selenium found by its id, the caption at the bottom says what it is doing, and the terminal prints the real Selenium command behind every step and PASS for every check. Then we run four of our attack and limit tests: SQL injection, age 121, ages 0 and 120, and a script typed into a form. Each must show an error, or be shown as plain text, and nothing harmful may be saved. To show that the tests really check something, we change the expected bill total from 1700.00 to 1800.00 and run TC13 again: the test FAILS and a screenshot is saved. Finally python report.py runs all 122 tests in about 90 seconds and opens the HTML test report.</a:t>
+            </a:r>
+          </a:p>
+        </p:txBody>
+      </p:sp>
+      <p:sp>
+        <p:nvSpPr>
+          <p:cNvPr id="4" name="Slide Number Placeholder 3"/>
+          <p:cNvSpPr>
+            <a:spLocks noGrp="1"/>
+          </p:cNvSpPr>
+          <p:nvPr>
+            <p:ph type="sldNum" idx="5" sz="quarter"/>
+          </p:nvPr>
+        </p:nvSpPr>
+        <p:spPr/>
+      </p:sp>
+    </p:spTree>
+  </p:cSld>
+  <p:clrMapOvr>
+    <a:masterClrMapping/>
+  </p:clrMapOvr>
+</p:notes>
+</file>
+
+<file path=ppt/notesSlides/notesSlide11.xml><?xml version="1.0" encoding="utf-8"?>
+<p:notes xmlns:a="http://schemas.openxmlformats.org/drawingml/2006/main" xmlns:p="http://schemas.openxmlformats.org/presentationml/2006/main" xmlns:r="http://schemas.openxmlformats.org/officeDocument/2006/relationships">
+  <p:cSld>
+    <p:spTree>
+      <p:nvGrpSpPr>
+        <p:cNvPr id="1" name=""/>
+        <p:cNvGrpSpPr/>
+        <p:nvPr/>
+      </p:nvGrpSpPr>
+      <p:grpSpPr>
+        <a:xfrm>
+          <a:off x="0" y="0"/>
+          <a:ext cx="0" cy="0"/>
+          <a:chOff x="0" y="0"/>
+          <a:chExt cx="0" cy="0"/>
+        </a:xfrm>
+      </p:grpSpPr>
+      <p:sp>
+        <p:nvSpPr>
+          <p:cNvPr id="2" name="Slide Image Placeholder 1"/>
+          <p:cNvSpPr>
+            <a:spLocks noGrp="1"/>
+          </p:cNvSpPr>
+          <p:nvPr>
+            <p:ph type="sldImg" idx="2"/>
+          </p:nvPr>
+        </p:nvSpPr>
+        <p:spPr/>
+      </p:sp>
+      <p:sp>
+        <p:nvSpPr>
+          <p:cNvPr id="3" name="Notes Placeholder 2"/>
+          <p:cNvSpPr>
+            <a:spLocks noGrp="1"/>
+          </p:cNvSpPr>
+          <p:nvPr>
+            <p:ph type="body" idx="3" sz="quarter"/>
+          </p:nvPr>
+        </p:nvSpPr>
+        <p:spPr/>
+        <p:txBody>
+          <a:bodyPr/>
+          <a:lstStyle/>
+          <a:p>
+            <a:r>
+              <a:t>Testing only valid input is not enough: real users make mistakes and attackers try to break in. So besides our 10 positive test cases we wrote 17 negative, 7 boundary or edge, and 3 security test cases, 37 in total. Negative tests give wrong or missing input, like a 5-digit phone number or a date in the past. Boundary value analysis tests exactly at the limits and just past them: age 0 and 120 must be accepted, 121 must be rejected. Security tests try a SQL injection attack in the login, type a script into a form, and open pages without logging in. For every negative test we check two things: the error message is shown, and nothing was saved. To prove the tests really catch bugs we used mutation testing: we put 6 bugs into a copy of the app on purpose, and every one made its test fail.</a:t>
             </a:r>
           </a:p>
         </p:txBody>
@@ -1059,7 +1130,7 @@
           <a:p>
             <a:r>
               <a:rPr lang="en-US" dirty="0"/>
-              <a:t>These are the nine test cases from our project document, TC01 to TC09. Each covers a valid or an invalid input. For example TC02 enters a wrong password and checks that the error message appears; TC04 submits an empty form and checks that a validation message appears. All nine passed. We also wrote four extra tests for the other modules: doctor availability, double booking prevention, medical records, and checking that the bill total is calculated correctly.</a:t>
+              <a:t>These are the nine test cases from our project document, TC01 to TC09. Each covers a valid or an invalid input. For example TC02 enters a wrong password and checks that the error message appears; TC04 submits an empty form and checks that a validation message appears. All nine passed. We also wrote four extra tests for the other modules: doctor availability, double booking prevention, medical records, and checking that the bill total is calculated correctly. On the next slide are 24 more test cases that try to break the system.</a:t>
             </a:r>
             <a:endParaRPr lang="en-US" dirty="0"/>
           </a:p>
@@ -1146,7 +1217,7 @@
           <a:lstStyle/>
           <a:p>
             <a:r>
-              <a:t>This is the same login example as in our document, written in Python. It is in our project as login.py. webdriver.Chrome opens Chrome, get opens our HMS, find_element finds the username box by its id, send_keys types into it, click presses the login button. The assert line is the actual test: if the dashboard did not open, the test fails. quit closes the browser. Our full test file uses exactly these commands for all 13 test cases, run by PyTest. Now we will show this live: the next slide is our demo plan.</a:t>
+              <a:t>This is the same login example as in our document, written in Python. It is in our project as login.py. webdriver.Chrome opens Chrome, get opens our HMS, find_element finds the username box by its id, send_keys types into it, click presses the login button. The assert line is the actual test: if the dashboard did not open, the test fails. quit closes the browser. Our full test file uses exactly these commands for all 37 test cases, run by PyTest. Now we will show this live: the next slide is our demo plan.</a:t>
             </a:r>
           </a:p>
         </p:txBody>
@@ -1232,7 +1303,7 @@
           <a:lstStyle/>
           <a:p>
             <a:r>
-              <a:t>All 13 Selenium tests passed, and we also have 85 PyTest tests that check the validation rules and database directly, without a browser. All 98 run in about 40 seconds and produce this HTML report. Our testing also FOUND real defects. Using exploratory testing we tried to break the app on purpose: typing 'nan' as a doctor fee crashed the server, infinity was accepted as a bill amount, the same patient could be booked with two doctors at the same time, and deleting a record that does not exist still showed success. We also found that our Selenium tests failed randomly about one run in three, because Selenium checked the page while Chrome was still loading it - a common automation problem called synchronization. We fixed all 9 defects and added a regression test for each one, so they can never come back. The full list is in our README.</a:t>
+              <a:t>All 37 Selenium tests passed, and we also have 85 PyTest tests that check the validation rules and database directly, without a browser. All 122 run in about 90 seconds and produce this HTML report. Our testing also FOUND real defects. Using exploratory testing we tried to break the app on purpose: typing 'nan' as a doctor fee crashed the server, infinity was accepted as a bill amount, the same patient could be booked with two doctors at the same time, and deleting a record that does not exist still showed success. We also found that our Selenium tests failed randomly about one run in three, because Selenium checked the page while Chrome was still loading it - a common automation problem called synchronization. We fixed all 9 defects and added a regression test for each one, so they can never come back. The full list is in our README.</a:t>
             </a:r>
           </a:p>
         </p:txBody>
@@ -2504,7 +2575,7 @@
                   <a:schemeClr val="bg1"/>
                 </a:solidFill>
               </a:rPr>
-              <a:t>Selenium WebDriver automated every test case from our document, for valid and invalid inputs</a:t>
+              <a:t>37 Selenium test cases: every case from our document, plus negative, boundary and security tests</a:t>
             </a:r>
             <a:endParaRPr lang="en-US" sz="1600" dirty="0"/>
           </a:p>
@@ -3119,6 +3190,2208 @@
               <a:t>Questions?  |  Arun C (23MIS0445)  |  Sai Chandan K S (23MIS0115)</a:t>
             </a:r>
             <a:endParaRPr lang="en-US" sz="3000" dirty="0"/>
+          </a:p>
+        </p:txBody>
+      </p:sp>
+    </p:spTree>
+  </p:cSld>
+  <p:clrMapOvr>
+    <a:masterClrMapping/>
+  </p:clrMapOvr>
+</p:sld>
+</file>
+
+<file path=ppt/slides/slide11.xml><?xml version="1.0" encoding="utf-8"?>
+<p:sld xmlns:a="http://schemas.openxmlformats.org/drawingml/2006/main" xmlns:p="http://schemas.openxmlformats.org/presentationml/2006/main" xmlns:r="http://schemas.openxmlformats.org/officeDocument/2006/relationships">
+  <p:cSld>
+    <p:spTree>
+      <p:nvGrpSpPr>
+        <p:cNvPr id="1" name=""/>
+        <p:cNvGrpSpPr/>
+        <p:nvPr/>
+      </p:nvGrpSpPr>
+      <p:grpSpPr/>
+      <p:sp>
+        <p:nvSpPr>
+          <p:cNvPr id="2" name="Text 0"/>
+          <p:cNvSpPr/>
+          <p:nvPr>
+            <p:ph idx="100" type="title" hasCustomPrompt="1"/>
+          </p:nvPr>
+        </p:nvSpPr>
+        <p:spPr>
+          <a:xfrm>
+            <a:off x="548640" y="320040"/>
+            <a:ext cx="11064240" cy="777240"/>
+          </a:xfrm>
+          <a:prstGeom prst="rect">
+            <a:avLst/>
+          </a:prstGeom>
+          <a:noFill/>
+          <a:ln/>
+        </p:spPr>
+        <p:txBody>
+          <a:bodyPr wrap="square" lIns="0" tIns="0" rIns="0" bIns="0" rtlCol="0" anchor="ctr"/>
+          <a:lstStyle/>
+          <a:p>
+            <a:pPr indent="0" marL="0">
+              <a:buNone/>
+            </a:pPr>
+            <a:r>
+              <a:rPr lang="en-US" sz="3400" b="1" dirty="0">
+                <a:solidFill>
+                  <a:schemeClr val="tx2"/>
+                </a:solidFill>
+              </a:rPr>
+              <a:t>Negative, Boundary and Security Tests</a:t>
+            </a:r>
+            <a:endParaRPr lang="en-US" sz="3400" dirty="0"/>
+          </a:p>
+        </p:txBody>
+      </p:sp>
+      <p:sp>
+        <p:nvSpPr>
+          <p:cNvPr id="3" name="Slide Number Placeholder 0"/>
+          <p:cNvSpPr>
+            <a:spLocks noGrp="1"/>
+          </p:cNvSpPr>
+          <p:nvPr>
+            <p:ph type="sldNum" sz="quarter" idx="4294967295"/>
+          </p:nvPr>
+        </p:nvSpPr>
+        <p:spPr>
+          <a:xfrm>
+            <a:off x="11155680" y="6400800"/>
+            <a:ext cx="457200" cy="274320"/>
+          </a:xfrm>
+          <a:prstGeom prst="rect">
+            <a:avLst/>
+          </a:prstGeom>
+          <a:extLst>
+            <a:ext uri="{C572A759-6A51-4108-AA02-DFA0A04FC94B}">
+              <ma14:wrappingTextBoxFlag xmlns:ma14="http://schemas.microsoft.com/office/mac/drawingml/2011/main" val="0"/>
+            </a:ext>
+          </a:extLst>
+        </p:spPr>
+        <p:txBody>
+          <a:bodyPr/>
+          <a:lstStyle>
+            <a:lvl1pPr>
+              <a:defRPr sz="1000">
+                <a:solidFill>
+                  <a:schemeClr val="accent6"/>
+                </a:solidFill>
+              </a:defRPr>
+            </a:lvl1pPr>
+          </a:lstStyle>
+          <a:p>
+            <a:pPr algn="r"/>
+            <a:fld id="{F7021451-1387-4CA6-816F-3879F97B5CBC}" type="slidenum">
+              <a:rPr b="0" lang="en-US"/>
+              <a:t>6</a:t>
+            </a:fld>
+            <a:endParaRPr lang="en-US"/>
+          </a:p>
+        </p:txBody>
+      </p:sp>
+      <p:sp>
+        <p:nvSpPr>
+          <p:cNvPr id="4" name="Positive card"/>
+          <p:cNvSpPr/>
+          <p:nvPr/>
+        </p:nvSpPr>
+        <p:spPr>
+          <a:xfrm>
+            <a:off x="548640" y="1188720"/>
+            <a:ext cx="2615184" cy="822960"/>
+          </a:xfrm>
+          <a:prstGeom prst="roundRect">
+            <a:avLst>
+              <a:gd name="adj" fmla="val 10000"/>
+            </a:avLst>
+          </a:prstGeom>
+          <a:solidFill>
+            <a:schemeClr val="bg2"/>
+          </a:solidFill>
+          <a:ln>
+            <a:noFill/>
+          </a:ln>
+          <a:effectLst/>
+        </p:spPr>
+        <p:style>
+          <a:lnRef idx="1">
+            <a:schemeClr val="accent1"/>
+          </a:lnRef>
+          <a:fillRef idx="3">
+            <a:schemeClr val="accent1"/>
+          </a:fillRef>
+          <a:effectRef idx="2">
+            <a:schemeClr val="accent1"/>
+          </a:effectRef>
+          <a:fontRef idx="minor">
+            <a:schemeClr val="lt1"/>
+          </a:fontRef>
+        </p:style>
+        <p:txBody>
+          <a:bodyPr rtlCol="0" anchor="ctr"/>
+          <a:lstStyle/>
+          <a:p>
+            <a:pPr algn="ctr"/>
+          </a:p>
+        </p:txBody>
+      </p:sp>
+      <p:sp>
+        <p:nvSpPr>
+          <p:cNvPr id="5" name="Positive number"/>
+          <p:cNvSpPr txBox="1"/>
+          <p:nvPr/>
+        </p:nvSpPr>
+        <p:spPr>
+          <a:xfrm>
+            <a:off x="713232" y="1188720"/>
+            <a:ext cx="731520" cy="822960"/>
+          </a:xfrm>
+          <a:prstGeom prst="rect">
+            <a:avLst/>
+          </a:prstGeom>
+          <a:noFill/>
+        </p:spPr>
+        <p:txBody>
+          <a:bodyPr wrap="square" lIns="0" rIns="0" tIns="0" bIns="0" anchor="ctr">
+            <a:spAutoFit/>
+          </a:bodyPr>
+          <a:lstStyle/>
+          <a:p>
+            <a:r>
+              <a:rPr sz="3600" b="1">
+                <a:solidFill>
+                  <a:schemeClr val="accent4"/>
+                </a:solidFill>
+              </a:rPr>
+              <a:t>10</a:t>
+            </a:r>
+          </a:p>
+        </p:txBody>
+      </p:sp>
+      <p:sp>
+        <p:nvSpPr>
+          <p:cNvPr id="6" name="Positive label"/>
+          <p:cNvSpPr txBox="1"/>
+          <p:nvPr/>
+        </p:nvSpPr>
+        <p:spPr>
+          <a:xfrm>
+            <a:off x="1444752" y="1261872"/>
+            <a:ext cx="1627631" cy="676656"/>
+          </a:xfrm>
+          <a:prstGeom prst="rect">
+            <a:avLst/>
+          </a:prstGeom>
+          <a:noFill/>
+        </p:spPr>
+        <p:txBody>
+          <a:bodyPr wrap="square" lIns="0" rIns="0" tIns="0" bIns="0" anchor="ctr">
+            <a:spAutoFit/>
+          </a:bodyPr>
+          <a:lstStyle/>
+          <a:p>
+            <a:r>
+              <a:rPr sz="1400" b="1">
+                <a:solidFill>
+                  <a:schemeClr val="tx2"/>
+                </a:solidFill>
+              </a:rPr>
+              <a:t>Positive</a:t>
+            </a:r>
+          </a:p>
+          <a:p>
+            <a:r>
+              <a:rPr sz="1200" b="0">
+                <a:solidFill>
+                  <a:schemeClr val="tx1"/>
+                </a:solidFill>
+              </a:rPr>
+              <a:t>valid input works</a:t>
+            </a:r>
+          </a:p>
+        </p:txBody>
+      </p:sp>
+      <p:sp>
+        <p:nvSpPr>
+          <p:cNvPr id="7" name="Negative card"/>
+          <p:cNvSpPr/>
+          <p:nvPr/>
+        </p:nvSpPr>
+        <p:spPr>
+          <a:xfrm>
+            <a:off x="3364992" y="1188720"/>
+            <a:ext cx="2615184" cy="822960"/>
+          </a:xfrm>
+          <a:prstGeom prst="roundRect">
+            <a:avLst>
+              <a:gd name="adj" fmla="val 10000"/>
+            </a:avLst>
+          </a:prstGeom>
+          <a:solidFill>
+            <a:schemeClr val="bg2"/>
+          </a:solidFill>
+          <a:ln>
+            <a:noFill/>
+          </a:ln>
+          <a:effectLst/>
+        </p:spPr>
+        <p:style>
+          <a:lnRef idx="1">
+            <a:schemeClr val="accent1"/>
+          </a:lnRef>
+          <a:fillRef idx="3">
+            <a:schemeClr val="accent1"/>
+          </a:fillRef>
+          <a:effectRef idx="2">
+            <a:schemeClr val="accent1"/>
+          </a:effectRef>
+          <a:fontRef idx="minor">
+            <a:schemeClr val="lt1"/>
+          </a:fontRef>
+        </p:style>
+        <p:txBody>
+          <a:bodyPr rtlCol="0" anchor="ctr"/>
+          <a:lstStyle/>
+          <a:p>
+            <a:pPr algn="ctr"/>
+          </a:p>
+        </p:txBody>
+      </p:sp>
+      <p:sp>
+        <p:nvSpPr>
+          <p:cNvPr id="8" name="Negative number"/>
+          <p:cNvSpPr txBox="1"/>
+          <p:nvPr/>
+        </p:nvSpPr>
+        <p:spPr>
+          <a:xfrm>
+            <a:off x="3529584" y="1188720"/>
+            <a:ext cx="731520" cy="822960"/>
+          </a:xfrm>
+          <a:prstGeom prst="rect">
+            <a:avLst/>
+          </a:prstGeom>
+          <a:noFill/>
+        </p:spPr>
+        <p:txBody>
+          <a:bodyPr wrap="square" lIns="0" rIns="0" tIns="0" bIns="0" anchor="ctr">
+            <a:spAutoFit/>
+          </a:bodyPr>
+          <a:lstStyle/>
+          <a:p>
+            <a:r>
+              <a:rPr sz="3600" b="1">
+                <a:solidFill>
+                  <a:schemeClr val="accent3"/>
+                </a:solidFill>
+              </a:rPr>
+              <a:t>17</a:t>
+            </a:r>
+          </a:p>
+        </p:txBody>
+      </p:sp>
+      <p:sp>
+        <p:nvSpPr>
+          <p:cNvPr id="9" name="Negative label"/>
+          <p:cNvSpPr txBox="1"/>
+          <p:nvPr/>
+        </p:nvSpPr>
+        <p:spPr>
+          <a:xfrm>
+            <a:off x="4261104" y="1261872"/>
+            <a:ext cx="1627631" cy="676656"/>
+          </a:xfrm>
+          <a:prstGeom prst="rect">
+            <a:avLst/>
+          </a:prstGeom>
+          <a:noFill/>
+        </p:spPr>
+        <p:txBody>
+          <a:bodyPr wrap="square" lIns="0" rIns="0" tIns="0" bIns="0" anchor="ctr">
+            <a:spAutoFit/>
+          </a:bodyPr>
+          <a:lstStyle/>
+          <a:p>
+            <a:r>
+              <a:rPr sz="1400" b="1">
+                <a:solidFill>
+                  <a:schemeClr val="tx2"/>
+                </a:solidFill>
+              </a:rPr>
+              <a:t>Negative</a:t>
+            </a:r>
+          </a:p>
+          <a:p>
+            <a:r>
+              <a:rPr sz="1200" b="0">
+                <a:solidFill>
+                  <a:schemeClr val="tx1"/>
+                </a:solidFill>
+              </a:rPr>
+              <a:t>error shown, nothing saved</a:t>
+            </a:r>
+          </a:p>
+        </p:txBody>
+      </p:sp>
+      <p:sp>
+        <p:nvSpPr>
+          <p:cNvPr id="10" name="Boundary / Edge card"/>
+          <p:cNvSpPr/>
+          <p:nvPr/>
+        </p:nvSpPr>
+        <p:spPr>
+          <a:xfrm>
+            <a:off x="6181344" y="1188720"/>
+            <a:ext cx="2615184" cy="822960"/>
+          </a:xfrm>
+          <a:prstGeom prst="roundRect">
+            <a:avLst>
+              <a:gd name="adj" fmla="val 10000"/>
+            </a:avLst>
+          </a:prstGeom>
+          <a:solidFill>
+            <a:schemeClr val="bg2"/>
+          </a:solidFill>
+          <a:ln>
+            <a:noFill/>
+          </a:ln>
+          <a:effectLst/>
+        </p:spPr>
+        <p:style>
+          <a:lnRef idx="1">
+            <a:schemeClr val="accent1"/>
+          </a:lnRef>
+          <a:fillRef idx="3">
+            <a:schemeClr val="accent1"/>
+          </a:fillRef>
+          <a:effectRef idx="2">
+            <a:schemeClr val="accent1"/>
+          </a:effectRef>
+          <a:fontRef idx="minor">
+            <a:schemeClr val="lt1"/>
+          </a:fontRef>
+        </p:style>
+        <p:txBody>
+          <a:bodyPr rtlCol="0" anchor="ctr"/>
+          <a:lstStyle/>
+          <a:p>
+            <a:pPr algn="ctr"/>
+          </a:p>
+        </p:txBody>
+      </p:sp>
+      <p:sp>
+        <p:nvSpPr>
+          <p:cNvPr id="11" name="Boundary / Edge number"/>
+          <p:cNvSpPr txBox="1"/>
+          <p:nvPr/>
+        </p:nvSpPr>
+        <p:spPr>
+          <a:xfrm>
+            <a:off x="6345936" y="1188720"/>
+            <a:ext cx="731520" cy="822960"/>
+          </a:xfrm>
+          <a:prstGeom prst="rect">
+            <a:avLst/>
+          </a:prstGeom>
+          <a:noFill/>
+        </p:spPr>
+        <p:txBody>
+          <a:bodyPr wrap="square" lIns="0" rIns="0" tIns="0" bIns="0" anchor="ctr">
+            <a:spAutoFit/>
+          </a:bodyPr>
+          <a:lstStyle/>
+          <a:p>
+            <a:r>
+              <a:rPr sz="3600" b="1">
+                <a:solidFill>
+                  <a:schemeClr val="accent1"/>
+                </a:solidFill>
+              </a:rPr>
+              <a:t>7</a:t>
+            </a:r>
+          </a:p>
+        </p:txBody>
+      </p:sp>
+      <p:sp>
+        <p:nvSpPr>
+          <p:cNvPr id="12" name="Boundary / Edge label"/>
+          <p:cNvSpPr txBox="1"/>
+          <p:nvPr/>
+        </p:nvSpPr>
+        <p:spPr>
+          <a:xfrm>
+            <a:off x="7077456" y="1261872"/>
+            <a:ext cx="1627631" cy="676656"/>
+          </a:xfrm>
+          <a:prstGeom prst="rect">
+            <a:avLst/>
+          </a:prstGeom>
+          <a:noFill/>
+        </p:spPr>
+        <p:txBody>
+          <a:bodyPr wrap="square" lIns="0" rIns="0" tIns="0" bIns="0" anchor="ctr">
+            <a:spAutoFit/>
+          </a:bodyPr>
+          <a:lstStyle/>
+          <a:p>
+            <a:r>
+              <a:rPr sz="1400" b="1">
+                <a:solidFill>
+                  <a:schemeClr val="tx2"/>
+                </a:solidFill>
+              </a:rPr>
+              <a:t>Boundary / Edge</a:t>
+            </a:r>
+          </a:p>
+          <a:p>
+            <a:r>
+              <a:rPr sz="1200" b="0">
+                <a:solidFill>
+                  <a:schemeClr val="tx1"/>
+                </a:solidFill>
+              </a:rPr>
+              <a:t>at and past the limits</a:t>
+            </a:r>
+          </a:p>
+        </p:txBody>
+      </p:sp>
+      <p:sp>
+        <p:nvSpPr>
+          <p:cNvPr id="13" name="Security card"/>
+          <p:cNvSpPr/>
+          <p:nvPr/>
+        </p:nvSpPr>
+        <p:spPr>
+          <a:xfrm>
+            <a:off x="8997696" y="1188720"/>
+            <a:ext cx="2615184" cy="822960"/>
+          </a:xfrm>
+          <a:prstGeom prst="roundRect">
+            <a:avLst>
+              <a:gd name="adj" fmla="val 10000"/>
+            </a:avLst>
+          </a:prstGeom>
+          <a:solidFill>
+            <a:schemeClr val="bg2"/>
+          </a:solidFill>
+          <a:ln>
+            <a:noFill/>
+          </a:ln>
+          <a:effectLst/>
+        </p:spPr>
+        <p:style>
+          <a:lnRef idx="1">
+            <a:schemeClr val="accent1"/>
+          </a:lnRef>
+          <a:fillRef idx="3">
+            <a:schemeClr val="accent1"/>
+          </a:fillRef>
+          <a:effectRef idx="2">
+            <a:schemeClr val="accent1"/>
+          </a:effectRef>
+          <a:fontRef idx="minor">
+            <a:schemeClr val="lt1"/>
+          </a:fontRef>
+        </p:style>
+        <p:txBody>
+          <a:bodyPr rtlCol="0" anchor="ctr"/>
+          <a:lstStyle/>
+          <a:p>
+            <a:pPr algn="ctr"/>
+          </a:p>
+        </p:txBody>
+      </p:sp>
+      <p:sp>
+        <p:nvSpPr>
+          <p:cNvPr id="14" name="Security number"/>
+          <p:cNvSpPr txBox="1"/>
+          <p:nvPr/>
+        </p:nvSpPr>
+        <p:spPr>
+          <a:xfrm>
+            <a:off x="9162288" y="1188720"/>
+            <a:ext cx="731520" cy="822960"/>
+          </a:xfrm>
+          <a:prstGeom prst="rect">
+            <a:avLst/>
+          </a:prstGeom>
+          <a:noFill/>
+        </p:spPr>
+        <p:txBody>
+          <a:bodyPr wrap="square" lIns="0" rIns="0" tIns="0" bIns="0" anchor="ctr">
+            <a:spAutoFit/>
+          </a:bodyPr>
+          <a:lstStyle/>
+          <a:p>
+            <a:r>
+              <a:rPr sz="3600" b="1">
+                <a:solidFill>
+                  <a:schemeClr val="tx2"/>
+                </a:solidFill>
+              </a:rPr>
+              <a:t>3</a:t>
+            </a:r>
+          </a:p>
+        </p:txBody>
+      </p:sp>
+      <p:sp>
+        <p:nvSpPr>
+          <p:cNvPr id="15" name="Security label"/>
+          <p:cNvSpPr txBox="1"/>
+          <p:nvPr/>
+        </p:nvSpPr>
+        <p:spPr>
+          <a:xfrm>
+            <a:off x="9893808" y="1261872"/>
+            <a:ext cx="1627631" cy="676656"/>
+          </a:xfrm>
+          <a:prstGeom prst="rect">
+            <a:avLst/>
+          </a:prstGeom>
+          <a:noFill/>
+        </p:spPr>
+        <p:txBody>
+          <a:bodyPr wrap="square" lIns="0" rIns="0" tIns="0" bIns="0" anchor="ctr">
+            <a:spAutoFit/>
+          </a:bodyPr>
+          <a:lstStyle/>
+          <a:p>
+            <a:r>
+              <a:rPr sz="1400" b="1">
+                <a:solidFill>
+                  <a:schemeClr val="tx2"/>
+                </a:solidFill>
+              </a:rPr>
+              <a:t>Security</a:t>
+            </a:r>
+          </a:p>
+          <a:p>
+            <a:r>
+              <a:rPr sz="1200" b="0">
+                <a:solidFill>
+                  <a:schemeClr val="tx1"/>
+                </a:solidFill>
+              </a:rPr>
+              <a:t>SQL injection, XSS, login</a:t>
+            </a:r>
+          </a:p>
+        </p:txBody>
+      </p:sp>
+      <p:graphicFrame>
+        <p:nvGraphicFramePr>
+          <p:cNvPr id="16" name="Negative tests table"/>
+          <p:cNvGraphicFramePr>
+            <a:graphicFrameLocks noGrp="1"/>
+          </p:cNvGraphicFramePr>
+          <p:nvPr>
+            <p:extLst>
+              <p:ext uri="{D42A27DB-BD31-4B8C-83A1-F6EECF244321}">
+                <p14:modId xmlns:p14="http://schemas.microsoft.com/office/powerpoint/2010/main" val="1579011935"/>
+              </p:ext>
+            </p:extLst>
+          </p:nvPr>
+        </p:nvGraphicFramePr>
+        <p:xfrm>
+          <a:off x="548640" y="2194560"/>
+          <a:ext cx="11064240" cy="3145536"/>
+        </p:xfrm>
+        <a:graphic>
+          <a:graphicData uri="http://schemas.openxmlformats.org/drawingml/2006/table">
+            <a:tbl>
+              <a:tblPr/>
+              <a:tblGrid>
+                <a:gridCol w="1691640"/>
+                <a:gridCol w="9372600"/>
+              </a:tblGrid>
+              <a:tr h="365760">
+                <a:tc>
+                  <a:txBody>
+                    <a:bodyPr/>
+                    <a:lstStyle/>
+                    <a:p>
+                      <a:pPr indent="0" marL="0">
+                        <a:buNone/>
+                      </a:pPr>
+                      <a:r>
+                        <a:rPr lang="en-US" sz="1400" b="1" dirty="0">
+                          <a:solidFill>
+                            <a:srgbClr val="FFFFFF"/>
+                          </a:solidFill>
+                          <a:latin typeface="Calibri" pitchFamily="34" charset="0"/>
+                          <a:ea typeface="Calibri" pitchFamily="34" charset="-122"/>
+                          <a:cs typeface="Calibri" pitchFamily="34" charset="-120"/>
+                        </a:rPr>
+                        <a:t>Module</a:t>
+                      </a:r>
+                      <a:endParaRPr lang="en-US" sz="1400" dirty="0">
+                        <a:latin typeface="Calibri" charset="0"/>
+                        <a:ea typeface="Calibri" charset="0"/>
+                        <a:cs typeface="Calibri" charset="0"/>
+                      </a:endParaRPr>
+                    </a:p>
+                  </a:txBody>
+                  <a:tcPr marL="91440" marR="91440" marT="45720" marB="45720" anchor="ctr">
+                    <a:lnL w="6350" cap="flat" cmpd="sng" algn="ctr">
+                      <a:solidFill>
+                        <a:srgbClr val="D5E3E6"/>
+                      </a:solidFill>
+                      <a:prstDash val="solid"/>
+                      <a:round/>
+                      <a:headEnd type="none" w="med" len="med"/>
+                      <a:tailEnd type="none" w="med" len="med"/>
+                    </a:lnL>
+                    <a:lnR w="6350" cap="flat" cmpd="sng" algn="ctr">
+                      <a:solidFill>
+                        <a:srgbClr val="D5E3E6"/>
+                      </a:solidFill>
+                      <a:prstDash val="solid"/>
+                      <a:round/>
+                      <a:headEnd type="none" w="med" len="med"/>
+                      <a:tailEnd type="none" w="med" len="med"/>
+                    </a:lnR>
+                    <a:lnT w="6350" cap="flat" cmpd="sng" algn="ctr">
+                      <a:solidFill>
+                        <a:srgbClr val="D5E3E6"/>
+                      </a:solidFill>
+                      <a:prstDash val="solid"/>
+                      <a:round/>
+                      <a:headEnd type="none" w="med" len="med"/>
+                      <a:tailEnd type="none" w="med" len="med"/>
+                    </a:lnT>
+                    <a:lnB w="6350" cap="flat" cmpd="sng" algn="ctr">
+                      <a:solidFill>
+                        <a:srgbClr val="D5E3E6"/>
+                      </a:solidFill>
+                      <a:prstDash val="solid"/>
+                      <a:round/>
+                      <a:headEnd type="none" w="med" len="med"/>
+                      <a:tailEnd type="none" w="med" len="med"/>
+                    </a:lnB>
+                    <a:solidFill>
+                      <a:srgbClr val="0B4F5C"/>
+                    </a:solidFill>
+                  </a:tcPr>
+                </a:tc>
+                <a:tc>
+                  <a:txBody>
+                    <a:bodyPr/>
+                    <a:lstStyle/>
+                    <a:p>
+                      <a:pPr indent="0" marL="0">
+                        <a:buNone/>
+                      </a:pPr>
+                      <a:r>
+                        <a:rPr lang="en-US" sz="1300" b="1" dirty="0">
+                          <a:solidFill>
+                            <a:srgbClr val="FFFFFF"/>
+                          </a:solidFill>
+                          <a:latin typeface="Calibri" pitchFamily="34" charset="0"/>
+                          <a:ea typeface="Calibri" pitchFamily="34" charset="-122"/>
+                          <a:cs typeface="Calibri" pitchFamily="34" charset="-120"/>
+                        </a:rPr>
+                        <a:t>Negative, boundary / edge and security test cases (TC14–TC37)</a:t>
+                      </a:r>
+                      <a:endParaRPr lang="en-US" sz="1400" dirty="0">
+                        <a:latin typeface="Calibri" charset="0"/>
+                        <a:ea typeface="Calibri" charset="0"/>
+                        <a:cs typeface="Calibri" charset="0"/>
+                      </a:endParaRPr>
+                    </a:p>
+                  </a:txBody>
+                  <a:tcPr marL="91440" marR="91440" marT="45720" marB="45720" anchor="ctr">
+                    <a:lnL w="6350" cap="flat" cmpd="sng" algn="ctr">
+                      <a:solidFill>
+                        <a:srgbClr val="D5E3E6"/>
+                      </a:solidFill>
+                      <a:prstDash val="solid"/>
+                      <a:round/>
+                      <a:headEnd type="none" w="med" len="med"/>
+                      <a:tailEnd type="none" w="med" len="med"/>
+                    </a:lnL>
+                    <a:lnR w="6350" cap="flat" cmpd="sng" algn="ctr">
+                      <a:solidFill>
+                        <a:srgbClr val="D5E3E6"/>
+                      </a:solidFill>
+                      <a:prstDash val="solid"/>
+                      <a:round/>
+                      <a:headEnd type="none" w="med" len="med"/>
+                      <a:tailEnd type="none" w="med" len="med"/>
+                    </a:lnR>
+                    <a:lnT w="6350" cap="flat" cmpd="sng" algn="ctr">
+                      <a:solidFill>
+                        <a:srgbClr val="D5E3E6"/>
+                      </a:solidFill>
+                      <a:prstDash val="solid"/>
+                      <a:round/>
+                      <a:headEnd type="none" w="med" len="med"/>
+                      <a:tailEnd type="none" w="med" len="med"/>
+                    </a:lnT>
+                    <a:lnB w="6350" cap="flat" cmpd="sng" algn="ctr">
+                      <a:solidFill>
+                        <a:srgbClr val="D5E3E6"/>
+                      </a:solidFill>
+                      <a:prstDash val="solid"/>
+                      <a:round/>
+                      <a:headEnd type="none" w="med" len="med"/>
+                      <a:tailEnd type="none" w="med" len="med"/>
+                    </a:lnB>
+                    <a:solidFill>
+                      <a:srgbClr val="0B4F5C"/>
+                    </a:solidFill>
+                  </a:tcPr>
+                </a:tc>
+              </a:tr>
+              <a:tr h="384048">
+                <a:tc>
+                  <a:txBody>
+                    <a:bodyPr/>
+                    <a:lstStyle/>
+                    <a:p>
+                      <a:pPr indent="0" marL="0">
+                        <a:buNone/>
+                      </a:pPr>
+                      <a:r>
+                        <a:rPr lang="en-US" sz="1400" b="1" dirty="0">
+                          <a:solidFill>
+                            <a:srgbClr val="0E7C86"/>
+                          </a:solidFill>
+                          <a:latin typeface="Calibri" pitchFamily="34" charset="0"/>
+                          <a:ea typeface="Calibri" pitchFamily="34" charset="-122"/>
+                          <a:cs typeface="Calibri" pitchFamily="34" charset="-120"/>
+                        </a:rPr>
+                        <a:t>Login</a:t>
+                      </a:r>
+                      <a:endParaRPr lang="en-US" sz="1400" dirty="0">
+                        <a:latin typeface="Calibri" charset="0"/>
+                        <a:ea typeface="Calibri" charset="0"/>
+                        <a:cs typeface="Calibri" charset="0"/>
+                      </a:endParaRPr>
+                    </a:p>
+                  </a:txBody>
+                  <a:tcPr marL="91440" marR="91440" marT="45720" marB="45720" anchor="ctr">
+                    <a:lnL w="6350" cap="flat" cmpd="sng" algn="ctr">
+                      <a:solidFill>
+                        <a:srgbClr val="D5E3E6"/>
+                      </a:solidFill>
+                      <a:prstDash val="solid"/>
+                      <a:round/>
+                      <a:headEnd type="none" w="med" len="med"/>
+                      <a:tailEnd type="none" w="med" len="med"/>
+                    </a:lnL>
+                    <a:lnR w="6350" cap="flat" cmpd="sng" algn="ctr">
+                      <a:solidFill>
+                        <a:srgbClr val="D5E3E6"/>
+                      </a:solidFill>
+                      <a:prstDash val="solid"/>
+                      <a:round/>
+                      <a:headEnd type="none" w="med" len="med"/>
+                      <a:tailEnd type="none" w="med" len="med"/>
+                    </a:lnR>
+                    <a:lnT w="6350" cap="flat" cmpd="sng" algn="ctr">
+                      <a:solidFill>
+                        <a:srgbClr val="D5E3E6"/>
+                      </a:solidFill>
+                      <a:prstDash val="solid"/>
+                      <a:round/>
+                      <a:headEnd type="none" w="med" len="med"/>
+                      <a:tailEnd type="none" w="med" len="med"/>
+                    </a:lnT>
+                    <a:lnB w="6350" cap="flat" cmpd="sng" algn="ctr">
+                      <a:solidFill>
+                        <a:srgbClr val="D5E3E6"/>
+                      </a:solidFill>
+                      <a:prstDash val="solid"/>
+                      <a:round/>
+                      <a:headEnd type="none" w="med" len="med"/>
+                      <a:tailEnd type="none" w="med" len="med"/>
+                    </a:lnB>
+                    <a:solidFill>
+                      <a:srgbClr val="EEF5F6"/>
+                    </a:solidFill>
+                  </a:tcPr>
+                </a:tc>
+                <a:tc>
+                  <a:txBody>
+                    <a:bodyPr/>
+                    <a:lstStyle/>
+                    <a:p>
+                      <a:pPr indent="0" marL="0">
+                        <a:buNone/>
+                      </a:pPr>
+                      <a:r>
+                        <a:rPr lang="en-US" sz="1300" dirty="0" b="1">
+                          <a:solidFill>
+                            <a:srgbClr val="1D2B33"/>
+                          </a:solidFill>
+                          <a:latin typeface="Calibri" pitchFamily="34" charset="0"/>
+                          <a:ea typeface="Calibri" pitchFamily="34" charset="-122"/>
+                          <a:cs typeface="Calibri" pitchFamily="34" charset="-120"/>
+                        </a:rPr>
+                        <a:t>TC14</a:t>
+                      </a:r>
+                      <a:r>
+                        <a:rPr lang="en-US" sz="1300" dirty="0">
+                          <a:solidFill>
+                            <a:srgbClr val="1D2B33"/>
+                          </a:solidFill>
+                          <a:latin typeface="Calibri" pitchFamily="34" charset="0"/>
+                          <a:ea typeface="Calibri" pitchFamily="34" charset="-122"/>
+                          <a:cs typeface="Calibri" pitchFamily="34" charset="-120"/>
+                        </a:rPr>
+                        <a:t> wrong username  ·  </a:t>
+                      </a:r>
+                      <a:r>
+                        <a:rPr lang="en-US" sz="1300" dirty="0" b="1">
+                          <a:solidFill>
+                            <a:srgbClr val="1D2B33"/>
+                          </a:solidFill>
+                          <a:latin typeface="Calibri" pitchFamily="34" charset="0"/>
+                          <a:ea typeface="Calibri" pitchFamily="34" charset="-122"/>
+                          <a:cs typeface="Calibri" pitchFamily="34" charset="-120"/>
+                        </a:rPr>
+                        <a:t>TC15</a:t>
+                      </a:r>
+                      <a:r>
+                        <a:rPr lang="en-US" sz="1300" dirty="0">
+                          <a:solidFill>
+                            <a:srgbClr val="1D2B33"/>
+                          </a:solidFill>
+                          <a:latin typeface="Calibri" pitchFamily="34" charset="0"/>
+                          <a:ea typeface="Calibri" pitchFamily="34" charset="-122"/>
+                          <a:cs typeface="Calibri" pitchFamily="34" charset="-120"/>
+                        </a:rPr>
+                        <a:t> empty fields  ·  </a:t>
+                      </a:r>
+                      <a:r>
+                        <a:rPr lang="en-US" sz="1300" dirty="0" b="1">
+                          <a:solidFill>
+                            <a:srgbClr val="1D2B33"/>
+                          </a:solidFill>
+                          <a:latin typeface="Calibri" pitchFamily="34" charset="0"/>
+                          <a:ea typeface="Calibri" pitchFamily="34" charset="-122"/>
+                          <a:cs typeface="Calibri" pitchFamily="34" charset="-120"/>
+                        </a:rPr>
+                        <a:t>TC16</a:t>
+                      </a:r>
+                      <a:r>
+                        <a:rPr lang="en-US" sz="1300" dirty="0">
+                          <a:solidFill>
+                            <a:srgbClr val="1D2B33"/>
+                          </a:solidFill>
+                          <a:latin typeface="Calibri" pitchFamily="34" charset="0"/>
+                          <a:ea typeface="Calibri" pitchFamily="34" charset="-122"/>
+                          <a:cs typeface="Calibri" pitchFamily="34" charset="-120"/>
+                        </a:rPr>
+                        <a:t> SQL injection  ·  </a:t>
+                      </a:r>
+                      <a:r>
+                        <a:rPr lang="en-US" sz="1300" dirty="0" b="1">
+                          <a:solidFill>
+                            <a:srgbClr val="1D2B33"/>
+                          </a:solidFill>
+                          <a:latin typeface="Calibri" pitchFamily="34" charset="0"/>
+                          <a:ea typeface="Calibri" pitchFamily="34" charset="-122"/>
+                          <a:cs typeface="Calibri" pitchFamily="34" charset="-120"/>
+                        </a:rPr>
+                        <a:t>TC17</a:t>
+                      </a:r>
+                      <a:r>
+                        <a:rPr lang="en-US" sz="1300" dirty="0">
+                          <a:solidFill>
+                            <a:srgbClr val="1D2B33"/>
+                          </a:solidFill>
+                          <a:latin typeface="Calibri" pitchFamily="34" charset="0"/>
+                          <a:ea typeface="Calibri" pitchFamily="34" charset="-122"/>
+                          <a:cs typeface="Calibri" pitchFamily="34" charset="-120"/>
+                        </a:rPr>
+                        <a:t> page without login</a:t>
+                      </a:r>
+                      <a:endParaRPr lang="en-US" sz="1400" dirty="0">
+                        <a:latin typeface="Calibri" charset="0"/>
+                        <a:ea typeface="Calibri" charset="0"/>
+                        <a:cs typeface="Calibri" charset="0"/>
+                      </a:endParaRPr>
+                    </a:p>
+                  </a:txBody>
+                  <a:tcPr marL="91440" marR="91440" marT="45720" marB="45720" anchor="ctr">
+                    <a:lnL w="6350" cap="flat" cmpd="sng" algn="ctr">
+                      <a:solidFill>
+                        <a:srgbClr val="D5E3E6"/>
+                      </a:solidFill>
+                      <a:prstDash val="solid"/>
+                      <a:round/>
+                      <a:headEnd type="none" w="med" len="med"/>
+                      <a:tailEnd type="none" w="med" len="med"/>
+                    </a:lnL>
+                    <a:lnR w="6350" cap="flat" cmpd="sng" algn="ctr">
+                      <a:solidFill>
+                        <a:srgbClr val="D5E3E6"/>
+                      </a:solidFill>
+                      <a:prstDash val="solid"/>
+                      <a:round/>
+                      <a:headEnd type="none" w="med" len="med"/>
+                      <a:tailEnd type="none" w="med" len="med"/>
+                    </a:lnR>
+                    <a:lnT w="6350" cap="flat" cmpd="sng" algn="ctr">
+                      <a:solidFill>
+                        <a:srgbClr val="D5E3E6"/>
+                      </a:solidFill>
+                      <a:prstDash val="solid"/>
+                      <a:round/>
+                      <a:headEnd type="none" w="med" len="med"/>
+                      <a:tailEnd type="none" w="med" len="med"/>
+                    </a:lnT>
+                    <a:lnB w="6350" cap="flat" cmpd="sng" algn="ctr">
+                      <a:solidFill>
+                        <a:srgbClr val="D5E3E6"/>
+                      </a:solidFill>
+                      <a:prstDash val="solid"/>
+                      <a:round/>
+                      <a:headEnd type="none" w="med" len="med"/>
+                      <a:tailEnd type="none" w="med" len="med"/>
+                    </a:lnB>
+                    <a:solidFill>
+                      <a:srgbClr val="EEF5F6"/>
+                    </a:solidFill>
+                  </a:tcPr>
+                </a:tc>
+              </a:tr>
+              <a:tr h="621792">
+                <a:tc>
+                  <a:txBody>
+                    <a:bodyPr/>
+                    <a:lstStyle/>
+                    <a:p>
+                      <a:pPr indent="0" marL="0">
+                        <a:buNone/>
+                      </a:pPr>
+                      <a:r>
+                        <a:rPr lang="en-US" sz="1400" b="1" dirty="0">
+                          <a:solidFill>
+                            <a:srgbClr val="0E7C86"/>
+                          </a:solidFill>
+                          <a:latin typeface="Calibri" pitchFamily="34" charset="0"/>
+                          <a:ea typeface="Calibri" pitchFamily="34" charset="-122"/>
+                          <a:cs typeface="Calibri" pitchFamily="34" charset="-120"/>
+                        </a:rPr>
+                        <a:t>Patients</a:t>
+                      </a:r>
+                      <a:endParaRPr lang="en-US" sz="1400" dirty="0">
+                        <a:latin typeface="Calibri" charset="0"/>
+                        <a:ea typeface="Calibri" charset="0"/>
+                        <a:cs typeface="Calibri" charset="0"/>
+                      </a:endParaRPr>
+                    </a:p>
+                  </a:txBody>
+                  <a:tcPr marL="91440" marR="91440" marT="45720" marB="45720" anchor="ctr">
+                    <a:lnL w="6350" cap="flat" cmpd="sng" algn="ctr">
+                      <a:solidFill>
+                        <a:srgbClr val="D5E3E6"/>
+                      </a:solidFill>
+                      <a:prstDash val="solid"/>
+                      <a:round/>
+                      <a:headEnd type="none" w="med" len="med"/>
+                      <a:tailEnd type="none" w="med" len="med"/>
+                    </a:lnL>
+                    <a:lnR w="6350" cap="flat" cmpd="sng" algn="ctr">
+                      <a:solidFill>
+                        <a:srgbClr val="D5E3E6"/>
+                      </a:solidFill>
+                      <a:prstDash val="solid"/>
+                      <a:round/>
+                      <a:headEnd type="none" w="med" len="med"/>
+                      <a:tailEnd type="none" w="med" len="med"/>
+                    </a:lnR>
+                    <a:lnT w="6350" cap="flat" cmpd="sng" algn="ctr">
+                      <a:solidFill>
+                        <a:srgbClr val="D5E3E6"/>
+                      </a:solidFill>
+                      <a:prstDash val="solid"/>
+                      <a:round/>
+                      <a:headEnd type="none" w="med" len="med"/>
+                      <a:tailEnd type="none" w="med" len="med"/>
+                    </a:lnT>
+                    <a:lnB w="6350" cap="flat" cmpd="sng" algn="ctr">
+                      <a:solidFill>
+                        <a:srgbClr val="D5E3E6"/>
+                      </a:solidFill>
+                      <a:prstDash val="solid"/>
+                      <a:round/>
+                      <a:headEnd type="none" w="med" len="med"/>
+                      <a:tailEnd type="none" w="med" len="med"/>
+                    </a:lnB>
+                    <a:solidFill>
+                      <a:srgbClr val="FFFFFF"/>
+                    </a:solidFill>
+                  </a:tcPr>
+                </a:tc>
+                <a:tc>
+                  <a:txBody>
+                    <a:bodyPr/>
+                    <a:lstStyle/>
+                    <a:p>
+                      <a:pPr indent="0" marL="0">
+                        <a:buNone/>
+                      </a:pPr>
+                      <a:r>
+                        <a:rPr lang="en-US" sz="1300" dirty="0" b="1">
+                          <a:solidFill>
+                            <a:srgbClr val="1D2B33"/>
+                          </a:solidFill>
+                          <a:latin typeface="Calibri" pitchFamily="34" charset="0"/>
+                          <a:ea typeface="Calibri" pitchFamily="34" charset="-122"/>
+                          <a:cs typeface="Calibri" pitchFamily="34" charset="-120"/>
+                        </a:rPr>
+                        <a:t>TC18</a:t>
+                      </a:r>
+                      <a:r>
+                        <a:rPr lang="en-US" sz="1300" dirty="0">
+                          <a:solidFill>
+                            <a:srgbClr val="1D2B33"/>
+                          </a:solidFill>
+                          <a:latin typeface="Calibri" pitchFamily="34" charset="0"/>
+                          <a:ea typeface="Calibri" pitchFamily="34" charset="-122"/>
+                          <a:cs typeface="Calibri" pitchFamily="34" charset="-120"/>
+                        </a:rPr>
+                        <a:t> phone 12345  ·  </a:t>
+                      </a:r>
+                      <a:r>
+                        <a:rPr lang="en-US" sz="1300" dirty="0" b="1">
+                          <a:solidFill>
+                            <a:srgbClr val="1D2B33"/>
+                          </a:solidFill>
+                          <a:latin typeface="Calibri" pitchFamily="34" charset="0"/>
+                          <a:ea typeface="Calibri" pitchFamily="34" charset="-122"/>
+                          <a:cs typeface="Calibri" pitchFamily="34" charset="-120"/>
+                        </a:rPr>
+                        <a:t>TC19</a:t>
+                      </a:r>
+                      <a:r>
+                        <a:rPr lang="en-US" sz="1300" dirty="0">
+                          <a:solidFill>
+                            <a:srgbClr val="1D2B33"/>
+                          </a:solidFill>
+                          <a:latin typeface="Calibri" pitchFamily="34" charset="0"/>
+                          <a:ea typeface="Calibri" pitchFamily="34" charset="-122"/>
+                          <a:cs typeface="Calibri" pitchFamily="34" charset="-120"/>
+                        </a:rPr>
+                        <a:t> phone with 11 digits  ·  </a:t>
+                      </a:r>
+                      <a:r>
+                        <a:rPr lang="en-US" sz="1300" dirty="0" b="1">
+                          <a:solidFill>
+                            <a:srgbClr val="1D2B33"/>
+                          </a:solidFill>
+                          <a:latin typeface="Calibri" pitchFamily="34" charset="0"/>
+                          <a:ea typeface="Calibri" pitchFamily="34" charset="-122"/>
+                          <a:cs typeface="Calibri" pitchFamily="34" charset="-120"/>
+                        </a:rPr>
+                        <a:t>TC20</a:t>
+                      </a:r>
+                      <a:r>
+                        <a:rPr lang="en-US" sz="1300" dirty="0">
+                          <a:solidFill>
+                            <a:srgbClr val="1D2B33"/>
+                          </a:solidFill>
+                          <a:latin typeface="Calibri" pitchFamily="34" charset="0"/>
+                          <a:ea typeface="Calibri" pitchFamily="34" charset="-122"/>
+                          <a:cs typeface="Calibri" pitchFamily="34" charset="-120"/>
+                        </a:rPr>
+                        <a:t> name Ravi123  ·  </a:t>
+                      </a:r>
+                      <a:r>
+                        <a:rPr lang="en-US" sz="1300" dirty="0" b="1">
+                          <a:solidFill>
+                            <a:srgbClr val="1D2B33"/>
+                          </a:solidFill>
+                          <a:latin typeface="Calibri" pitchFamily="34" charset="0"/>
+                          <a:ea typeface="Calibri" pitchFamily="34" charset="-122"/>
+                          <a:cs typeface="Calibri" pitchFamily="34" charset="-120"/>
+                        </a:rPr>
+                        <a:t>TC21</a:t>
+                      </a:r>
+                      <a:r>
+                        <a:rPr lang="en-US" sz="1300" dirty="0">
+                          <a:solidFill>
+                            <a:srgbClr val="1D2B33"/>
+                          </a:solidFill>
+                          <a:latin typeface="Calibri" pitchFamily="34" charset="0"/>
+                          <a:ea typeface="Calibri" pitchFamily="34" charset="-122"/>
+                          <a:cs typeface="Calibri" pitchFamily="34" charset="-120"/>
+                        </a:rPr>
+                        <a:t> age 121  ·  </a:t>
+                      </a:r>
+                      <a:r>
+                        <a:rPr lang="en-US" sz="1300" dirty="0" b="1">
+                          <a:solidFill>
+                            <a:srgbClr val="1D2B33"/>
+                          </a:solidFill>
+                          <a:latin typeface="Calibri" pitchFamily="34" charset="0"/>
+                          <a:ea typeface="Calibri" pitchFamily="34" charset="-122"/>
+                          <a:cs typeface="Calibri" pitchFamily="34" charset="-120"/>
+                        </a:rPr>
+                        <a:t>TC22</a:t>
+                      </a:r>
+                      <a:r>
+                        <a:rPr lang="en-US" sz="1300" dirty="0">
+                          <a:solidFill>
+                            <a:srgbClr val="1D2B33"/>
+                          </a:solidFill>
+                          <a:latin typeface="Calibri" pitchFamily="34" charset="0"/>
+                          <a:ea typeface="Calibri" pitchFamily="34" charset="-122"/>
+                          <a:cs typeface="Calibri" pitchFamily="34" charset="-120"/>
+                        </a:rPr>
+                        <a:t> age 0 and 120 accepted  ·  </a:t>
+                      </a:r>
+                      <a:r>
+                        <a:rPr lang="en-US" sz="1300" dirty="0" b="1">
+                          <a:solidFill>
+                            <a:srgbClr val="1D2B33"/>
+                          </a:solidFill>
+                          <a:latin typeface="Calibri" pitchFamily="34" charset="0"/>
+                          <a:ea typeface="Calibri" pitchFamily="34" charset="-122"/>
+                          <a:cs typeface="Calibri" pitchFamily="34" charset="-120"/>
+                        </a:rPr>
+                        <a:t>TC23</a:t>
+                      </a:r>
+                      <a:r>
+                        <a:rPr lang="en-US" sz="1300" dirty="0">
+                          <a:solidFill>
+                            <a:srgbClr val="1D2B33"/>
+                          </a:solidFill>
+                          <a:latin typeface="Calibri" pitchFamily="34" charset="0"/>
+                          <a:ea typeface="Calibri" pitchFamily="34" charset="-122"/>
+                          <a:cs typeface="Calibri" pitchFamily="34" charset="-120"/>
+                        </a:rPr>
+                        <a:t> unknown patient ID  ·  </a:t>
+                      </a:r>
+                      <a:r>
+                        <a:rPr lang="en-US" sz="1300" dirty="0" b="1">
+                          <a:solidFill>
+                            <a:srgbClr val="1D2B33"/>
+                          </a:solidFill>
+                          <a:latin typeface="Calibri" pitchFamily="34" charset="0"/>
+                          <a:ea typeface="Calibri" pitchFamily="34" charset="-122"/>
+                          <a:cs typeface="Calibri" pitchFamily="34" charset="-120"/>
+                        </a:rPr>
+                        <a:t>TC24</a:t>
+                      </a:r>
+                      <a:r>
+                        <a:rPr lang="en-US" sz="1300" dirty="0">
+                          <a:solidFill>
+                            <a:srgbClr val="1D2B33"/>
+                          </a:solidFill>
+                          <a:latin typeface="Calibri" pitchFamily="34" charset="0"/>
+                          <a:ea typeface="Calibri" pitchFamily="34" charset="-122"/>
+                          <a:cs typeface="Calibri" pitchFamily="34" charset="-120"/>
+                        </a:rPr>
+                        <a:t> invalid update keeps old data  ·  </a:t>
+                      </a:r>
+                      <a:r>
+                        <a:rPr lang="en-US" sz="1300" dirty="0" b="1">
+                          <a:solidFill>
+                            <a:srgbClr val="1D2B33"/>
+                          </a:solidFill>
+                          <a:latin typeface="Calibri" pitchFamily="34" charset="0"/>
+                          <a:ea typeface="Calibri" pitchFamily="34" charset="-122"/>
+                          <a:cs typeface="Calibri" pitchFamily="34" charset="-120"/>
+                        </a:rPr>
+                        <a:t>TC25</a:t>
+                      </a:r>
+                      <a:r>
+                        <a:rPr lang="en-US" sz="1300" dirty="0">
+                          <a:solidFill>
+                            <a:srgbClr val="1D2B33"/>
+                          </a:solidFill>
+                          <a:latin typeface="Calibri" pitchFamily="34" charset="0"/>
+                          <a:ea typeface="Calibri" pitchFamily="34" charset="-122"/>
+                          <a:cs typeface="Calibri" pitchFamily="34" charset="-120"/>
+                        </a:rPr>
+                        <a:t> &lt;script&gt; in a form (XSS)</a:t>
+                      </a:r>
+                      <a:endParaRPr lang="en-US" sz="1400" dirty="0">
+                        <a:latin typeface="Calibri" charset="0"/>
+                        <a:ea typeface="Calibri" charset="0"/>
+                        <a:cs typeface="Calibri" charset="0"/>
+                      </a:endParaRPr>
+                    </a:p>
+                  </a:txBody>
+                  <a:tcPr marL="91440" marR="91440" marT="45720" marB="45720" anchor="ctr">
+                    <a:lnL w="6350" cap="flat" cmpd="sng" algn="ctr">
+                      <a:solidFill>
+                        <a:srgbClr val="D5E3E6"/>
+                      </a:solidFill>
+                      <a:prstDash val="solid"/>
+                      <a:round/>
+                      <a:headEnd type="none" w="med" len="med"/>
+                      <a:tailEnd type="none" w="med" len="med"/>
+                    </a:lnL>
+                    <a:lnR w="6350" cap="flat" cmpd="sng" algn="ctr">
+                      <a:solidFill>
+                        <a:srgbClr val="D5E3E6"/>
+                      </a:solidFill>
+                      <a:prstDash val="solid"/>
+                      <a:round/>
+                      <a:headEnd type="none" w="med" len="med"/>
+                      <a:tailEnd type="none" w="med" len="med"/>
+                    </a:lnR>
+                    <a:lnT w="6350" cap="flat" cmpd="sng" algn="ctr">
+                      <a:solidFill>
+                        <a:srgbClr val="D5E3E6"/>
+                      </a:solidFill>
+                      <a:prstDash val="solid"/>
+                      <a:round/>
+                      <a:headEnd type="none" w="med" len="med"/>
+                      <a:tailEnd type="none" w="med" len="med"/>
+                    </a:lnT>
+                    <a:lnB w="6350" cap="flat" cmpd="sng" algn="ctr">
+                      <a:solidFill>
+                        <a:srgbClr val="D5E3E6"/>
+                      </a:solidFill>
+                      <a:prstDash val="solid"/>
+                      <a:round/>
+                      <a:headEnd type="none" w="med" len="med"/>
+                      <a:tailEnd type="none" w="med" len="med"/>
+                    </a:lnB>
+                    <a:solidFill>
+                      <a:srgbClr val="FFFFFF"/>
+                    </a:solidFill>
+                  </a:tcPr>
+                </a:tc>
+              </a:tr>
+              <a:tr h="384048">
+                <a:tc>
+                  <a:txBody>
+                    <a:bodyPr/>
+                    <a:lstStyle/>
+                    <a:p>
+                      <a:pPr indent="0" marL="0">
+                        <a:buNone/>
+                      </a:pPr>
+                      <a:r>
+                        <a:rPr lang="en-US" sz="1400" b="1" dirty="0">
+                          <a:solidFill>
+                            <a:srgbClr val="0E7C86"/>
+                          </a:solidFill>
+                          <a:latin typeface="Calibri" pitchFamily="34" charset="0"/>
+                          <a:ea typeface="Calibri" pitchFamily="34" charset="-122"/>
+                          <a:cs typeface="Calibri" pitchFamily="34" charset="-120"/>
+                        </a:rPr>
+                        <a:t>Doctors</a:t>
+                      </a:r>
+                      <a:endParaRPr lang="en-US" sz="1400" dirty="0">
+                        <a:latin typeface="Calibri" charset="0"/>
+                        <a:ea typeface="Calibri" charset="0"/>
+                        <a:cs typeface="Calibri" charset="0"/>
+                      </a:endParaRPr>
+                    </a:p>
+                  </a:txBody>
+                  <a:tcPr marL="91440" marR="91440" marT="45720" marB="45720" anchor="ctr">
+                    <a:lnL w="6350" cap="flat" cmpd="sng" algn="ctr">
+                      <a:solidFill>
+                        <a:srgbClr val="D5E3E6"/>
+                      </a:solidFill>
+                      <a:prstDash val="solid"/>
+                      <a:round/>
+                      <a:headEnd type="none" w="med" len="med"/>
+                      <a:tailEnd type="none" w="med" len="med"/>
+                    </a:lnL>
+                    <a:lnR w="6350" cap="flat" cmpd="sng" algn="ctr">
+                      <a:solidFill>
+                        <a:srgbClr val="D5E3E6"/>
+                      </a:solidFill>
+                      <a:prstDash val="solid"/>
+                      <a:round/>
+                      <a:headEnd type="none" w="med" len="med"/>
+                      <a:tailEnd type="none" w="med" len="med"/>
+                    </a:lnR>
+                    <a:lnT w="6350" cap="flat" cmpd="sng" algn="ctr">
+                      <a:solidFill>
+                        <a:srgbClr val="D5E3E6"/>
+                      </a:solidFill>
+                      <a:prstDash val="solid"/>
+                      <a:round/>
+                      <a:headEnd type="none" w="med" len="med"/>
+                      <a:tailEnd type="none" w="med" len="med"/>
+                    </a:lnT>
+                    <a:lnB w="6350" cap="flat" cmpd="sng" algn="ctr">
+                      <a:solidFill>
+                        <a:srgbClr val="D5E3E6"/>
+                      </a:solidFill>
+                      <a:prstDash val="solid"/>
+                      <a:round/>
+                      <a:headEnd type="none" w="med" len="med"/>
+                      <a:tailEnd type="none" w="med" len="med"/>
+                    </a:lnB>
+                    <a:solidFill>
+                      <a:srgbClr val="EEF5F6"/>
+                    </a:solidFill>
+                  </a:tcPr>
+                </a:tc>
+                <a:tc>
+                  <a:txBody>
+                    <a:bodyPr/>
+                    <a:lstStyle/>
+                    <a:p>
+                      <a:pPr indent="0" marL="0">
+                        <a:buNone/>
+                      </a:pPr>
+                      <a:r>
+                        <a:rPr lang="en-US" sz="1300" dirty="0" b="1">
+                          <a:solidFill>
+                            <a:srgbClr val="1D2B33"/>
+                          </a:solidFill>
+                          <a:latin typeface="Calibri" pitchFamily="34" charset="0"/>
+                          <a:ea typeface="Calibri" pitchFamily="34" charset="-122"/>
+                          <a:cs typeface="Calibri" pitchFamily="34" charset="-120"/>
+                        </a:rPr>
+                        <a:t>TC26</a:t>
+                      </a:r>
+                      <a:r>
+                        <a:rPr lang="en-US" sz="1300" dirty="0">
+                          <a:solidFill>
+                            <a:srgbClr val="1D2B33"/>
+                          </a:solidFill>
+                          <a:latin typeface="Calibri" pitchFamily="34" charset="0"/>
+                          <a:ea typeface="Calibri" pitchFamily="34" charset="-122"/>
+                          <a:cs typeface="Calibri" pitchFamily="34" charset="-120"/>
+                        </a:rPr>
+                        <a:t> fee 0  ·  </a:t>
+                      </a:r>
+                      <a:r>
+                        <a:rPr lang="en-US" sz="1300" dirty="0" b="1">
+                          <a:solidFill>
+                            <a:srgbClr val="1D2B33"/>
+                          </a:solidFill>
+                          <a:latin typeface="Calibri" pitchFamily="34" charset="0"/>
+                          <a:ea typeface="Calibri" pitchFamily="34" charset="-122"/>
+                          <a:cs typeface="Calibri" pitchFamily="34" charset="-120"/>
+                        </a:rPr>
+                        <a:t>TC27</a:t>
+                      </a:r>
+                      <a:r>
+                        <a:rPr lang="en-US" sz="1300" dirty="0">
+                          <a:solidFill>
+                            <a:srgbClr val="1D2B33"/>
+                          </a:solidFill>
+                          <a:latin typeface="Calibri" pitchFamily="34" charset="0"/>
+                          <a:ea typeface="Calibri" pitchFamily="34" charset="-122"/>
+                          <a:cs typeface="Calibri" pitchFamily="34" charset="-120"/>
+                        </a:rPr>
+                        <a:t> search with no match</a:t>
+                      </a:r>
+                      <a:endParaRPr lang="en-US" sz="1400" dirty="0">
+                        <a:latin typeface="Calibri" charset="0"/>
+                        <a:ea typeface="Calibri" charset="0"/>
+                        <a:cs typeface="Calibri" charset="0"/>
+                      </a:endParaRPr>
+                    </a:p>
+                  </a:txBody>
+                  <a:tcPr marL="91440" marR="91440" marT="45720" marB="45720" anchor="ctr">
+                    <a:lnL w="6350" cap="flat" cmpd="sng" algn="ctr">
+                      <a:solidFill>
+                        <a:srgbClr val="D5E3E6"/>
+                      </a:solidFill>
+                      <a:prstDash val="solid"/>
+                      <a:round/>
+                      <a:headEnd type="none" w="med" len="med"/>
+                      <a:tailEnd type="none" w="med" len="med"/>
+                    </a:lnL>
+                    <a:lnR w="6350" cap="flat" cmpd="sng" algn="ctr">
+                      <a:solidFill>
+                        <a:srgbClr val="D5E3E6"/>
+                      </a:solidFill>
+                      <a:prstDash val="solid"/>
+                      <a:round/>
+                      <a:headEnd type="none" w="med" len="med"/>
+                      <a:tailEnd type="none" w="med" len="med"/>
+                    </a:lnR>
+                    <a:lnT w="6350" cap="flat" cmpd="sng" algn="ctr">
+                      <a:solidFill>
+                        <a:srgbClr val="D5E3E6"/>
+                      </a:solidFill>
+                      <a:prstDash val="solid"/>
+                      <a:round/>
+                      <a:headEnd type="none" w="med" len="med"/>
+                      <a:tailEnd type="none" w="med" len="med"/>
+                    </a:lnT>
+                    <a:lnB w="6350" cap="flat" cmpd="sng" algn="ctr">
+                      <a:solidFill>
+                        <a:srgbClr val="D5E3E6"/>
+                      </a:solidFill>
+                      <a:prstDash val="solid"/>
+                      <a:round/>
+                      <a:headEnd type="none" w="med" len="med"/>
+                      <a:tailEnd type="none" w="med" len="med"/>
+                    </a:lnB>
+                    <a:solidFill>
+                      <a:srgbClr val="EEF5F6"/>
+                    </a:solidFill>
+                  </a:tcPr>
+                </a:tc>
+              </a:tr>
+              <a:tr h="621792">
+                <a:tc>
+                  <a:txBody>
+                    <a:bodyPr/>
+                    <a:lstStyle/>
+                    <a:p>
+                      <a:pPr indent="0" marL="0">
+                        <a:buNone/>
+                      </a:pPr>
+                      <a:r>
+                        <a:rPr lang="en-US" sz="1400" b="1" dirty="0">
+                          <a:solidFill>
+                            <a:srgbClr val="0E7C86"/>
+                          </a:solidFill>
+                          <a:latin typeface="Calibri" pitchFamily="34" charset="0"/>
+                          <a:ea typeface="Calibri" pitchFamily="34" charset="-122"/>
+                          <a:cs typeface="Calibri" pitchFamily="34" charset="-120"/>
+                        </a:rPr>
+                        <a:t>Appointments</a:t>
+                      </a:r>
+                      <a:endParaRPr lang="en-US" sz="1400" dirty="0">
+                        <a:latin typeface="Calibri" charset="0"/>
+                        <a:ea typeface="Calibri" charset="0"/>
+                        <a:cs typeface="Calibri" charset="0"/>
+                      </a:endParaRPr>
+                    </a:p>
+                  </a:txBody>
+                  <a:tcPr marL="91440" marR="91440" marT="45720" marB="45720" anchor="ctr">
+                    <a:lnL w="6350" cap="flat" cmpd="sng" algn="ctr">
+                      <a:solidFill>
+                        <a:srgbClr val="D5E3E6"/>
+                      </a:solidFill>
+                      <a:prstDash val="solid"/>
+                      <a:round/>
+                      <a:headEnd type="none" w="med" len="med"/>
+                      <a:tailEnd type="none" w="med" len="med"/>
+                    </a:lnL>
+                    <a:lnR w="6350" cap="flat" cmpd="sng" algn="ctr">
+                      <a:solidFill>
+                        <a:srgbClr val="D5E3E6"/>
+                      </a:solidFill>
+                      <a:prstDash val="solid"/>
+                      <a:round/>
+                      <a:headEnd type="none" w="med" len="med"/>
+                      <a:tailEnd type="none" w="med" len="med"/>
+                    </a:lnR>
+                    <a:lnT w="6350" cap="flat" cmpd="sng" algn="ctr">
+                      <a:solidFill>
+                        <a:srgbClr val="D5E3E6"/>
+                      </a:solidFill>
+                      <a:prstDash val="solid"/>
+                      <a:round/>
+                      <a:headEnd type="none" w="med" len="med"/>
+                      <a:tailEnd type="none" w="med" len="med"/>
+                    </a:lnT>
+                    <a:lnB w="6350" cap="flat" cmpd="sng" algn="ctr">
+                      <a:solidFill>
+                        <a:srgbClr val="D5E3E6"/>
+                      </a:solidFill>
+                      <a:prstDash val="solid"/>
+                      <a:round/>
+                      <a:headEnd type="none" w="med" len="med"/>
+                      <a:tailEnd type="none" w="med" len="med"/>
+                    </a:lnB>
+                    <a:solidFill>
+                      <a:srgbClr val="FFFFFF"/>
+                    </a:solidFill>
+                  </a:tcPr>
+                </a:tc>
+                <a:tc>
+                  <a:txBody>
+                    <a:bodyPr/>
+                    <a:lstStyle/>
+                    <a:p>
+                      <a:pPr indent="0" marL="0">
+                        <a:buNone/>
+                      </a:pPr>
+                      <a:r>
+                        <a:rPr lang="en-US" sz="1300" dirty="0" b="1">
+                          <a:solidFill>
+                            <a:srgbClr val="1D2B33"/>
+                          </a:solidFill>
+                          <a:latin typeface="Calibri" pitchFamily="34" charset="0"/>
+                          <a:ea typeface="Calibri" pitchFamily="34" charset="-122"/>
+                          <a:cs typeface="Calibri" pitchFamily="34" charset="-120"/>
+                        </a:rPr>
+                        <a:t>TC28</a:t>
+                      </a:r>
+                      <a:r>
+                        <a:rPr lang="en-US" sz="1300" dirty="0">
+                          <a:solidFill>
+                            <a:srgbClr val="1D2B33"/>
+                          </a:solidFill>
+                          <a:latin typeface="Calibri" pitchFamily="34" charset="0"/>
+                          <a:ea typeface="Calibri" pitchFamily="34" charset="-122"/>
+                          <a:cs typeface="Calibri" pitchFamily="34" charset="-120"/>
+                        </a:rPr>
+                        <a:t> date in the past  ·  </a:t>
+                      </a:r>
+                      <a:r>
+                        <a:rPr lang="en-US" sz="1300" dirty="0" b="1">
+                          <a:solidFill>
+                            <a:srgbClr val="1D2B33"/>
+                          </a:solidFill>
+                          <a:latin typeface="Calibri" pitchFamily="34" charset="0"/>
+                          <a:ea typeface="Calibri" pitchFamily="34" charset="-122"/>
+                          <a:cs typeface="Calibri" pitchFamily="34" charset="-120"/>
+                        </a:rPr>
+                        <a:t>TC29</a:t>
+                      </a:r>
+                      <a:r>
+                        <a:rPr lang="en-US" sz="1300" dirty="0">
+                          <a:solidFill>
+                            <a:srgbClr val="1D2B33"/>
+                          </a:solidFill>
+                          <a:latin typeface="Calibri" pitchFamily="34" charset="0"/>
+                          <a:ea typeface="Calibri" pitchFamily="34" charset="-122"/>
+                          <a:cs typeface="Calibri" pitchFamily="34" charset="-120"/>
+                        </a:rPr>
+                        <a:t> no patient selected  ·  </a:t>
+                      </a:r>
+                      <a:r>
+                        <a:rPr lang="en-US" sz="1300" dirty="0" b="1">
+                          <a:solidFill>
+                            <a:srgbClr val="1D2B33"/>
+                          </a:solidFill>
+                          <a:latin typeface="Calibri" pitchFamily="34" charset="0"/>
+                          <a:ea typeface="Calibri" pitchFamily="34" charset="-122"/>
+                          <a:cs typeface="Calibri" pitchFamily="34" charset="-120"/>
+                        </a:rPr>
+                        <a:t>TC30</a:t>
+                      </a:r>
+                      <a:r>
+                        <a:rPr lang="en-US" sz="1300" dirty="0">
+                          <a:solidFill>
+                            <a:srgbClr val="1D2B33"/>
+                          </a:solidFill>
+                          <a:latin typeface="Calibri" pitchFamily="34" charset="0"/>
+                          <a:ea typeface="Calibri" pitchFamily="34" charset="-122"/>
+                          <a:cs typeface="Calibri" pitchFamily="34" charset="-120"/>
+                        </a:rPr>
+                        <a:t> unavailable doctor  ·  </a:t>
+                      </a:r>
+                      <a:r>
+                        <a:rPr lang="en-US" sz="1300" dirty="0" b="1">
+                          <a:solidFill>
+                            <a:srgbClr val="1D2B33"/>
+                          </a:solidFill>
+                          <a:latin typeface="Calibri" pitchFamily="34" charset="0"/>
+                          <a:ea typeface="Calibri" pitchFamily="34" charset="-122"/>
+                          <a:cs typeface="Calibri" pitchFamily="34" charset="-120"/>
+                        </a:rPr>
+                        <a:t>TC31</a:t>
+                      </a:r>
+                      <a:r>
+                        <a:rPr lang="en-US" sz="1300" dirty="0">
+                          <a:solidFill>
+                            <a:srgbClr val="1D2B33"/>
+                          </a:solidFill>
+                          <a:latin typeface="Calibri" pitchFamily="34" charset="0"/>
+                          <a:ea typeface="Calibri" pitchFamily="34" charset="-122"/>
+                          <a:cs typeface="Calibri" pitchFamily="34" charset="-120"/>
+                        </a:rPr>
+                        <a:t> same patient, two doctors, same time  ·  </a:t>
+                      </a:r>
+                      <a:r>
+                        <a:rPr lang="en-US" sz="1300" dirty="0" b="1">
+                          <a:solidFill>
+                            <a:srgbClr val="1D2B33"/>
+                          </a:solidFill>
+                          <a:latin typeface="Calibri" pitchFamily="34" charset="0"/>
+                          <a:ea typeface="Calibri" pitchFamily="34" charset="-122"/>
+                          <a:cs typeface="Calibri" pitchFamily="34" charset="-120"/>
+                        </a:rPr>
+                        <a:t>TC32</a:t>
+                      </a:r>
+                      <a:r>
+                        <a:rPr lang="en-US" sz="1300" dirty="0">
+                          <a:solidFill>
+                            <a:srgbClr val="1D2B33"/>
+                          </a:solidFill>
+                          <a:latin typeface="Calibri" pitchFamily="34" charset="0"/>
+                          <a:ea typeface="Calibri" pitchFamily="34" charset="-122"/>
+                          <a:cs typeface="Calibri" pitchFamily="34" charset="-120"/>
+                        </a:rPr>
+                        <a:t> cancelled slot booked again</a:t>
+                      </a:r>
+                      <a:endParaRPr lang="en-US" sz="1400" dirty="0">
+                        <a:latin typeface="Calibri" charset="0"/>
+                        <a:ea typeface="Calibri" charset="0"/>
+                        <a:cs typeface="Calibri" charset="0"/>
+                      </a:endParaRPr>
+                    </a:p>
+                  </a:txBody>
+                  <a:tcPr marL="91440" marR="91440" marT="45720" marB="45720" anchor="ctr">
+                    <a:lnL w="6350" cap="flat" cmpd="sng" algn="ctr">
+                      <a:solidFill>
+                        <a:srgbClr val="D5E3E6"/>
+                      </a:solidFill>
+                      <a:prstDash val="solid"/>
+                      <a:round/>
+                      <a:headEnd type="none" w="med" len="med"/>
+                      <a:tailEnd type="none" w="med" len="med"/>
+                    </a:lnL>
+                    <a:lnR w="6350" cap="flat" cmpd="sng" algn="ctr">
+                      <a:solidFill>
+                        <a:srgbClr val="D5E3E6"/>
+                      </a:solidFill>
+                      <a:prstDash val="solid"/>
+                      <a:round/>
+                      <a:headEnd type="none" w="med" len="med"/>
+                      <a:tailEnd type="none" w="med" len="med"/>
+                    </a:lnR>
+                    <a:lnT w="6350" cap="flat" cmpd="sng" algn="ctr">
+                      <a:solidFill>
+                        <a:srgbClr val="D5E3E6"/>
+                      </a:solidFill>
+                      <a:prstDash val="solid"/>
+                      <a:round/>
+                      <a:headEnd type="none" w="med" len="med"/>
+                      <a:tailEnd type="none" w="med" len="med"/>
+                    </a:lnT>
+                    <a:lnB w="6350" cap="flat" cmpd="sng" algn="ctr">
+                      <a:solidFill>
+                        <a:srgbClr val="D5E3E6"/>
+                      </a:solidFill>
+                      <a:prstDash val="solid"/>
+                      <a:round/>
+                      <a:headEnd type="none" w="med" len="med"/>
+                      <a:tailEnd type="none" w="med" len="med"/>
+                    </a:lnB>
+                    <a:solidFill>
+                      <a:srgbClr val="FFFFFF"/>
+                    </a:solidFill>
+                  </a:tcPr>
+                </a:tc>
+              </a:tr>
+              <a:tr h="384048">
+                <a:tc>
+                  <a:txBody>
+                    <a:bodyPr/>
+                    <a:lstStyle/>
+                    <a:p>
+                      <a:pPr indent="0" marL="0">
+                        <a:buNone/>
+                      </a:pPr>
+                      <a:r>
+                        <a:rPr lang="en-US" sz="1400" b="1" dirty="0">
+                          <a:solidFill>
+                            <a:srgbClr val="0E7C86"/>
+                          </a:solidFill>
+                          <a:latin typeface="Calibri" pitchFamily="34" charset="0"/>
+                          <a:ea typeface="Calibri" pitchFamily="34" charset="-122"/>
+                          <a:cs typeface="Calibri" pitchFamily="34" charset="-120"/>
+                        </a:rPr>
+                        <a:t>Medical Records</a:t>
+                      </a:r>
+                      <a:endParaRPr lang="en-US" sz="1400" dirty="0">
+                        <a:latin typeface="Calibri" charset="0"/>
+                        <a:ea typeface="Calibri" charset="0"/>
+                        <a:cs typeface="Calibri" charset="0"/>
+                      </a:endParaRPr>
+                    </a:p>
+                  </a:txBody>
+                  <a:tcPr marL="91440" marR="91440" marT="45720" marB="45720" anchor="ctr">
+                    <a:lnL w="6350" cap="flat" cmpd="sng" algn="ctr">
+                      <a:solidFill>
+                        <a:srgbClr val="D5E3E6"/>
+                      </a:solidFill>
+                      <a:prstDash val="solid"/>
+                      <a:round/>
+                      <a:headEnd type="none" w="med" len="med"/>
+                      <a:tailEnd type="none" w="med" len="med"/>
+                    </a:lnL>
+                    <a:lnR w="6350" cap="flat" cmpd="sng" algn="ctr">
+                      <a:solidFill>
+                        <a:srgbClr val="D5E3E6"/>
+                      </a:solidFill>
+                      <a:prstDash val="solid"/>
+                      <a:round/>
+                      <a:headEnd type="none" w="med" len="med"/>
+                      <a:tailEnd type="none" w="med" len="med"/>
+                    </a:lnR>
+                    <a:lnT w="6350" cap="flat" cmpd="sng" algn="ctr">
+                      <a:solidFill>
+                        <a:srgbClr val="D5E3E6"/>
+                      </a:solidFill>
+                      <a:prstDash val="solid"/>
+                      <a:round/>
+                      <a:headEnd type="none" w="med" len="med"/>
+                      <a:tailEnd type="none" w="med" len="med"/>
+                    </a:lnT>
+                    <a:lnB w="6350" cap="flat" cmpd="sng" algn="ctr">
+                      <a:solidFill>
+                        <a:srgbClr val="D5E3E6"/>
+                      </a:solidFill>
+                      <a:prstDash val="solid"/>
+                      <a:round/>
+                      <a:headEnd type="none" w="med" len="med"/>
+                      <a:tailEnd type="none" w="med" len="med"/>
+                    </a:lnB>
+                    <a:solidFill>
+                      <a:srgbClr val="EEF5F6"/>
+                    </a:solidFill>
+                  </a:tcPr>
+                </a:tc>
+                <a:tc>
+                  <a:txBody>
+                    <a:bodyPr/>
+                    <a:lstStyle/>
+                    <a:p>
+                      <a:pPr indent="0" marL="0">
+                        <a:buNone/>
+                      </a:pPr>
+                      <a:r>
+                        <a:rPr lang="en-US" sz="1300" dirty="0" b="1">
+                          <a:solidFill>
+                            <a:srgbClr val="1D2B33"/>
+                          </a:solidFill>
+                          <a:latin typeface="Calibri" pitchFamily="34" charset="0"/>
+                          <a:ea typeface="Calibri" pitchFamily="34" charset="-122"/>
+                          <a:cs typeface="Calibri" pitchFamily="34" charset="-120"/>
+                        </a:rPr>
+                        <a:t>TC33</a:t>
+                      </a:r>
+                      <a:r>
+                        <a:rPr lang="en-US" sz="1300" dirty="0">
+                          <a:solidFill>
+                            <a:srgbClr val="1D2B33"/>
+                          </a:solidFill>
+                          <a:latin typeface="Calibri" pitchFamily="34" charset="0"/>
+                          <a:ea typeface="Calibri" pitchFamily="34" charset="-122"/>
+                          <a:cs typeface="Calibri" pitchFamily="34" charset="-120"/>
+                        </a:rPr>
+                        <a:t> empty diagnosis  ·  </a:t>
+                      </a:r>
+                      <a:r>
+                        <a:rPr lang="en-US" sz="1300" dirty="0" b="1">
+                          <a:solidFill>
+                            <a:srgbClr val="1D2B33"/>
+                          </a:solidFill>
+                          <a:latin typeface="Calibri" pitchFamily="34" charset="0"/>
+                          <a:ea typeface="Calibri" pitchFamily="34" charset="-122"/>
+                          <a:cs typeface="Calibri" pitchFamily="34" charset="-120"/>
+                        </a:rPr>
+                        <a:t>TC34</a:t>
+                      </a:r>
+                      <a:r>
+                        <a:rPr lang="en-US" sz="1300" dirty="0">
+                          <a:solidFill>
+                            <a:srgbClr val="1D2B33"/>
+                          </a:solidFill>
+                          <a:latin typeface="Calibri" pitchFamily="34" charset="0"/>
+                          <a:ea typeface="Calibri" pitchFamily="34" charset="-122"/>
+                          <a:cs typeface="Calibri" pitchFamily="34" charset="-120"/>
+                        </a:rPr>
+                        <a:t> visit date in the future</a:t>
+                      </a:r>
+                      <a:endParaRPr lang="en-US" sz="1400" dirty="0">
+                        <a:latin typeface="Calibri" charset="0"/>
+                        <a:ea typeface="Calibri" charset="0"/>
+                        <a:cs typeface="Calibri" charset="0"/>
+                      </a:endParaRPr>
+                    </a:p>
+                  </a:txBody>
+                  <a:tcPr marL="91440" marR="91440" marT="45720" marB="45720" anchor="ctr">
+                    <a:lnL w="6350" cap="flat" cmpd="sng" algn="ctr">
+                      <a:solidFill>
+                        <a:srgbClr val="D5E3E6"/>
+                      </a:solidFill>
+                      <a:prstDash val="solid"/>
+                      <a:round/>
+                      <a:headEnd type="none" w="med" len="med"/>
+                      <a:tailEnd type="none" w="med" len="med"/>
+                    </a:lnL>
+                    <a:lnR w="6350" cap="flat" cmpd="sng" algn="ctr">
+                      <a:solidFill>
+                        <a:srgbClr val="D5E3E6"/>
+                      </a:solidFill>
+                      <a:prstDash val="solid"/>
+                      <a:round/>
+                      <a:headEnd type="none" w="med" len="med"/>
+                      <a:tailEnd type="none" w="med" len="med"/>
+                    </a:lnR>
+                    <a:lnT w="6350" cap="flat" cmpd="sng" algn="ctr">
+                      <a:solidFill>
+                        <a:srgbClr val="D5E3E6"/>
+                      </a:solidFill>
+                      <a:prstDash val="solid"/>
+                      <a:round/>
+                      <a:headEnd type="none" w="med" len="med"/>
+                      <a:tailEnd type="none" w="med" len="med"/>
+                    </a:lnT>
+                    <a:lnB w="6350" cap="flat" cmpd="sng" algn="ctr">
+                      <a:solidFill>
+                        <a:srgbClr val="D5E3E6"/>
+                      </a:solidFill>
+                      <a:prstDash val="solid"/>
+                      <a:round/>
+                      <a:headEnd type="none" w="med" len="med"/>
+                      <a:tailEnd type="none" w="med" len="med"/>
+                    </a:lnB>
+                    <a:solidFill>
+                      <a:srgbClr val="EEF5F6"/>
+                    </a:solidFill>
+                  </a:tcPr>
+                </a:tc>
+              </a:tr>
+              <a:tr h="384048">
+                <a:tc>
+                  <a:txBody>
+                    <a:bodyPr/>
+                    <a:lstStyle/>
+                    <a:p>
+                      <a:pPr indent="0" marL="0">
+                        <a:buNone/>
+                      </a:pPr>
+                      <a:r>
+                        <a:rPr lang="en-US" sz="1400" b="1" dirty="0">
+                          <a:solidFill>
+                            <a:srgbClr val="0E7C86"/>
+                          </a:solidFill>
+                          <a:latin typeface="Calibri" pitchFamily="34" charset="0"/>
+                          <a:ea typeface="Calibri" pitchFamily="34" charset="-122"/>
+                          <a:cs typeface="Calibri" pitchFamily="34" charset="-120"/>
+                        </a:rPr>
+                        <a:t>Billing</a:t>
+                      </a:r>
+                      <a:endParaRPr lang="en-US" sz="1400" dirty="0">
+                        <a:latin typeface="Calibri" charset="0"/>
+                        <a:ea typeface="Calibri" charset="0"/>
+                        <a:cs typeface="Calibri" charset="0"/>
+                      </a:endParaRPr>
+                    </a:p>
+                  </a:txBody>
+                  <a:tcPr marL="91440" marR="91440" marT="45720" marB="45720" anchor="ctr">
+                    <a:lnL w="6350" cap="flat" cmpd="sng" algn="ctr">
+                      <a:solidFill>
+                        <a:srgbClr val="D5E3E6"/>
+                      </a:solidFill>
+                      <a:prstDash val="solid"/>
+                      <a:round/>
+                      <a:headEnd type="none" w="med" len="med"/>
+                      <a:tailEnd type="none" w="med" len="med"/>
+                    </a:lnL>
+                    <a:lnR w="6350" cap="flat" cmpd="sng" algn="ctr">
+                      <a:solidFill>
+                        <a:srgbClr val="D5E3E6"/>
+                      </a:solidFill>
+                      <a:prstDash val="solid"/>
+                      <a:round/>
+                      <a:headEnd type="none" w="med" len="med"/>
+                      <a:tailEnd type="none" w="med" len="med"/>
+                    </a:lnR>
+                    <a:lnT w="6350" cap="flat" cmpd="sng" algn="ctr">
+                      <a:solidFill>
+                        <a:srgbClr val="D5E3E6"/>
+                      </a:solidFill>
+                      <a:prstDash val="solid"/>
+                      <a:round/>
+                      <a:headEnd type="none" w="med" len="med"/>
+                      <a:tailEnd type="none" w="med" len="med"/>
+                    </a:lnT>
+                    <a:lnB w="6350" cap="flat" cmpd="sng" algn="ctr">
+                      <a:solidFill>
+                        <a:srgbClr val="D5E3E6"/>
+                      </a:solidFill>
+                      <a:prstDash val="solid"/>
+                      <a:round/>
+                      <a:headEnd type="none" w="med" len="med"/>
+                      <a:tailEnd type="none" w="med" len="med"/>
+                    </a:lnB>
+                    <a:solidFill>
+                      <a:srgbClr val="FFFFFF"/>
+                    </a:solidFill>
+                  </a:tcPr>
+                </a:tc>
+                <a:tc>
+                  <a:txBody>
+                    <a:bodyPr/>
+                    <a:lstStyle/>
+                    <a:p>
+                      <a:pPr indent="0" marL="0">
+                        <a:buNone/>
+                      </a:pPr>
+                      <a:r>
+                        <a:rPr lang="en-US" sz="1300" dirty="0" b="1">
+                          <a:solidFill>
+                            <a:srgbClr val="1D2B33"/>
+                          </a:solidFill>
+                          <a:latin typeface="Calibri" pitchFamily="34" charset="0"/>
+                          <a:ea typeface="Calibri" pitchFamily="34" charset="-122"/>
+                          <a:cs typeface="Calibri" pitchFamily="34" charset="-120"/>
+                        </a:rPr>
+                        <a:t>TC35</a:t>
+                      </a:r>
+                      <a:r>
+                        <a:rPr lang="en-US" sz="1300" dirty="0">
+                          <a:solidFill>
+                            <a:srgbClr val="1D2B33"/>
+                          </a:solidFill>
+                          <a:latin typeface="Calibri" pitchFamily="34" charset="0"/>
+                          <a:ea typeface="Calibri" pitchFamily="34" charset="-122"/>
+                          <a:cs typeface="Calibri" pitchFamily="34" charset="-120"/>
+                        </a:rPr>
+                        <a:t> total 0  ·  </a:t>
+                      </a:r>
+                      <a:r>
+                        <a:rPr lang="en-US" sz="1300" dirty="0" b="1">
+                          <a:solidFill>
+                            <a:srgbClr val="1D2B33"/>
+                          </a:solidFill>
+                          <a:latin typeface="Calibri" pitchFamily="34" charset="0"/>
+                          <a:ea typeface="Calibri" pitchFamily="34" charset="-122"/>
+                          <a:cs typeface="Calibri" pitchFamily="34" charset="-120"/>
+                        </a:rPr>
+                        <a:t>TC36</a:t>
+                      </a:r>
+                      <a:r>
+                        <a:rPr lang="en-US" sz="1300" dirty="0">
+                          <a:solidFill>
+                            <a:srgbClr val="1D2B33"/>
+                          </a:solidFill>
+                          <a:latin typeface="Calibri" pitchFamily="34" charset="0"/>
+                          <a:ea typeface="Calibri" pitchFamily="34" charset="-122"/>
+                          <a:cs typeface="Calibri" pitchFamily="34" charset="-120"/>
+                        </a:rPr>
+                        <a:t> negative charge  ·  </a:t>
+                      </a:r>
+                      <a:r>
+                        <a:rPr lang="en-US" sz="1300" dirty="0" b="1">
+                          <a:solidFill>
+                            <a:srgbClr val="1D2B33"/>
+                          </a:solidFill>
+                          <a:latin typeface="Calibri" pitchFamily="34" charset="0"/>
+                          <a:ea typeface="Calibri" pitchFamily="34" charset="-122"/>
+                          <a:cs typeface="Calibri" pitchFamily="34" charset="-120"/>
+                        </a:rPr>
+                        <a:t>TC37</a:t>
+                      </a:r>
+                      <a:r>
+                        <a:rPr lang="en-US" sz="1300" dirty="0">
+                          <a:solidFill>
+                            <a:srgbClr val="1D2B33"/>
+                          </a:solidFill>
+                          <a:latin typeface="Calibri" pitchFamily="34" charset="0"/>
+                          <a:ea typeface="Calibri" pitchFamily="34" charset="-122"/>
+                          <a:cs typeface="Calibri" pitchFamily="34" charset="-120"/>
+                        </a:rPr>
+                        <a:t> 499.50 + 0.25 = 499.75</a:t>
+                      </a:r>
+                      <a:endParaRPr lang="en-US" sz="1400" dirty="0">
+                        <a:latin typeface="Calibri" charset="0"/>
+                        <a:ea typeface="Calibri" charset="0"/>
+                        <a:cs typeface="Calibri" charset="0"/>
+                      </a:endParaRPr>
+                    </a:p>
+                  </a:txBody>
+                  <a:tcPr marL="91440" marR="91440" marT="45720" marB="45720" anchor="ctr">
+                    <a:lnL w="6350" cap="flat" cmpd="sng" algn="ctr">
+                      <a:solidFill>
+                        <a:srgbClr val="D5E3E6"/>
+                      </a:solidFill>
+                      <a:prstDash val="solid"/>
+                      <a:round/>
+                      <a:headEnd type="none" w="med" len="med"/>
+                      <a:tailEnd type="none" w="med" len="med"/>
+                    </a:lnL>
+                    <a:lnR w="6350" cap="flat" cmpd="sng" algn="ctr">
+                      <a:solidFill>
+                        <a:srgbClr val="D5E3E6"/>
+                      </a:solidFill>
+                      <a:prstDash val="solid"/>
+                      <a:round/>
+                      <a:headEnd type="none" w="med" len="med"/>
+                      <a:tailEnd type="none" w="med" len="med"/>
+                    </a:lnR>
+                    <a:lnT w="6350" cap="flat" cmpd="sng" algn="ctr">
+                      <a:solidFill>
+                        <a:srgbClr val="D5E3E6"/>
+                      </a:solidFill>
+                      <a:prstDash val="solid"/>
+                      <a:round/>
+                      <a:headEnd type="none" w="med" len="med"/>
+                      <a:tailEnd type="none" w="med" len="med"/>
+                    </a:lnT>
+                    <a:lnB w="6350" cap="flat" cmpd="sng" algn="ctr">
+                      <a:solidFill>
+                        <a:srgbClr val="D5E3E6"/>
+                      </a:solidFill>
+                      <a:prstDash val="solid"/>
+                      <a:round/>
+                      <a:headEnd type="none" w="med" len="med"/>
+                      <a:tailEnd type="none" w="med" len="med"/>
+                    </a:lnB>
+                    <a:solidFill>
+                      <a:srgbClr val="FFFFFF"/>
+                    </a:solidFill>
+                  </a:tcPr>
+                </a:tc>
+              </a:tr>
+            </a:tbl>
+          </a:graphicData>
+        </a:graphic>
+      </p:graphicFrame>
+      <p:sp>
+        <p:nvSpPr>
+          <p:cNvPr id="17" name="Key message box"/>
+          <p:cNvSpPr/>
+          <p:nvPr/>
+        </p:nvSpPr>
+        <p:spPr>
+          <a:xfrm>
+            <a:off x="548640" y="5669280"/>
+            <a:ext cx="11064240" cy="566928"/>
+          </a:xfrm>
+          <a:prstGeom prst="roundRect">
+            <a:avLst>
+              <a:gd name="adj" fmla="val 12000"/>
+            </a:avLst>
+          </a:prstGeom>
+          <a:solidFill>
+            <a:schemeClr val="bg2"/>
+          </a:solidFill>
+          <a:ln>
+            <a:noFill/>
+          </a:ln>
+          <a:effectLst/>
+        </p:spPr>
+        <p:style>
+          <a:lnRef idx="1">
+            <a:schemeClr val="accent1"/>
+          </a:lnRef>
+          <a:fillRef idx="3">
+            <a:schemeClr val="accent1"/>
+          </a:fillRef>
+          <a:effectRef idx="2">
+            <a:schemeClr val="accent1"/>
+          </a:effectRef>
+          <a:fontRef idx="minor">
+            <a:schemeClr val="lt1"/>
+          </a:fontRef>
+        </p:style>
+        <p:txBody>
+          <a:bodyPr rtlCol="0" anchor="ctr"/>
+          <a:lstStyle/>
+          <a:p>
+            <a:pPr algn="ctr"/>
+          </a:p>
+        </p:txBody>
+      </p:sp>
+      <p:sp>
+        <p:nvSpPr>
+          <p:cNvPr id="18" name="Key message icon circle"/>
+          <p:cNvSpPr/>
+          <p:nvPr/>
+        </p:nvSpPr>
+        <p:spPr>
+          <a:xfrm>
+            <a:off x="685800" y="5742432"/>
+            <a:ext cx="402336" cy="402336"/>
+          </a:xfrm>
+          <a:prstGeom prst="ellipse">
+            <a:avLst/>
+          </a:prstGeom>
+          <a:solidFill>
+            <a:schemeClr val="accent3"/>
+          </a:solidFill>
+          <a:ln>
+            <a:noFill/>
+          </a:ln>
+          <a:effectLst/>
+        </p:spPr>
+        <p:style>
+          <a:lnRef idx="1">
+            <a:schemeClr val="accent1"/>
+          </a:lnRef>
+          <a:fillRef idx="3">
+            <a:schemeClr val="accent1"/>
+          </a:fillRef>
+          <a:effectRef idx="2">
+            <a:schemeClr val="accent1"/>
+          </a:effectRef>
+          <a:fontRef idx="minor">
+            <a:schemeClr val="lt1"/>
+          </a:fontRef>
+        </p:style>
+        <p:txBody>
+          <a:bodyPr rtlCol="0" anchor="ctr"/>
+          <a:lstStyle/>
+          <a:p>
+            <a:pPr algn="ctr"/>
+          </a:p>
+        </p:txBody>
+      </p:sp>
+      <p:pic>
+        <p:nvPicPr>
+          <p:cNvPr id="19" name="Key message icon" descr="image.png"/>
+          <p:cNvPicPr>
+            <a:picLocks noChangeAspect="1"/>
+          </p:cNvPicPr>
+          <p:nvPr/>
+        </p:nvPicPr>
+        <p:blipFill>
+          <a:blip r:embed="rId2"/>
+          <a:stretch>
+            <a:fillRect/>
+          </a:stretch>
+        </p:blipFill>
+        <p:spPr>
+          <a:xfrm>
+            <a:off x="786384" y="5843016"/>
+            <a:ext cx="201168" cy="201168"/>
+          </a:xfrm>
+          <a:prstGeom prst="rect">
+            <a:avLst/>
+          </a:prstGeom>
+        </p:spPr>
+      </p:pic>
+      <p:sp>
+        <p:nvSpPr>
+          <p:cNvPr id="20" name="Key message text"/>
+          <p:cNvSpPr txBox="1"/>
+          <p:nvPr/>
+        </p:nvSpPr>
+        <p:spPr>
+          <a:xfrm>
+            <a:off x="1234440" y="5669280"/>
+            <a:ext cx="10241280" cy="566928"/>
+          </a:xfrm>
+          <a:prstGeom prst="rect">
+            <a:avLst/>
+          </a:prstGeom>
+          <a:noFill/>
+        </p:spPr>
+        <p:txBody>
+          <a:bodyPr wrap="square" lIns="0" rIns="0" tIns="0" bIns="0" anchor="ctr">
+            <a:spAutoFit/>
+          </a:bodyPr>
+          <a:lstStyle/>
+          <a:p>
+            <a:r>
+              <a:rPr sz="1400" b="1">
+                <a:solidFill>
+                  <a:schemeClr val="tx2"/>
+                </a:solidFill>
+              </a:rPr>
+              <a:t>Every negative test checks 2 things: </a:t>
+            </a:r>
+            <a:r>
+              <a:rPr sz="1400" b="0">
+                <a:solidFill>
+                  <a:schemeClr val="tx1"/>
+                </a:solidFill>
+              </a:rPr>
+              <a:t>the error message is shown AND nothing is saved. Mutation testing: 6 planted bugs, all 6 caught.</a:t>
+            </a:r>
           </a:p>
         </p:txBody>
       </p:sp>
@@ -11169,7 +13442,7 @@
                   <a:schemeClr val="tx2"/>
                 </a:solidFill>
               </a:rPr>
-              <a:t>+4 extra tests: </a:t>
+              <a:t>+28 more: </a:t>
             </a:r>
             <a:pPr indent="0" marL="0">
               <a:buNone/>
@@ -11180,7 +13453,7 @@
                   <a:schemeClr val="tx1"/>
                 </a:solidFill>
               </a:rPr>
-              <a:t>TC10 doctor availability, TC11 no double booking, TC12 medical record, TC13 bill total = consultation + treatment</a:t>
+              <a:t>TC10–TC13 for the other modules, and TC14–TC37 negative, boundary and security tests (next slide)</a:t>
             </a:r>
             <a:endParaRPr lang="en-US" sz="1400" dirty="0"/>
           </a:p>
@@ -12619,7 +14892,7 @@
                   <a:schemeClr val="tx1"/>
                 </a:solidFill>
               </a:rPr>
-              <a:t>Our first Selenium test (code on slide 7)</a:t>
+              <a:t>Our first Selenium test (code on slide 8)</a:t>
             </a:r>
             <a:endParaRPr lang="en-US" sz="1300" dirty="0"/>
           </a:p>
@@ -12653,60 +14926,7 @@
       </p:sp>
       <p:sp>
         <p:nvSpPr>
-          <p:cNvPr id="35" name="Demo step 3 text"/>
-          <p:cNvSpPr txBox="1"/>
-          <p:nvPr/>
-        </p:nvSpPr>
-        <p:spPr>
-          <a:xfrm>
-            <a:off x="7726680" y="2651760"/>
-            <a:ext cx="3794760" cy="566928"/>
-          </a:xfrm>
-          <a:prstGeom prst="rect">
-            <a:avLst/>
-          </a:prstGeom>
-          <a:noFill/>
-          <a:ln/>
-        </p:spPr>
-        <p:txBody>
-          <a:bodyPr wrap="square" lIns="0" tIns="0" rIns="0" bIns="0" rtlCol="0" anchor="ctr"/>
-          <a:lstStyle/>
-          <a:p>
-            <a:pPr indent="0" marL="0">
-              <a:buNone/>
-            </a:pPr>
-            <a:r>
-              <a:rPr lang="en-US" sz="1300" b="1" dirty="0">
-                <a:solidFill>
-                  <a:schemeClr val="accent1"/>
-                </a:solidFill>
-                <a:latin typeface="Courier New" pitchFamily="34" charset="0"/>
-                <a:ea typeface="Courier New" pitchFamily="34" charset="-122"/>
-                <a:cs typeface="Courier New" pitchFamily="34" charset="-120"/>
-              </a:rPr>
-              <a:t>3  python run.py --step</a:t>
-            </a:r>
-            <a:endParaRPr lang="en-US" sz="1300" dirty="0"/>
-          </a:p>
-          <a:p>
-            <a:pPr indent="0" marL="0">
-              <a:buNone/>
-            </a:pPr>
-            <a:r>
-              <a:rPr lang="en-US" sz="1300" dirty="0">
-                <a:solidFill>
-                  <a:schemeClr val="tx1"/>
-                </a:solidFill>
-              </a:rPr>
-              <a:t>Selenium runs all 13 test cases in front of you</a:t>
-            </a:r>
-            <a:endParaRPr lang="en-US" sz="1300" dirty="0"/>
-          </a:p>
-        </p:txBody>
-      </p:sp>
-      <p:sp>
-        <p:nvSpPr>
-          <p:cNvPr id="36" name="Demo step 4 box"/>
+          <p:cNvPr id="41" name="Demo step 4 box"/>
           <p:cNvSpPr/>
           <p:nvPr/>
         </p:nvSpPr>
@@ -12732,13 +14952,13 @@
       </p:sp>
       <p:sp>
         <p:nvSpPr>
-          <p:cNvPr id="37" name="Demo step 4 text"/>
+          <p:cNvPr id="35" name="Demo step 3 text"/>
           <p:cNvSpPr txBox="1"/>
           <p:nvPr/>
         </p:nvSpPr>
         <p:spPr>
           <a:xfrm>
-            <a:off x="7726680" y="3337560"/>
+            <a:off x="7726680" y="2651760"/>
             <a:ext cx="3794760" cy="566928"/>
           </a:xfrm>
           <a:prstGeom prst="rect">
@@ -12763,7 +14983,7 @@
                 <a:ea typeface="Courier New" pitchFamily="34" charset="-122"/>
                 <a:cs typeface="Courier New" pitchFamily="34" charset="-120"/>
               </a:rPr>
-              <a:t>4  Edit "1700.00" -&gt; "1800.00"</a:t>
+              <a:t>3  python run.py --step TC01-TC13</a:t>
             </a:r>
             <a:endParaRPr lang="en-US" sz="1300" dirty="0"/>
           </a:p>
@@ -12777,7 +14997,7 @@
                   <a:schemeClr val="tx1"/>
                 </a:solidFill>
               </a:rPr>
-              <a:t>In run.py TC13: see a test FAIL</a:t>
+              <a:t>Selenium runs the 13 main test cases</a:t>
             </a:r>
             <a:endParaRPr lang="en-US" sz="1300" dirty="0"/>
           </a:p>
@@ -12785,7 +15005,60 @@
       </p:sp>
       <p:sp>
         <p:nvSpPr>
-          <p:cNvPr id="38" name="Demo step 5 box"/>
+          <p:cNvPr id="42" name="Demo step 4 text"/>
+          <p:cNvSpPr txBox="1"/>
+          <p:nvPr/>
+        </p:nvSpPr>
+        <p:spPr>
+          <a:xfrm>
+            <a:off x="7726680" y="3337560"/>
+            <a:ext cx="3794760" cy="566928"/>
+          </a:xfrm>
+          <a:prstGeom prst="rect">
+            <a:avLst/>
+          </a:prstGeom>
+          <a:noFill/>
+          <a:ln/>
+        </p:spPr>
+        <p:txBody>
+          <a:bodyPr wrap="square" lIns="0" tIns="0" rIns="0" bIns="0" rtlCol="0" anchor="ctr"/>
+          <a:lstStyle/>
+          <a:p>
+            <a:pPr indent="0" marL="0">
+              <a:buNone/>
+            </a:pPr>
+            <a:r>
+              <a:rPr lang="en-US" sz="1300" b="1" dirty="0">
+                <a:solidFill>
+                  <a:schemeClr val="accent1"/>
+                </a:solidFill>
+                <a:latin typeface="Courier New" pitchFamily="34" charset="0"/>
+                <a:ea typeface="Courier New" pitchFamily="34" charset="-122"/>
+                <a:cs typeface="Courier New" pitchFamily="34" charset="-120"/>
+              </a:rPr>
+              <a:t>4  python run.py TC16 TC21 TC22 TC25</a:t>
+            </a:r>
+            <a:endParaRPr lang="en-US" sz="1300" dirty="0"/>
+          </a:p>
+          <a:p>
+            <a:pPr indent="0" marL="0">
+              <a:buNone/>
+            </a:pPr>
+            <a:r>
+              <a:rPr lang="en-US" sz="1300" dirty="0">
+                <a:solidFill>
+                  <a:schemeClr val="tx1"/>
+                </a:solidFill>
+              </a:rPr>
+              <a:t>Security and boundary tests (slide 7)</a:t>
+            </a:r>
+            <a:endParaRPr lang="en-US" sz="1300" dirty="0"/>
+          </a:p>
+        </p:txBody>
+      </p:sp>
+      <p:sp>
+        <p:nvSpPr>
+          <p:cNvPr id="36" name="Demo step 5 box"/>
           <p:cNvSpPr/>
           <p:nvPr/>
         </p:nvSpPr>
@@ -12811,7 +15084,7 @@
       </p:sp>
       <p:sp>
         <p:nvSpPr>
-          <p:cNvPr id="39" name="Demo step 5 text"/>
+          <p:cNvPr id="37" name="Demo step 5 text"/>
           <p:cNvSpPr txBox="1"/>
           <p:nvPr/>
         </p:nvSpPr>
@@ -12842,7 +15115,7 @@
                 <a:ea typeface="Courier New" pitchFamily="34" charset="-122"/>
                 <a:cs typeface="Courier New" pitchFamily="34" charset="-120"/>
               </a:rPr>
-              <a:t>5  python report.py</a:t>
+              <a:t>5  Edit "1700.00" -&gt; "1800.00"</a:t>
             </a:r>
             <a:endParaRPr lang="en-US" sz="1300" dirty="0"/>
           </a:p>
@@ -12856,7 +15129,7 @@
                   <a:schemeClr val="tx1"/>
                 </a:solidFill>
               </a:rPr>
-              <a:t>All 98 tests and the HTML test report</a:t>
+              <a:t>In run.py TC13: see a test FAIL</a:t>
             </a:r>
             <a:endParaRPr lang="en-US" sz="1300" dirty="0"/>
           </a:p>
@@ -12864,14 +15137,40 @@
       </p:sp>
       <p:sp>
         <p:nvSpPr>
-          <p:cNvPr id="40" name="Report caption"/>
+          <p:cNvPr id="38" name="Demo step 6 box"/>
+          <p:cNvSpPr/>
+          <p:nvPr/>
+        </p:nvSpPr>
+        <p:spPr>
+          <a:xfrm>
+            <a:off x="7589520" y="4709160"/>
+            <a:ext cx="4023360" cy="566928"/>
+          </a:xfrm>
+          <a:prstGeom prst="roundRect">
+            <a:avLst>
+              <a:gd name="adj" fmla="val 12903"/>
+            </a:avLst>
+          </a:prstGeom>
+          <a:solidFill>
+            <a:schemeClr val="bg2"/>
+          </a:solidFill>
+          <a:ln/>
+        </p:spPr>
+        <p:txBody>
+          <a:bodyPr/>
+          <a:p/>
+        </p:txBody>
+      </p:sp>
+      <p:sp>
+        <p:nvSpPr>
+          <p:cNvPr id="39" name="Demo step 6 text"/>
           <p:cNvSpPr txBox="1"/>
           <p:nvPr/>
         </p:nvSpPr>
         <p:spPr>
           <a:xfrm>
-            <a:off x="7589520" y="4754880"/>
-            <a:ext cx="4023360" cy="274320"/>
+            <a:off x="7726680" y="4709160"/>
+            <a:ext cx="3794760" cy="566928"/>
           </a:xfrm>
           <a:prstGeom prst="rect">
             <a:avLst/>
@@ -12887,12 +15186,65 @@
               <a:buNone/>
             </a:pPr>
             <a:r>
+              <a:rPr lang="en-US" sz="1300" b="1" dirty="0">
+                <a:solidFill>
+                  <a:schemeClr val="accent1"/>
+                </a:solidFill>
+                <a:latin typeface="Courier New" pitchFamily="34" charset="0"/>
+                <a:ea typeface="Courier New" pitchFamily="34" charset="-122"/>
+                <a:cs typeface="Courier New" pitchFamily="34" charset="-120"/>
+              </a:rPr>
+              <a:t>6  python report.py</a:t>
+            </a:r>
+            <a:endParaRPr lang="en-US" sz="1300" dirty="0"/>
+          </a:p>
+          <a:p>
+            <a:pPr indent="0" marL="0">
+              <a:buNone/>
+            </a:pPr>
+            <a:r>
+              <a:rPr lang="en-US" sz="1300" dirty="0">
+                <a:solidFill>
+                  <a:schemeClr val="tx1"/>
+                </a:solidFill>
+              </a:rPr>
+              <a:t>All 122 tests and the HTML test report</a:t>
+            </a:r>
+            <a:endParaRPr lang="en-US" sz="1300" dirty="0"/>
+          </a:p>
+        </p:txBody>
+      </p:sp>
+      <p:sp>
+        <p:nvSpPr>
+          <p:cNvPr id="40" name="Report caption"/>
+          <p:cNvSpPr txBox="1"/>
+          <p:nvPr/>
+        </p:nvSpPr>
+        <p:spPr>
+          <a:xfrm>
+            <a:off x="7589520" y="5440680"/>
+            <a:ext cx="4023360" cy="274320"/>
+          </a:xfrm>
+          <a:prstGeom prst="rect">
+            <a:avLst/>
+          </a:prstGeom>
+          <a:noFill/>
+          <a:ln/>
+        </p:spPr>
+        <p:txBody>
+          <a:bodyPr wrap="square" lIns="0" tIns="0" rIns="0" bIns="0" rtlCol="0" anchor="ctr"/>
+          <a:lstStyle/>
+          <a:p>
+            <a:pPr indent="0" marL="0">
+              <a:buNone/>
+            </a:pPr>
+            <a:r>
               <a:rPr lang="en-US" sz="1100" i="1" dirty="0">
                 <a:solidFill>
                   <a:schemeClr val="accent6"/>
                 </a:solidFill>
               </a:rPr>
-              <a:t>Tip: python run.py TC03 runs only one test case</a:t>
+              <a:t>Tip: python run.py --type negative runs all 17 negative tests</a:t>
             </a:r>
             <a:endParaRPr lang="en-US" sz="1100" dirty="0"/>
           </a:p>
@@ -13013,7 +15365,7 @@
                   <a:schemeClr val="accent1"/>
                 </a:solidFill>
               </a:rPr>
-              <a:t>13</a:t>
+              <a:t>37</a:t>
             </a:r>
             <a:endParaRPr lang="en-US" sz="4000" dirty="0"/>
           </a:p>
@@ -13295,7 +15647,7 @@
                   <a:schemeClr val="accent1"/>
                 </a:solidFill>
               </a:rPr>
-              <a:t>~40 s</a:t>
+              <a:t>~90 s</a:t>
             </a:r>
             <a:endParaRPr lang="en-US" sz="4000" dirty="0"/>
           </a:p>
@@ -13331,7 +15683,7 @@
                   <a:schemeClr val="tx1"/>
                 </a:solidFill>
               </a:rPr>
-              <a:t>To run all 98 tests</a:t>
+              <a:t>To run all 122 tests</a:t>
             </a:r>
             <a:endParaRPr lang="en-US" sz="1200" dirty="0"/>
           </a:p>

</xml_diff>

<commit_message>
Remove the defects card from the Test Results slide
Co-Authored-By: Claude Opus 5.5 <noreply@anthropic.com>
Claude-Session: https://claude.ai/code/session_01KhLoTHysDZctQ2NgKJXDRu
</commit_message>
<xml_diff>
--- a/presentation/Hospital_Management_System_Selenium_Testing.pptx
+++ b/presentation/Hospital_Management_System_Selenium_Testing.pptx
@@ -350,6 +350,201 @@
 </c:chartSpace>
 </file>
 
+<file path=ppt/charts/chart2.xml><?xml version="1.0" encoding="utf-8"?>
+<c:chartSpace xmlns:c="http://schemas.openxmlformats.org/drawingml/2006/chart" xmlns:a="http://schemas.openxmlformats.org/drawingml/2006/main" xmlns:r="http://schemas.openxmlformats.org/officeDocument/2006/relationships">
+  <c:date1904 val="0"/>
+  <c:chart>
+    <c:title>
+      <c:tx>
+        <c:rich>
+          <a:bodyPr/>
+          <a:lstStyle/>
+          <a:p>
+            <a:r>
+              <a:rPr sz="1500" b="1">
+                <a:solidFill>
+                  <a:schemeClr val="tx2"/>
+                </a:solidFill>
+              </a:rPr>
+              <a:t>122 automated tests by testing level</a:t>
+            </a:r>
+          </a:p>
+        </c:rich>
+      </c:tx>
+      <c:layout/>
+      <c:overlay val="0"/>
+    </c:title>
+    <c:autoTitleDeleted val="0"/>
+    <c:plotArea>
+      <c:barChart>
+        <c:barDir val="bar"/>
+        <c:grouping val="clustered"/>
+        <c:varyColors val="0"/>
+        <c:ser>
+          <c:idx val="0"/>
+          <c:order val="0"/>
+          <c:tx>
+            <c:strRef>
+              <c:f>Sheet1!$B$1</c:f>
+              <c:strCache>
+                <c:ptCount val="1"/>
+                <c:pt idx="0">
+                  <c:v>Tests</c:v>
+                </c:pt>
+              </c:strCache>
+            </c:strRef>
+          </c:tx>
+          <c:spPr>
+            <a:solidFill>
+              <a:schemeClr val="accent6"/>
+            </a:solidFill>
+          </c:spPr>
+          <c:dPt>
+            <c:idx val="3"/>
+            <c:spPr>
+              <a:solidFill>
+                <a:schemeClr val="accent1"/>
+              </a:solidFill>
+            </c:spPr>
+          </c:dPt>
+          <c:cat>
+            <c:strRef>
+              <c:f>Sheet1!$A$2:$A$5</c:f>
+              <c:strCache>
+                <c:ptCount val="4"/>
+                <c:pt idx="0">
+                  <c:v>Unit tests  (validators.py)</c:v>
+                </c:pt>
+                <c:pt idx="1">
+                  <c:v>Integration  (database.py)</c:v>
+                </c:pt>
+                <c:pt idx="2">
+                  <c:v>Functional  (app pages, no browser)</c:v>
+                </c:pt>
+                <c:pt idx="3">
+                  <c:v>Selenium UI tests  (Chrome)</c:v>
+                </c:pt>
+              </c:strCache>
+            </c:strRef>
+          </c:cat>
+          <c:val>
+            <c:numRef>
+              <c:f>Sheet1!$B$2:$B$5</c:f>
+              <c:numCache>
+                <c:formatCode>General</c:formatCode>
+                <c:ptCount val="4"/>
+                <c:pt idx="0">
+                  <c:v>39</c:v>
+                </c:pt>
+                <c:pt idx="1">
+                  <c:v>28</c:v>
+                </c:pt>
+                <c:pt idx="2">
+                  <c:v>18</c:v>
+                </c:pt>
+                <c:pt idx="3">
+                  <c:v>37</c:v>
+                </c:pt>
+              </c:numCache>
+            </c:numRef>
+          </c:val>
+        </c:ser>
+        <c:dLbls>
+          <c:txPr>
+            <a:bodyPr/>
+            <a:lstStyle/>
+            <a:p>
+              <a:pPr>
+                <a:defRPr sz="1600" b="1">
+                  <a:solidFill>
+                    <a:schemeClr val="tx2"/>
+                  </a:solidFill>
+                </a:defRPr>
+              </a:pPr>
+            </a:p>
+          </c:txPr>
+          <c:dLblPos val="outEnd"/>
+          <c:showLegendKey val="0"/>
+          <c:showVal val="1"/>
+          <c:showCatName val="0"/>
+          <c:showSerName val="0"/>
+          <c:showPercent val="0"/>
+          <c:showBubbleSize val="0"/>
+          <c:showLeaderLines val="1"/>
+        </c:dLbls>
+        <c:gapWidth val="55"/>
+        <c:axId val="-2068027336"/>
+        <c:axId val="-2113994440"/>
+      </c:barChart>
+      <c:catAx>
+        <c:axId val="-2068027336"/>
+        <c:scaling>
+          <c:orientation val="maxMin"/>
+        </c:scaling>
+        <c:delete val="0"/>
+        <c:axPos val="l"/>
+        <c:majorTickMark val="out"/>
+        <c:minorTickMark val="none"/>
+        <c:tickLblPos val="nextTo"/>
+        <c:spPr>
+          <a:ln>
+            <a:noFill/>
+          </a:ln>
+        </c:spPr>
+        <c:txPr>
+          <a:bodyPr/>
+          <a:lstStyle/>
+          <a:p>
+            <a:pPr>
+              <a:defRPr sz="1300">
+                <a:solidFill>
+                  <a:schemeClr val="tx1"/>
+                </a:solidFill>
+              </a:defRPr>
+            </a:pPr>
+          </a:p>
+        </c:txPr>
+        <c:crossAx val="-2113994440"/>
+        <c:crosses val="autoZero"/>
+        <c:auto val="1"/>
+        <c:lblAlgn val="ctr"/>
+        <c:lblOffset val="100"/>
+        <c:noMultiLvlLbl val="0"/>
+      </c:catAx>
+      <c:valAx>
+        <c:axId val="-2113994440"/>
+        <c:scaling>
+          <c:max val="45.0"/>
+        </c:scaling>
+        <c:delete/>
+        <c:axPos val="b"/>
+        <c:majorTickMark val="out"/>
+        <c:minorTickMark val="none"/>
+        <c:tickLblPos val="nextTo"/>
+        <c:crossAx val="-2068027336"/>
+        <c:crosses val="autoZero"/>
+      </c:valAx>
+    </c:plotArea>
+    <c:dispBlanksAs val="gap"/>
+  </c:chart>
+  <c:txPr>
+    <a:bodyPr/>
+    <a:lstStyle/>
+    <a:p>
+      <a:pPr>
+        <a:defRPr sz="1300">
+          <a:latin typeface="Calibri"/>
+        </a:defRPr>
+      </a:pPr>
+      <a:endParaRPr lang="en-US"/>
+    </a:p>
+  </c:txPr>
+  <c:externalData r:id="rId1">
+    <c:autoUpdate val="0"/>
+  </c:externalData>
+</c:chartSpace>
+</file>
+
 <file path=ppt/notesMasters/notesMaster1.xml><?xml version="1.0" encoding="utf-8"?>
 <p:notesMaster xmlns:a="http://schemas.openxmlformats.org/drawingml/2006/main" xmlns:r="http://schemas.openxmlformats.org/officeDocument/2006/relationships" xmlns:p="http://schemas.openxmlformats.org/presentationml/2006/main">
   <p:cSld>
@@ -1498,7 +1693,7 @@
           <a:lstStyle/>
           <a:p>
             <a:r>
-              <a:t>These are our results. We have 122 automated tests at four testing levels. 39 unit tests check each input rule on its own, 28 integration tests check the rules together with the database, 18 functional tests open every page through HTTP without a browser, and 37 Selenium tests test the full system in a real Chrome browser. All 122 pass. Our testing also found 9 real defects; for example, typing 'nan' as a doctor's fee crashed the server. We fixed all of them and added a test for each one. To prove the tests really catch bugs we used mutation testing: we planted 6 bugs on purpose and all 6 were caught. One command, python report.py, runs everything and opens the HTML report.</a:t>
+              <a:t>These are our results. We have 122 automated tests at four testing levels. 39 unit tests check each input rule on its own, 28 integration tests check the rules together with the database, 18 functional tests open every page through HTTP without a browser, and 37 Selenium tests test the full system in a real Chrome browser. All 122 pass, 0 failed. To prove the tests really catch bugs we used mutation testing: we planted 6 bugs on purpose and all 6 were caught. One command, python report.py, runs everything and opens the HTML report.</a:t>
             </a:r>
           </a:p>
         </p:txBody>
@@ -2775,7 +2970,7 @@
         </p:xfrm>
         <a:graphic>
           <a:graphicData uri="http://schemas.openxmlformats.org/drawingml/2006/chart">
-            <c:chart xmlns:c="http://schemas.openxmlformats.org/drawingml/2006/chart" r:id="rId2"/>
+            <c:chart xmlns:c="http://schemas.openxmlformats.org/drawingml/2006/chart" r:id="rId7"/>
           </a:graphicData>
         </a:graphic>
       </p:graphicFrame>
@@ -2788,7 +2983,7 @@
         <p:spPr>
           <a:xfrm>
             <a:off x="7589520" y="1234440"/>
-            <a:ext cx="4023360" cy="1024128"/>
+            <a:ext cx="4023360" cy="1600200"/>
           </a:xfrm>
           <a:prstGeom prst="roundRect">
             <a:avLst>
@@ -2834,7 +3029,7 @@
         <p:spPr>
           <a:xfrm>
             <a:off x="7772400" y="1234440"/>
-            <a:ext cx="1600200" cy="1024128"/>
+            <a:ext cx="1600200" cy="1600200"/>
           </a:xfrm>
           <a:prstGeom prst="rect">
             <a:avLst/>
@@ -2853,7 +3048,7 @@
               </a:spcAft>
             </a:pPr>
             <a:r>
-              <a:rPr sz="3400" b="1" i="0">
+              <a:rPr sz="4000" b="1" i="0">
                 <a:solidFill>
                   <a:schemeClr val="accent4"/>
                 </a:solidFill>
@@ -2872,7 +3067,7 @@
         <p:spPr>
           <a:xfrm>
             <a:off x="9418320" y="1234440"/>
-            <a:ext cx="2103120" cy="1024128"/>
+            <a:ext cx="2103120" cy="1600200"/>
           </a:xfrm>
           <a:prstGeom prst="rect">
             <a:avLst/>
@@ -2910,8 +3105,8 @@
         </p:nvSpPr>
         <p:spPr>
           <a:xfrm>
-            <a:off x="7589520" y="2423160"/>
-            <a:ext cx="4023360" cy="1024128"/>
+            <a:off x="7589520" y="3017520"/>
+            <a:ext cx="4023360" cy="1600200"/>
           </a:xfrm>
           <a:prstGeom prst="roundRect">
             <a:avLst>
@@ -2956,8 +3151,8 @@
         </p:nvSpPr>
         <p:spPr>
           <a:xfrm>
-            <a:off x="7772400" y="2423160"/>
-            <a:ext cx="1600200" cy="1024128"/>
+            <a:off x="7772400" y="3017520"/>
+            <a:ext cx="1600200" cy="1600200"/>
           </a:xfrm>
           <a:prstGeom prst="rect">
             <a:avLst/>
@@ -2976,12 +3171,12 @@
               </a:spcAft>
             </a:pPr>
             <a:r>
-              <a:rPr sz="3400" b="1" i="0">
-                <a:solidFill>
-                  <a:schemeClr val="accent3"/>
-                </a:solidFill>
-              </a:rPr>
-              <a:t>9</a:t>
+              <a:rPr sz="4000" b="1" i="0">
+                <a:solidFill>
+                  <a:schemeClr val="accent1"/>
+                </a:solidFill>
+              </a:rPr>
+              <a:t>6 / 6</a:t>
             </a:r>
           </a:p>
         </p:txBody>
@@ -2994,8 +3189,8 @@
         </p:nvSpPr>
         <p:spPr>
           <a:xfrm>
-            <a:off x="9418320" y="2423160"/>
-            <a:ext cx="2103120" cy="1024128"/>
+            <a:off x="9418320" y="3017520"/>
+            <a:ext cx="2103120" cy="1600200"/>
           </a:xfrm>
           <a:prstGeom prst="rect">
             <a:avLst/>
@@ -3019,22 +3214,22 @@
                   <a:schemeClr val="tx1"/>
                 </a:solidFill>
               </a:rPr>
-              <a:t>real defects found
-and fixed</a:t>
-            </a:r>
-          </a:p>
-        </p:txBody>
-      </p:sp>
-      <p:sp>
-        <p:nvSpPr>
-          <p:cNvPr id="33" name="Stat 3 card"/>
+              <a:t>planted bugs caught
+(mutation testing)</a:t>
+            </a:r>
+          </a:p>
+        </p:txBody>
+      </p:sp>
+      <p:sp>
+        <p:nvSpPr>
+          <p:cNvPr id="33" name="Business rules box"/>
           <p:cNvSpPr/>
           <p:nvPr/>
         </p:nvSpPr>
         <p:spPr>
           <a:xfrm>
-            <a:off x="7589520" y="3611880"/>
-            <a:ext cx="4023360" cy="1024128"/>
+            <a:off x="548640" y="4846320"/>
+            <a:ext cx="6766560" cy="1280160"/>
           </a:xfrm>
           <a:prstGeom prst="roundRect">
             <a:avLst>
@@ -3042,7 +3237,7 @@
             </a:avLst>
           </a:prstGeom>
           <a:solidFill>
-            <a:schemeClr val="bg2"/>
+            <a:srgbClr val="E3F4EA"/>
           </a:solidFill>
           <a:ln>
             <a:noFill/>
@@ -3073,99 +3268,20 @@
       </p:sp>
       <p:sp>
         <p:nvSpPr>
-          <p:cNvPr id="34" name="Stat 3 number"/>
-          <p:cNvSpPr txBox="1"/>
-          <p:nvPr/>
-        </p:nvSpPr>
-        <p:spPr>
-          <a:xfrm>
-            <a:off x="7772400" y="3611880"/>
-            <a:ext cx="1600200" cy="1024128"/>
-          </a:xfrm>
-          <a:prstGeom prst="rect">
-            <a:avLst/>
-          </a:prstGeom>
-          <a:noFill/>
-        </p:spPr>
-        <p:txBody>
-          <a:bodyPr wrap="square" lIns="0" rIns="0" tIns="0" bIns="0" anchor="ctr">
-            <a:spAutoFit/>
-          </a:bodyPr>
-          <a:lstStyle/>
-          <a:p>
-            <a:pPr>
-              <a:spcAft>
-                <a:spcPts val="0"/>
-              </a:spcAft>
-            </a:pPr>
-            <a:r>
-              <a:rPr sz="3400" b="1" i="0">
-                <a:solidFill>
-                  <a:schemeClr val="accent1"/>
-                </a:solidFill>
-              </a:rPr>
-              <a:t>6 / 6</a:t>
-            </a:r>
-          </a:p>
-        </p:txBody>
-      </p:sp>
-      <p:sp>
-        <p:nvSpPr>
-          <p:cNvPr id="35" name="Stat 3 label"/>
-          <p:cNvSpPr txBox="1"/>
-          <p:nvPr/>
-        </p:nvSpPr>
-        <p:spPr>
-          <a:xfrm>
-            <a:off x="9418320" y="3611880"/>
-            <a:ext cx="2103120" cy="1024128"/>
-          </a:xfrm>
-          <a:prstGeom prst="rect">
-            <a:avLst/>
-          </a:prstGeom>
-          <a:noFill/>
-        </p:spPr>
-        <p:txBody>
-          <a:bodyPr wrap="square" lIns="0" rIns="0" tIns="0" bIns="0" anchor="ctr">
-            <a:spAutoFit/>
-          </a:bodyPr>
-          <a:lstStyle/>
-          <a:p>
-            <a:pPr>
-              <a:spcAft>
-                <a:spcPts val="0"/>
-              </a:spcAft>
-            </a:pPr>
-            <a:r>
-              <a:rPr sz="1400" b="0" i="0">
-                <a:solidFill>
-                  <a:schemeClr val="tx1"/>
-                </a:solidFill>
-              </a:rPr>
-              <a:t>planted bugs caught
-(mutation testing)</a:t>
-            </a:r>
-          </a:p>
-        </p:txBody>
-      </p:sp>
-      <p:sp>
-        <p:nvSpPr>
-          <p:cNvPr id="36" name="Business rules box"/>
+          <p:cNvPr id="34" name="Business rules circle"/>
           <p:cNvSpPr/>
           <p:nvPr/>
         </p:nvSpPr>
         <p:spPr>
           <a:xfrm>
-            <a:off x="548640" y="4846320"/>
-            <a:ext cx="6766560" cy="1280160"/>
-          </a:xfrm>
-          <a:prstGeom prst="roundRect">
-            <a:avLst>
-              <a:gd name="adj" fmla="val 6000"/>
-            </a:avLst>
+            <a:off x="731520" y="5029200"/>
+            <a:ext cx="502920" cy="502920"/>
+          </a:xfrm>
+          <a:prstGeom prst="ellipse">
+            <a:avLst/>
           </a:prstGeom>
           <a:solidFill>
-            <a:srgbClr val="E3F4EA"/>
+            <a:schemeClr val="accent4"/>
           </a:solidFill>
           <a:ln>
             <a:noFill/>
@@ -3194,22 +3310,94 @@
           </a:p>
         </p:txBody>
       </p:sp>
-      <p:sp>
-        <p:nvSpPr>
-          <p:cNvPr id="37" name="Business rules circle"/>
+      <p:pic>
+        <p:nvPicPr>
+          <p:cNvPr id="35" name="Business rules icon" descr="image.png"/>
+          <p:cNvPicPr>
+            <a:picLocks noChangeAspect="1"/>
+          </p:cNvPicPr>
+          <p:nvPr/>
+        </p:nvPicPr>
+        <p:blipFill>
+          <a:blip r:embed="rId3"/>
+          <a:stretch>
+            <a:fillRect/>
+          </a:stretch>
+        </p:blipFill>
+        <p:spPr>
+          <a:xfrm>
+            <a:off x="867308" y="5164988"/>
+            <a:ext cx="231343" cy="231343"/>
+          </a:xfrm>
+          <a:prstGeom prst="rect">
+            <a:avLst/>
+          </a:prstGeom>
+        </p:spPr>
+      </p:pic>
+      <p:sp>
+        <p:nvSpPr>
+          <p:cNvPr id="36" name="Business rules text"/>
+          <p:cNvSpPr txBox="1"/>
+          <p:nvPr/>
+        </p:nvSpPr>
+        <p:spPr>
+          <a:xfrm>
+            <a:off x="1417320" y="4892040"/>
+            <a:ext cx="5760720" cy="1188720"/>
+          </a:xfrm>
+          <a:prstGeom prst="rect">
+            <a:avLst/>
+          </a:prstGeom>
+          <a:noFill/>
+        </p:spPr>
+        <p:txBody>
+          <a:bodyPr wrap="square" lIns="0" rIns="0" tIns="0" bIns="0" anchor="ctr">
+            <a:spAutoFit/>
+          </a:bodyPr>
+          <a:lstStyle/>
+          <a:p>
+            <a:pPr>
+              <a:spcAft>
+                <a:spcPts val="0"/>
+              </a:spcAft>
+            </a:pPr>
+            <a:r>
+              <a:rPr sz="1400" b="1" i="0">
+                <a:solidFill>
+                  <a:schemeClr val="tx2"/>
+                </a:solidFill>
+              </a:rPr>
+              <a:t>Business rules verified: </a:t>
+            </a:r>
+            <a:r>
+              <a:rPr sz="1400" b="0" i="0">
+                <a:solidFill>
+                  <a:schemeClr val="tx1"/>
+                </a:solidFill>
+              </a:rPr>
+              <a:t>wrong input is rejected and not saved, a doctor or patient cannot be double-booked, an unavailable doctor cannot be booked, and the bill total is calculated correctly.</a:t>
+            </a:r>
+          </a:p>
+        </p:txBody>
+      </p:sp>
+      <p:sp>
+        <p:nvSpPr>
+          <p:cNvPr id="37" name="Report command box"/>
           <p:cNvSpPr/>
           <p:nvPr/>
         </p:nvSpPr>
         <p:spPr>
           <a:xfrm>
-            <a:off x="731520" y="5029200"/>
-            <a:ext cx="502920" cy="502920"/>
-          </a:xfrm>
-          <a:prstGeom prst="ellipse">
-            <a:avLst/>
+            <a:off x="7589520" y="4846320"/>
+            <a:ext cx="4023360" cy="1280160"/>
+          </a:xfrm>
+          <a:prstGeom prst="roundRect">
+            <a:avLst>
+              <a:gd name="adj" fmla="val 6000"/>
+            </a:avLst>
           </a:prstGeom>
           <a:solidFill>
-            <a:schemeClr val="accent4"/>
+            <a:srgbClr val="1E2A30"/>
           </a:solidFill>
           <a:ln>
             <a:noFill/>
@@ -3238,125 +3426,9 @@
           </a:p>
         </p:txBody>
       </p:sp>
-      <p:pic>
-        <p:nvPicPr>
-          <p:cNvPr id="38" name="Business rules icon" descr="image.png"/>
-          <p:cNvPicPr>
-            <a:picLocks noChangeAspect="1"/>
-          </p:cNvPicPr>
-          <p:nvPr/>
-        </p:nvPicPr>
-        <p:blipFill>
-          <a:blip r:embed="rId3"/>
-          <a:stretch>
-            <a:fillRect/>
-          </a:stretch>
-        </p:blipFill>
-        <p:spPr>
-          <a:xfrm>
-            <a:off x="867308" y="5164988"/>
-            <a:ext cx="231343" cy="231343"/>
-          </a:xfrm>
-          <a:prstGeom prst="rect">
-            <a:avLst/>
-          </a:prstGeom>
-        </p:spPr>
-      </p:pic>
-      <p:sp>
-        <p:nvSpPr>
-          <p:cNvPr id="39" name="Business rules text"/>
-          <p:cNvSpPr txBox="1"/>
-          <p:nvPr/>
-        </p:nvSpPr>
-        <p:spPr>
-          <a:xfrm>
-            <a:off x="1417320" y="4892040"/>
-            <a:ext cx="5760720" cy="1188720"/>
-          </a:xfrm>
-          <a:prstGeom prst="rect">
-            <a:avLst/>
-          </a:prstGeom>
-          <a:noFill/>
-        </p:spPr>
-        <p:txBody>
-          <a:bodyPr wrap="square" lIns="0" rIns="0" tIns="0" bIns="0" anchor="ctr">
-            <a:spAutoFit/>
-          </a:bodyPr>
-          <a:lstStyle/>
-          <a:p>
-            <a:pPr>
-              <a:spcAft>
-                <a:spcPts val="0"/>
-              </a:spcAft>
-            </a:pPr>
-            <a:r>
-              <a:rPr sz="1400" b="1" i="0">
-                <a:solidFill>
-                  <a:schemeClr val="tx2"/>
-                </a:solidFill>
-              </a:rPr>
-              <a:t>Business rules verified: </a:t>
-            </a:r>
-            <a:r>
-              <a:rPr sz="1400" b="0" i="0">
-                <a:solidFill>
-                  <a:schemeClr val="tx1"/>
-                </a:solidFill>
-              </a:rPr>
-              <a:t>wrong input is rejected and not saved, a doctor or patient cannot be double-booked, an unavailable doctor cannot be booked, and the bill total is calculated correctly.</a:t>
-            </a:r>
-          </a:p>
-        </p:txBody>
-      </p:sp>
-      <p:sp>
-        <p:nvSpPr>
-          <p:cNvPr id="40" name="Report command box"/>
-          <p:cNvSpPr/>
-          <p:nvPr/>
-        </p:nvSpPr>
-        <p:spPr>
-          <a:xfrm>
-            <a:off x="7589520" y="4846320"/>
-            <a:ext cx="4023360" cy="1280160"/>
-          </a:xfrm>
-          <a:prstGeom prst="roundRect">
-            <a:avLst>
-              <a:gd name="adj" fmla="val 6000"/>
-            </a:avLst>
-          </a:prstGeom>
-          <a:solidFill>
-            <a:srgbClr val="1E2A30"/>
-          </a:solidFill>
-          <a:ln>
-            <a:noFill/>
-          </a:ln>
-          <a:effectLst/>
-        </p:spPr>
-        <p:style>
-          <a:lnRef idx="1">
-            <a:schemeClr val="accent1"/>
-          </a:lnRef>
-          <a:fillRef idx="3">
-            <a:schemeClr val="accent1"/>
-          </a:fillRef>
-          <a:effectRef idx="2">
-            <a:schemeClr val="accent1"/>
-          </a:effectRef>
-          <a:fontRef idx="minor">
-            <a:schemeClr val="lt1"/>
-          </a:fontRef>
-        </p:style>
-        <p:txBody>
-          <a:bodyPr rtlCol="0" anchor="ctr"/>
-          <a:lstStyle/>
-          <a:p>
-            <a:pPr algn="ctr"/>
-          </a:p>
-        </p:txBody>
-      </p:sp>
-      <p:sp>
-        <p:nvSpPr>
-          <p:cNvPr id="41" name="Report command text"/>
+      <p:sp>
+        <p:nvSpPr>
+          <p:cNvPr id="38" name="Report command text"/>
           <p:cNvSpPr txBox="1"/>
           <p:nvPr/>
         </p:nvSpPr>
@@ -3805,7 +3877,7 @@
       </p:sp>
       <p:pic>
         <p:nvPicPr>
-          <p:cNvPr id="31" name="What we tested icon" descr="vial.png"/>
+          <p:cNvPr id="31" name="What we tested icon" descr="image.png"/>
           <p:cNvPicPr>
             <a:picLocks noChangeAspect="1"/>
           </p:cNvPicPr>
@@ -4139,7 +4211,7 @@
       </p:sp>
       <p:pic>
         <p:nvPicPr>
-          <p:cNvPr id="39" name="What we learned icon" descr="bulb.png"/>
+          <p:cNvPr id="39" name="What we learned icon" descr="image.png"/>
           <p:cNvPicPr>
             <a:picLocks noChangeAspect="1"/>
           </p:cNvPicPr>
@@ -15603,7 +15675,7 @@
       </p:sp>
       <p:pic>
         <p:nvPicPr>
-          <p:cNvPr id="41" name="TC02 screenshot" descr="test_TC02_login_with_invalid_details.png"/>
+          <p:cNvPr id="41" name="TC02 screenshot" descr="image.png"/>
           <p:cNvPicPr>
             <a:picLocks noChangeAspect="1"/>
           </p:cNvPicPr>
@@ -16155,7 +16227,7 @@
       </p:sp>
       <p:pic>
         <p:nvPicPr>
-          <p:cNvPr id="29" name="Demo step 1 screenshot" descr="demo_01_selenium_typing.png"/>
+          <p:cNvPr id="29" name="Demo step 1 screenshot" descr="image.png"/>
           <p:cNvPicPr>
             <a:picLocks noChangeAspect="1"/>
           </p:cNvPicPr>
@@ -16351,7 +16423,7 @@
       </p:sp>
       <p:pic>
         <p:nvPicPr>
-          <p:cNvPr id="34" name="Demo step 2 screenshot" descr="demo_02_check_passed.png"/>
+          <p:cNvPr id="34" name="Demo step 2 screenshot" descr="image.png"/>
           <p:cNvPicPr>
             <a:picLocks noChangeAspect="1"/>
           </p:cNvPicPr>
@@ -16547,7 +16619,7 @@
       </p:sp>
       <p:pic>
         <p:nvPicPr>
-          <p:cNvPr id="39" name="Demo step 3 screenshot" descr="demo_03_crop.png"/>
+          <p:cNvPr id="39" name="Demo step 3 screenshot" descr="image.png"/>
           <p:cNvPicPr>
             <a:picLocks noChangeAspect="1"/>
           </p:cNvPicPr>

</xml_diff>